<commit_message>
Books deck: keep bank rec out of the already-built card (commercial framing)
The Commercial slide deliberately packages bank reconciliation and the
cash-flow statement in the Books Complete tier; the "builds on what is
shipped" card on the same slide shouldn't list bank rec as already built.

Co-Authored-By: Claude Fable 5 <noreply@anthropic.com>
</commit_message>
<xml_diff>
--- a/docs/Blueprint Books Pitch Deck - Raves.pptx
+++ b/docs/Blueprint Books Pitch Deck - Raves.pptx
@@ -2,23 +2,23 @@
 <file path=ppt/presentation.xml><?xml version="1.0" encoding="utf-8"?>
 <p:presentation xmlns:p="http://schemas.openxmlformats.org/presentationml/2006/main">
   <p:sldMasterIdLst>
-    <p:sldMasterId xmlns:r="http://schemas.openxmlformats.org/officeDocument/2006/relationships" id="2147483648" r:id="R91c8fdf8a1e04614"/>
+    <p:sldMasterId xmlns:r="http://schemas.openxmlformats.org/officeDocument/2006/relationships" id="2147483648" r:id="Rf29e60e7b698424f"/>
   </p:sldMasterIdLst>
   <p:notesMasterIdLst>
-    <p:notesMasterId xmlns:r="http://schemas.openxmlformats.org/officeDocument/2006/relationships" r:id="Rbddd324d89604e53"/>
+    <p:notesMasterId xmlns:r="http://schemas.openxmlformats.org/officeDocument/2006/relationships" r:id="R946f091c9c34431f"/>
   </p:notesMasterIdLst>
   <p:sldIdLst>
-    <p:sldId xmlns:r="http://schemas.openxmlformats.org/officeDocument/2006/relationships" id="256" r:id="R16e60532a45448c1"/>
-    <p:sldId xmlns:r="http://schemas.openxmlformats.org/officeDocument/2006/relationships" id="257" r:id="R61c3dabe2f134b2a"/>
-    <p:sldId xmlns:r="http://schemas.openxmlformats.org/officeDocument/2006/relationships" id="258" r:id="Rcafd86bbd908472c"/>
-    <p:sldId xmlns:r="http://schemas.openxmlformats.org/officeDocument/2006/relationships" id="259" r:id="Rced9f55626f84b00"/>
-    <p:sldId xmlns:r="http://schemas.openxmlformats.org/officeDocument/2006/relationships" id="260" r:id="R89fdff4586304fd1"/>
-    <p:sldId xmlns:r="http://schemas.openxmlformats.org/officeDocument/2006/relationships" id="261" r:id="R56f08515536845e7"/>
-    <p:sldId xmlns:r="http://schemas.openxmlformats.org/officeDocument/2006/relationships" id="262" r:id="Re0ca5ec4410f480b"/>
-    <p:sldId xmlns:r="http://schemas.openxmlformats.org/officeDocument/2006/relationships" id="263" r:id="Rf0424d20ad1143f7"/>
-    <p:sldId xmlns:r="http://schemas.openxmlformats.org/officeDocument/2006/relationships" id="264" r:id="Re6ca11c1d23c4989"/>
-    <p:sldId xmlns:r="http://schemas.openxmlformats.org/officeDocument/2006/relationships" id="265" r:id="Ra9ec3132bf6f455f"/>
-    <p:sldId xmlns:r="http://schemas.openxmlformats.org/officeDocument/2006/relationships" id="266" r:id="R99f36da28e794542"/>
+    <p:sldId xmlns:r="http://schemas.openxmlformats.org/officeDocument/2006/relationships" id="256" r:id="Rc801782da9da4e42"/>
+    <p:sldId xmlns:r="http://schemas.openxmlformats.org/officeDocument/2006/relationships" id="257" r:id="R5dee284de5bf4083"/>
+    <p:sldId xmlns:r="http://schemas.openxmlformats.org/officeDocument/2006/relationships" id="258" r:id="R368875123b0741d8"/>
+    <p:sldId xmlns:r="http://schemas.openxmlformats.org/officeDocument/2006/relationships" id="259" r:id="Rde4e71d65d404fcd"/>
+    <p:sldId xmlns:r="http://schemas.openxmlformats.org/officeDocument/2006/relationships" id="260" r:id="R276081a658174008"/>
+    <p:sldId xmlns:r="http://schemas.openxmlformats.org/officeDocument/2006/relationships" id="261" r:id="R747f89d6a7784cfe"/>
+    <p:sldId xmlns:r="http://schemas.openxmlformats.org/officeDocument/2006/relationships" id="262" r:id="R96c96a8516df43ab"/>
+    <p:sldId xmlns:r="http://schemas.openxmlformats.org/officeDocument/2006/relationships" id="263" r:id="R648fdcc727b24c51"/>
+    <p:sldId xmlns:r="http://schemas.openxmlformats.org/officeDocument/2006/relationships" id="264" r:id="R1e5933d333f34896"/>
+    <p:sldId xmlns:r="http://schemas.openxmlformats.org/officeDocument/2006/relationships" id="265" r:id="Rdf0bf97610734d96"/>
+    <p:sldId xmlns:r="http://schemas.openxmlformats.org/officeDocument/2006/relationships" id="266" r:id="R21461f808aa84350"/>
   </p:sldIdLst>
   <p:sldSz cx="12192000" cy="6858000"/>
   <p:notesSz cx="6858000" cy="9144000"/>
@@ -1225,7 +1225,7 @@
   </p:cSld>
   <p:clrMap bg1="lt1" tx1="dk1" bg2="lt2" tx2="dk2" accent1="accent1" accent2="accent2" accent3="accent3" accent4="accent4" accent5="accent5" accent6="accent6" hlink="hlink" folHlink="folHlink"/>
   <p:sldLayoutIdLst>
-    <p:sldLayoutId xmlns:r="http://schemas.openxmlformats.org/officeDocument/2006/relationships" id="2147483649" r:id="Rd5816606f2264237"/>
+    <p:sldLayoutId xmlns:r="http://schemas.openxmlformats.org/officeDocument/2006/relationships" id="2147483649" r:id="R6c63ba5815d44f81"/>
   </p:sldLayoutIdLst>
   <p:txStyles>
     <p:titleStyle>
@@ -1723,7 +1723,7 @@
           <p:cNvPr id="1" name="">
             <a:extLst xmlns:a="http://schemas.openxmlformats.org/drawingml/2006/main">
               <a:ext uri="{FF2B5EF4-FFF2-40B4-BE49-F238E27FC236}">
-                <a16:creationId xmlns:a16="http://schemas.microsoft.com/office/drawing/2014/main" id="{A2843F07-F90D-4A8C-9BDA-C14354586139}"/>
+                <a16:creationId xmlns:a16="http://schemas.microsoft.com/office/drawing/2014/main" id="{29E37280-3131-4CAE-AABE-E78A8F1A0550}"/>
               </a:ext>
             </a:extLst>
           </p:cNvPr>
@@ -1756,7 +1756,7 @@
           <p:cNvPr id="2" name="">
             <a:extLst xmlns:a="http://schemas.openxmlformats.org/drawingml/2006/main">
               <a:ext uri="{FF2B5EF4-FFF2-40B4-BE49-F238E27FC236}">
-                <a16:creationId xmlns:a16="http://schemas.microsoft.com/office/drawing/2014/main" id="{DEF9761C-0525-46C4-A080-2F1BCC401FEA}"/>
+                <a16:creationId xmlns:a16="http://schemas.microsoft.com/office/drawing/2014/main" id="{45872626-CA4C-43DC-9AFD-4F9C89838CEB}"/>
               </a:ext>
             </a:extLst>
           </p:cNvPr>
@@ -1789,7 +1789,7 @@
           <p:cNvPr id="3" name="">
             <a:extLst xmlns:a="http://schemas.openxmlformats.org/drawingml/2006/main">
               <a:ext uri="{FF2B5EF4-FFF2-40B4-BE49-F238E27FC236}">
-                <a16:creationId xmlns:a16="http://schemas.microsoft.com/office/drawing/2014/main" id="{7D026858-384C-43E4-B825-30620C1CE6AB}"/>
+                <a16:creationId xmlns:a16="http://schemas.microsoft.com/office/drawing/2014/main" id="{4C088F5D-AE64-4D47-87F7-C400A8B349E9}"/>
               </a:ext>
             </a:extLst>
           </p:cNvPr>
@@ -1840,7 +1840,7 @@
           <p:cNvPr id="4" name="">
             <a:extLst xmlns:a="http://schemas.openxmlformats.org/drawingml/2006/main">
               <a:ext uri="{FF2B5EF4-FFF2-40B4-BE49-F238E27FC236}">
-                <a16:creationId xmlns:a16="http://schemas.microsoft.com/office/drawing/2014/main" id="{C8137DF9-1B7F-4075-A326-CD3767F92510}"/>
+                <a16:creationId xmlns:a16="http://schemas.microsoft.com/office/drawing/2014/main" id="{2B110531-C83B-4F8F-A924-A5B053B9F93F}"/>
               </a:ext>
             </a:extLst>
           </p:cNvPr>
@@ -1891,7 +1891,7 @@
           <p:cNvPr id="5" name="">
             <a:extLst xmlns:a="http://schemas.openxmlformats.org/drawingml/2006/main">
               <a:ext uri="{FF2B5EF4-FFF2-40B4-BE49-F238E27FC236}">
-                <a16:creationId xmlns:a16="http://schemas.microsoft.com/office/drawing/2014/main" id="{F8BB9DB9-3190-4570-8B74-C61BC0DAF9B9}"/>
+                <a16:creationId xmlns:a16="http://schemas.microsoft.com/office/drawing/2014/main" id="{03949C35-5B0A-44D1-B180-548991365548}"/>
               </a:ext>
             </a:extLst>
           </p:cNvPr>
@@ -1942,7 +1942,7 @@
           <p:cNvPr id="6" name="">
             <a:extLst xmlns:a="http://schemas.openxmlformats.org/drawingml/2006/main">
               <a:ext uri="{FF2B5EF4-FFF2-40B4-BE49-F238E27FC236}">
-                <a16:creationId xmlns:a16="http://schemas.microsoft.com/office/drawing/2014/main" id="{C525A20B-6A75-489C-BD35-32C932B59C61}"/>
+                <a16:creationId xmlns:a16="http://schemas.microsoft.com/office/drawing/2014/main" id="{9B2698EF-2BE4-4197-A3ED-2CE8C0A44971}"/>
               </a:ext>
             </a:extLst>
           </p:cNvPr>
@@ -1993,7 +1993,7 @@
           <p:cNvPr id="7" name="">
             <a:extLst xmlns:a="http://schemas.openxmlformats.org/drawingml/2006/main">
               <a:ext uri="{FF2B5EF4-FFF2-40B4-BE49-F238E27FC236}">
-                <a16:creationId xmlns:a16="http://schemas.microsoft.com/office/drawing/2014/main" id="{680D85CB-8C58-4C37-8DA6-CC2D3CA8B686}"/>
+                <a16:creationId xmlns:a16="http://schemas.microsoft.com/office/drawing/2014/main" id="{2711CA28-F20A-41FE-874E-7DE0DC1B627E}"/>
               </a:ext>
             </a:extLst>
           </p:cNvPr>
@@ -2044,7 +2044,7 @@
           <p:cNvPr id="8" name="">
             <a:extLst xmlns:a="http://schemas.openxmlformats.org/drawingml/2006/main">
               <a:ext uri="{FF2B5EF4-FFF2-40B4-BE49-F238E27FC236}">
-                <a16:creationId xmlns:a16="http://schemas.microsoft.com/office/drawing/2014/main" id="{D573111E-FD3D-453D-81D8-D74A1D6FBDAA}"/>
+                <a16:creationId xmlns:a16="http://schemas.microsoft.com/office/drawing/2014/main" id="{B2FD66F7-E455-4D80-A293-D80D4F19D2E5}"/>
               </a:ext>
             </a:extLst>
           </p:cNvPr>
@@ -2095,7 +2095,7 @@
           <p:cNvPr id="9" name="">
             <a:extLst xmlns:a="http://schemas.openxmlformats.org/drawingml/2006/main">
               <a:ext uri="{FF2B5EF4-FFF2-40B4-BE49-F238E27FC236}">
-                <a16:creationId xmlns:a16="http://schemas.microsoft.com/office/drawing/2014/main" id="{BCF1C939-C42E-401A-BD65-CE77024D4966}"/>
+                <a16:creationId xmlns:a16="http://schemas.microsoft.com/office/drawing/2014/main" id="{4F9C790B-3A12-4CD0-8C3B-860974827CAF}"/>
               </a:ext>
             </a:extLst>
           </p:cNvPr>
@@ -2128,7 +2128,7 @@
           <p:cNvPr id="10" name="">
             <a:extLst xmlns:a="http://schemas.openxmlformats.org/drawingml/2006/main">
               <a:ext uri="{FF2B5EF4-FFF2-40B4-BE49-F238E27FC236}">
-                <a16:creationId xmlns:a16="http://schemas.microsoft.com/office/drawing/2014/main" id="{754E4839-DA89-427E-9757-DEB468140C25}"/>
+                <a16:creationId xmlns:a16="http://schemas.microsoft.com/office/drawing/2014/main" id="{5C5F98DA-C039-48AF-BD2B-9881A4102FD0}"/>
               </a:ext>
             </a:extLst>
           </p:cNvPr>
@@ -2179,7 +2179,7 @@
           <p:cNvPr id="11" name="">
             <a:extLst xmlns:a="http://schemas.openxmlformats.org/drawingml/2006/main">
               <a:ext uri="{FF2B5EF4-FFF2-40B4-BE49-F238E27FC236}">
-                <a16:creationId xmlns:a16="http://schemas.microsoft.com/office/drawing/2014/main" id="{9AF849DE-9E2A-464D-A809-1DB0C6EF68AF}"/>
+                <a16:creationId xmlns:a16="http://schemas.microsoft.com/office/drawing/2014/main" id="{76FC7697-9681-4238-A8D6-FA0356D2E581}"/>
               </a:ext>
             </a:extLst>
           </p:cNvPr>
@@ -2247,7 +2247,7 @@
           <p:cNvPr id="12" name="">
             <a:extLst xmlns:a="http://schemas.openxmlformats.org/drawingml/2006/main">
               <a:ext uri="{FF2B5EF4-FFF2-40B4-BE49-F238E27FC236}">
-                <a16:creationId xmlns:a16="http://schemas.microsoft.com/office/drawing/2014/main" id="{1DD572BE-3640-4DF0-9C14-04B02136A3E4}"/>
+                <a16:creationId xmlns:a16="http://schemas.microsoft.com/office/drawing/2014/main" id="{1307EF2B-ED9C-4FC4-8C4E-18997F296B4C}"/>
               </a:ext>
             </a:extLst>
           </p:cNvPr>
@@ -2298,7 +2298,7 @@
           <p:cNvPr id="13" name="">
             <a:extLst xmlns:a="http://schemas.openxmlformats.org/drawingml/2006/main">
               <a:ext uri="{FF2B5EF4-FFF2-40B4-BE49-F238E27FC236}">
-                <a16:creationId xmlns:a16="http://schemas.microsoft.com/office/drawing/2014/main" id="{C7BAEBF7-798E-41BA-8B07-06A603B5CC91}"/>
+                <a16:creationId xmlns:a16="http://schemas.microsoft.com/office/drawing/2014/main" id="{370D8DC5-C028-45D8-82B1-DE7686C167A4}"/>
               </a:ext>
             </a:extLst>
           </p:cNvPr>
@@ -2347,7 +2347,7 @@
     </p:spTree>
     <p:extLst>
       <p:ext uri="{BB962C8B-B14F-4D97-AF65-F5344CB8AC3E}">
-        <p14:creationId xmlns:p14="http://schemas.microsoft.com/office/powerpoint/2010/main" val="1420710754"/>
+        <p14:creationId xmlns:p14="http://schemas.microsoft.com/office/powerpoint/2010/main" val="1854565988"/>
       </p:ext>
     </p:extLst>
   </p:cSld>
@@ -2371,7 +2371,7 @@
           <p:cNvPr id="1" name="">
             <a:extLst xmlns:a="http://schemas.openxmlformats.org/drawingml/2006/main">
               <a:ext uri="{FF2B5EF4-FFF2-40B4-BE49-F238E27FC236}">
-                <a16:creationId xmlns:a16="http://schemas.microsoft.com/office/drawing/2014/main" id="{52511A6F-25D4-4278-875B-C10E3D8CCD94}"/>
+                <a16:creationId xmlns:a16="http://schemas.microsoft.com/office/drawing/2014/main" id="{64EA4308-4647-4F8D-A95F-559DEE42E8AF}"/>
               </a:ext>
             </a:extLst>
           </p:cNvPr>
@@ -2404,7 +2404,7 @@
           <p:cNvPr id="2" name="">
             <a:extLst xmlns:a="http://schemas.openxmlformats.org/drawingml/2006/main">
               <a:ext uri="{FF2B5EF4-FFF2-40B4-BE49-F238E27FC236}">
-                <a16:creationId xmlns:a16="http://schemas.microsoft.com/office/drawing/2014/main" id="{8082BC9F-E7D3-4609-B0D8-891976925D3F}"/>
+                <a16:creationId xmlns:a16="http://schemas.microsoft.com/office/drawing/2014/main" id="{8910A232-E92C-4FAD-B51F-907F6B295CC8}"/>
               </a:ext>
             </a:extLst>
           </p:cNvPr>
@@ -2455,7 +2455,7 @@
           <p:cNvPr id="3" name="">
             <a:extLst xmlns:a="http://schemas.openxmlformats.org/drawingml/2006/main">
               <a:ext uri="{FF2B5EF4-FFF2-40B4-BE49-F238E27FC236}">
-                <a16:creationId xmlns:a16="http://schemas.microsoft.com/office/drawing/2014/main" id="{0044FDFD-A761-4C86-9F68-6710840EEAFA}"/>
+                <a16:creationId xmlns:a16="http://schemas.microsoft.com/office/drawing/2014/main" id="{44D2AC35-247F-4C65-9A9A-B3E32C13FBD7}"/>
               </a:ext>
             </a:extLst>
           </p:cNvPr>
@@ -2506,7 +2506,7 @@
           <p:cNvPr id="4" name="">
             <a:extLst xmlns:a="http://schemas.openxmlformats.org/drawingml/2006/main">
               <a:ext uri="{FF2B5EF4-FFF2-40B4-BE49-F238E27FC236}">
-                <a16:creationId xmlns:a16="http://schemas.microsoft.com/office/drawing/2014/main" id="{020A96C4-315D-48AC-BF7C-1124492B7831}"/>
+                <a16:creationId xmlns:a16="http://schemas.microsoft.com/office/drawing/2014/main" id="{72B4D3C5-5D22-4D77-AD33-2455F07B9118}"/>
               </a:ext>
             </a:extLst>
           </p:cNvPr>
@@ -2539,7 +2539,7 @@
           <p:cNvPr id="5" name="">
             <a:extLst xmlns:a="http://schemas.openxmlformats.org/drawingml/2006/main">
               <a:ext uri="{FF2B5EF4-FFF2-40B4-BE49-F238E27FC236}">
-                <a16:creationId xmlns:a16="http://schemas.microsoft.com/office/drawing/2014/main" id="{F0E8D5FB-4B75-4DD7-A490-1C5AFE44F861}"/>
+                <a16:creationId xmlns:a16="http://schemas.microsoft.com/office/drawing/2014/main" id="{78F3ED17-362B-4DB4-9566-8B11EA402CA1}"/>
               </a:ext>
             </a:extLst>
           </p:cNvPr>
@@ -2572,7 +2572,7 @@
           <p:cNvPr id="6" name="">
             <a:extLst xmlns:a="http://schemas.openxmlformats.org/drawingml/2006/main">
               <a:ext uri="{FF2B5EF4-FFF2-40B4-BE49-F238E27FC236}">
-                <a16:creationId xmlns:a16="http://schemas.microsoft.com/office/drawing/2014/main" id="{170DFF5F-6652-44A7-89F8-ACA48524F36E}"/>
+                <a16:creationId xmlns:a16="http://schemas.microsoft.com/office/drawing/2014/main" id="{8F7F2418-A7DF-46F7-AE7E-9CE10959C954}"/>
               </a:ext>
             </a:extLst>
           </p:cNvPr>
@@ -2623,7 +2623,7 @@
           <p:cNvPr id="7" name="">
             <a:extLst xmlns:a="http://schemas.openxmlformats.org/drawingml/2006/main">
               <a:ext uri="{FF2B5EF4-FFF2-40B4-BE49-F238E27FC236}">
-                <a16:creationId xmlns:a16="http://schemas.microsoft.com/office/drawing/2014/main" id="{93E6B392-CA43-43BB-BE0F-E25565AFEA0D}"/>
+                <a16:creationId xmlns:a16="http://schemas.microsoft.com/office/drawing/2014/main" id="{9D8491DA-CD56-4365-BF9E-E3E62AAC37A8}"/>
               </a:ext>
             </a:extLst>
           </p:cNvPr>
@@ -2674,7 +2674,7 @@
           <p:cNvPr id="8" name="">
             <a:extLst xmlns:a="http://schemas.openxmlformats.org/drawingml/2006/main">
               <a:ext uri="{FF2B5EF4-FFF2-40B4-BE49-F238E27FC236}">
-                <a16:creationId xmlns:a16="http://schemas.microsoft.com/office/drawing/2014/main" id="{FF889570-563C-4419-8F33-FFC3773597BD}"/>
+                <a16:creationId xmlns:a16="http://schemas.microsoft.com/office/drawing/2014/main" id="{37E919C1-BBA0-4784-B4BC-AAC25E5193E9}"/>
               </a:ext>
             </a:extLst>
           </p:cNvPr>
@@ -2725,7 +2725,7 @@
           <p:cNvPr id="9" name="">
             <a:extLst xmlns:a="http://schemas.openxmlformats.org/drawingml/2006/main">
               <a:ext uri="{FF2B5EF4-FFF2-40B4-BE49-F238E27FC236}">
-                <a16:creationId xmlns:a16="http://schemas.microsoft.com/office/drawing/2014/main" id="{8BB40F31-C723-4E2A-9FAC-F495DCB6EE80}"/>
+                <a16:creationId xmlns:a16="http://schemas.microsoft.com/office/drawing/2014/main" id="{92E355A4-27F6-436D-9401-5CDEA36FCCA1}"/>
               </a:ext>
             </a:extLst>
           </p:cNvPr>
@@ -2776,7 +2776,7 @@
           <p:cNvPr id="10" name="">
             <a:extLst xmlns:a="http://schemas.openxmlformats.org/drawingml/2006/main">
               <a:ext uri="{FF2B5EF4-FFF2-40B4-BE49-F238E27FC236}">
-                <a16:creationId xmlns:a16="http://schemas.microsoft.com/office/drawing/2014/main" id="{CBD17AEC-D82E-4D62-B851-E557FA9298FB}"/>
+                <a16:creationId xmlns:a16="http://schemas.microsoft.com/office/drawing/2014/main" id="{E233136D-5A5E-4076-A401-5FE09F969D2D}"/>
               </a:ext>
             </a:extLst>
           </p:cNvPr>
@@ -2809,7 +2809,7 @@
           <p:cNvPr id="11" name="">
             <a:extLst xmlns:a="http://schemas.openxmlformats.org/drawingml/2006/main">
               <a:ext uri="{FF2B5EF4-FFF2-40B4-BE49-F238E27FC236}">
-                <a16:creationId xmlns:a16="http://schemas.microsoft.com/office/drawing/2014/main" id="{D34C4F21-E7F2-498A-81F1-BFDF5AD4D5EE}"/>
+                <a16:creationId xmlns:a16="http://schemas.microsoft.com/office/drawing/2014/main" id="{77F455D1-74E8-4EE1-B844-393A64AA4D34}"/>
               </a:ext>
             </a:extLst>
           </p:cNvPr>
@@ -2842,7 +2842,7 @@
           <p:cNvPr id="12" name="">
             <a:extLst xmlns:a="http://schemas.openxmlformats.org/drawingml/2006/main">
               <a:ext uri="{FF2B5EF4-FFF2-40B4-BE49-F238E27FC236}">
-                <a16:creationId xmlns:a16="http://schemas.microsoft.com/office/drawing/2014/main" id="{6C1C6C55-ED68-48F9-B8F3-2FC3BEF3C7EF}"/>
+                <a16:creationId xmlns:a16="http://schemas.microsoft.com/office/drawing/2014/main" id="{E4D389C0-36A1-46E3-84A1-315D70713CC1}"/>
               </a:ext>
             </a:extLst>
           </p:cNvPr>
@@ -2893,7 +2893,7 @@
           <p:cNvPr id="13" name="">
             <a:extLst xmlns:a="http://schemas.openxmlformats.org/drawingml/2006/main">
               <a:ext uri="{FF2B5EF4-FFF2-40B4-BE49-F238E27FC236}">
-                <a16:creationId xmlns:a16="http://schemas.microsoft.com/office/drawing/2014/main" id="{8B0842C9-1646-4E0A-8273-5457432A6E71}"/>
+                <a16:creationId xmlns:a16="http://schemas.microsoft.com/office/drawing/2014/main" id="{A11F73DF-C767-4E07-8CF1-D4F850124443}"/>
               </a:ext>
             </a:extLst>
           </p:cNvPr>
@@ -2944,7 +2944,7 @@
           <p:cNvPr id="14" name="">
             <a:extLst xmlns:a="http://schemas.openxmlformats.org/drawingml/2006/main">
               <a:ext uri="{FF2B5EF4-FFF2-40B4-BE49-F238E27FC236}">
-                <a16:creationId xmlns:a16="http://schemas.microsoft.com/office/drawing/2014/main" id="{008B8446-9049-4FF2-8DAF-B834CE8F64AA}"/>
+                <a16:creationId xmlns:a16="http://schemas.microsoft.com/office/drawing/2014/main" id="{74092CA4-21CB-42AB-B321-E7E7FF653538}"/>
               </a:ext>
             </a:extLst>
           </p:cNvPr>
@@ -2995,7 +2995,7 @@
           <p:cNvPr id="15" name="">
             <a:extLst xmlns:a="http://schemas.openxmlformats.org/drawingml/2006/main">
               <a:ext uri="{FF2B5EF4-FFF2-40B4-BE49-F238E27FC236}">
-                <a16:creationId xmlns:a16="http://schemas.microsoft.com/office/drawing/2014/main" id="{16C3FC9E-5860-422D-9003-E8582DE88CEE}"/>
+                <a16:creationId xmlns:a16="http://schemas.microsoft.com/office/drawing/2014/main" id="{571E3899-8CDC-4A36-865B-1E80E6C1CA35}"/>
               </a:ext>
             </a:extLst>
           </p:cNvPr>
@@ -3046,7 +3046,7 @@
           <p:cNvPr id="16" name="">
             <a:extLst xmlns:a="http://schemas.openxmlformats.org/drawingml/2006/main">
               <a:ext uri="{FF2B5EF4-FFF2-40B4-BE49-F238E27FC236}">
-                <a16:creationId xmlns:a16="http://schemas.microsoft.com/office/drawing/2014/main" id="{17C227EE-31B3-4F3B-B176-73EAFAF41DB2}"/>
+                <a16:creationId xmlns:a16="http://schemas.microsoft.com/office/drawing/2014/main" id="{336A14B6-C5FA-4746-8CA3-DD1ACADCBFD1}"/>
               </a:ext>
             </a:extLst>
           </p:cNvPr>
@@ -3079,7 +3079,7 @@
           <p:cNvPr id="17" name="">
             <a:extLst xmlns:a="http://schemas.openxmlformats.org/drawingml/2006/main">
               <a:ext uri="{FF2B5EF4-FFF2-40B4-BE49-F238E27FC236}">
-                <a16:creationId xmlns:a16="http://schemas.microsoft.com/office/drawing/2014/main" id="{3CFC2F97-AAD4-4B47-9538-B05390393013}"/>
+                <a16:creationId xmlns:a16="http://schemas.microsoft.com/office/drawing/2014/main" id="{84F43FBD-583A-45C2-B007-D6D97D679032}"/>
               </a:ext>
             </a:extLst>
           </p:cNvPr>
@@ -3112,7 +3112,7 @@
           <p:cNvPr id="18" name="">
             <a:extLst xmlns:a="http://schemas.openxmlformats.org/drawingml/2006/main">
               <a:ext uri="{FF2B5EF4-FFF2-40B4-BE49-F238E27FC236}">
-                <a16:creationId xmlns:a16="http://schemas.microsoft.com/office/drawing/2014/main" id="{2EA85162-AE80-4F1C-BA7E-CC89C3A4B66E}"/>
+                <a16:creationId xmlns:a16="http://schemas.microsoft.com/office/drawing/2014/main" id="{463A9AF7-CE77-4DED-B4F2-1A22D3578FD3}"/>
               </a:ext>
             </a:extLst>
           </p:cNvPr>
@@ -3163,7 +3163,7 @@
           <p:cNvPr id="19" name="">
             <a:extLst xmlns:a="http://schemas.openxmlformats.org/drawingml/2006/main">
               <a:ext uri="{FF2B5EF4-FFF2-40B4-BE49-F238E27FC236}">
-                <a16:creationId xmlns:a16="http://schemas.microsoft.com/office/drawing/2014/main" id="{8F7D8F75-C0A0-4814-AF37-1CF062081983}"/>
+                <a16:creationId xmlns:a16="http://schemas.microsoft.com/office/drawing/2014/main" id="{CB61910E-A9BF-4E62-A80F-BF8528B3CD5F}"/>
               </a:ext>
             </a:extLst>
           </p:cNvPr>
@@ -3214,7 +3214,7 @@
           <p:cNvPr id="20" name="">
             <a:extLst xmlns:a="http://schemas.openxmlformats.org/drawingml/2006/main">
               <a:ext uri="{FF2B5EF4-FFF2-40B4-BE49-F238E27FC236}">
-                <a16:creationId xmlns:a16="http://schemas.microsoft.com/office/drawing/2014/main" id="{B867BCA8-3837-4D71-9C93-536BFC0284BC}"/>
+                <a16:creationId xmlns:a16="http://schemas.microsoft.com/office/drawing/2014/main" id="{C2DE018F-15FB-4FB9-8DE3-8881186FEE0A}"/>
               </a:ext>
             </a:extLst>
           </p:cNvPr>
@@ -3265,7 +3265,7 @@
           <p:cNvPr id="21" name="">
             <a:extLst xmlns:a="http://schemas.openxmlformats.org/drawingml/2006/main">
               <a:ext uri="{FF2B5EF4-FFF2-40B4-BE49-F238E27FC236}">
-                <a16:creationId xmlns:a16="http://schemas.microsoft.com/office/drawing/2014/main" id="{84940A0A-9429-47E2-9B7A-1F6B515EAF78}"/>
+                <a16:creationId xmlns:a16="http://schemas.microsoft.com/office/drawing/2014/main" id="{F8CF07A6-47CC-4EBA-BCB7-03AF796AF2FF}"/>
               </a:ext>
             </a:extLst>
           </p:cNvPr>
@@ -3316,7 +3316,7 @@
           <p:cNvPr id="22" name="">
             <a:extLst xmlns:a="http://schemas.openxmlformats.org/drawingml/2006/main">
               <a:ext uri="{FF2B5EF4-FFF2-40B4-BE49-F238E27FC236}">
-                <a16:creationId xmlns:a16="http://schemas.microsoft.com/office/drawing/2014/main" id="{B04145C5-5E25-459A-9273-AF867E9A9010}"/>
+                <a16:creationId xmlns:a16="http://schemas.microsoft.com/office/drawing/2014/main" id="{EFB577CD-3389-4DAF-90D4-61F79464FC60}"/>
               </a:ext>
             </a:extLst>
           </p:cNvPr>
@@ -3349,7 +3349,7 @@
           <p:cNvPr id="23" name="">
             <a:extLst xmlns:a="http://schemas.openxmlformats.org/drawingml/2006/main">
               <a:ext uri="{FF2B5EF4-FFF2-40B4-BE49-F238E27FC236}">
-                <a16:creationId xmlns:a16="http://schemas.microsoft.com/office/drawing/2014/main" id="{AD44FFA3-78CF-4C23-B896-D71A3CAEF17E}"/>
+                <a16:creationId xmlns:a16="http://schemas.microsoft.com/office/drawing/2014/main" id="{18FE2265-1B7C-43D5-BCF3-CFC71DED7F00}"/>
               </a:ext>
             </a:extLst>
           </p:cNvPr>
@@ -3382,7 +3382,7 @@
           <p:cNvPr id="24" name="">
             <a:extLst xmlns:a="http://schemas.openxmlformats.org/drawingml/2006/main">
               <a:ext uri="{FF2B5EF4-FFF2-40B4-BE49-F238E27FC236}">
-                <a16:creationId xmlns:a16="http://schemas.microsoft.com/office/drawing/2014/main" id="{19621A37-F7C3-4C9B-B09B-3EB13E042949}"/>
+                <a16:creationId xmlns:a16="http://schemas.microsoft.com/office/drawing/2014/main" id="{9769D421-B18C-428E-A7A7-C5C29BFE0E67}"/>
               </a:ext>
             </a:extLst>
           </p:cNvPr>
@@ -3433,7 +3433,7 @@
           <p:cNvPr id="25" name="">
             <a:extLst xmlns:a="http://schemas.openxmlformats.org/drawingml/2006/main">
               <a:ext uri="{FF2B5EF4-FFF2-40B4-BE49-F238E27FC236}">
-                <a16:creationId xmlns:a16="http://schemas.microsoft.com/office/drawing/2014/main" id="{E8922ED0-B70F-479A-A7F8-3E74AE8E1502}"/>
+                <a16:creationId xmlns:a16="http://schemas.microsoft.com/office/drawing/2014/main" id="{2647CFFE-6299-434C-973B-A250C8848C0C}"/>
               </a:ext>
             </a:extLst>
           </p:cNvPr>
@@ -3484,7 +3484,7 @@
           <p:cNvPr id="26" name="">
             <a:extLst xmlns:a="http://schemas.openxmlformats.org/drawingml/2006/main">
               <a:ext uri="{FF2B5EF4-FFF2-40B4-BE49-F238E27FC236}">
-                <a16:creationId xmlns:a16="http://schemas.microsoft.com/office/drawing/2014/main" id="{2E55DA48-D761-4FFF-84C1-80FDCE5C1EDD}"/>
+                <a16:creationId xmlns:a16="http://schemas.microsoft.com/office/drawing/2014/main" id="{4828E555-9720-4EB4-AA96-090A7DFCA92A}"/>
               </a:ext>
             </a:extLst>
           </p:cNvPr>
@@ -3535,7 +3535,7 @@
           <p:cNvPr id="27" name="">
             <a:extLst xmlns:a="http://schemas.openxmlformats.org/drawingml/2006/main">
               <a:ext uri="{FF2B5EF4-FFF2-40B4-BE49-F238E27FC236}">
-                <a16:creationId xmlns:a16="http://schemas.microsoft.com/office/drawing/2014/main" id="{A95FCE28-6D4A-4425-BE05-8F62E2B9681B}"/>
+                <a16:creationId xmlns:a16="http://schemas.microsoft.com/office/drawing/2014/main" id="{3E503E33-9614-4A2D-8FB3-8F9997B0CA5D}"/>
               </a:ext>
             </a:extLst>
           </p:cNvPr>
@@ -3586,7 +3586,7 @@
           <p:cNvPr id="28" name="">
             <a:extLst xmlns:a="http://schemas.openxmlformats.org/drawingml/2006/main">
               <a:ext uri="{FF2B5EF4-FFF2-40B4-BE49-F238E27FC236}">
-                <a16:creationId xmlns:a16="http://schemas.microsoft.com/office/drawing/2014/main" id="{0D384C1B-8859-47AF-9974-1D014E859708}"/>
+                <a16:creationId xmlns:a16="http://schemas.microsoft.com/office/drawing/2014/main" id="{C1D2A0D4-4B60-46A3-AC00-F245FB350F1F}"/>
               </a:ext>
             </a:extLst>
           </p:cNvPr>
@@ -3619,7 +3619,7 @@
           <p:cNvPr id="29" name="">
             <a:extLst xmlns:a="http://schemas.openxmlformats.org/drawingml/2006/main">
               <a:ext uri="{FF2B5EF4-FFF2-40B4-BE49-F238E27FC236}">
-                <a16:creationId xmlns:a16="http://schemas.microsoft.com/office/drawing/2014/main" id="{BD53963C-ADC8-48C9-ACD5-A9CCE162E6AB}"/>
+                <a16:creationId xmlns:a16="http://schemas.microsoft.com/office/drawing/2014/main" id="{751548C1-C85B-4072-9D8A-2B97C80F77C5}"/>
               </a:ext>
             </a:extLst>
           </p:cNvPr>
@@ -3652,7 +3652,7 @@
           <p:cNvPr id="30" name="">
             <a:extLst xmlns:a="http://schemas.openxmlformats.org/drawingml/2006/main">
               <a:ext uri="{FF2B5EF4-FFF2-40B4-BE49-F238E27FC236}">
-                <a16:creationId xmlns:a16="http://schemas.microsoft.com/office/drawing/2014/main" id="{963E3F7D-7F62-475C-B5F7-DA5098FECC2B}"/>
+                <a16:creationId xmlns:a16="http://schemas.microsoft.com/office/drawing/2014/main" id="{4C7999EE-86C7-4BE3-AFCE-706807E7E354}"/>
               </a:ext>
             </a:extLst>
           </p:cNvPr>
@@ -3703,7 +3703,7 @@
           <p:cNvPr id="31" name="">
             <a:extLst xmlns:a="http://schemas.openxmlformats.org/drawingml/2006/main">
               <a:ext uri="{FF2B5EF4-FFF2-40B4-BE49-F238E27FC236}">
-                <a16:creationId xmlns:a16="http://schemas.microsoft.com/office/drawing/2014/main" id="{7B5CB242-8097-4280-89B4-F63A66F4A371}"/>
+                <a16:creationId xmlns:a16="http://schemas.microsoft.com/office/drawing/2014/main" id="{503B3F27-5468-4F0F-A8FD-35A37B6C1AA0}"/>
               </a:ext>
             </a:extLst>
           </p:cNvPr>
@@ -3754,7 +3754,7 @@
           <p:cNvPr id="32" name="">
             <a:extLst xmlns:a="http://schemas.openxmlformats.org/drawingml/2006/main">
               <a:ext uri="{FF2B5EF4-FFF2-40B4-BE49-F238E27FC236}">
-                <a16:creationId xmlns:a16="http://schemas.microsoft.com/office/drawing/2014/main" id="{0584F545-C914-41EC-9AD8-EFCA6B83FFFC}"/>
+                <a16:creationId xmlns:a16="http://schemas.microsoft.com/office/drawing/2014/main" id="{BC3A9195-90F6-4E42-AB8C-D5AE3C41AD65}"/>
               </a:ext>
             </a:extLst>
           </p:cNvPr>
@@ -3805,7 +3805,7 @@
           <p:cNvPr id="33" name="">
             <a:extLst xmlns:a="http://schemas.openxmlformats.org/drawingml/2006/main">
               <a:ext uri="{FF2B5EF4-FFF2-40B4-BE49-F238E27FC236}">
-                <a16:creationId xmlns:a16="http://schemas.microsoft.com/office/drawing/2014/main" id="{AB7D18B1-BC66-45BE-90CC-B077EF16529E}"/>
+                <a16:creationId xmlns:a16="http://schemas.microsoft.com/office/drawing/2014/main" id="{9BC276D7-5FBC-4596-B0A8-D0FF59F2C5E9}"/>
               </a:ext>
             </a:extLst>
           </p:cNvPr>
@@ -3856,7 +3856,7 @@
           <p:cNvPr id="34" name="">
             <a:extLst xmlns:a="http://schemas.openxmlformats.org/drawingml/2006/main">
               <a:ext uri="{FF2B5EF4-FFF2-40B4-BE49-F238E27FC236}">
-                <a16:creationId xmlns:a16="http://schemas.microsoft.com/office/drawing/2014/main" id="{32AF275F-8560-4A54-A615-76FC705AADBB}"/>
+                <a16:creationId xmlns:a16="http://schemas.microsoft.com/office/drawing/2014/main" id="{0E1BCBD3-EBBA-475F-8001-8FEEEF8CA226}"/>
               </a:ext>
             </a:extLst>
           </p:cNvPr>
@@ -3905,7 +3905,7 @@
     </p:spTree>
     <p:extLst>
       <p:ext uri="{BB962C8B-B14F-4D97-AF65-F5344CB8AC3E}">
-        <p14:creationId xmlns:p14="http://schemas.microsoft.com/office/powerpoint/2010/main" val="341073340"/>
+        <p14:creationId xmlns:p14="http://schemas.microsoft.com/office/powerpoint/2010/main" val="195968863"/>
       </p:ext>
     </p:extLst>
   </p:cSld>
@@ -3929,7 +3929,7 @@
           <p:cNvPr id="1" name="">
             <a:extLst xmlns:a="http://schemas.openxmlformats.org/drawingml/2006/main">
               <a:ext uri="{FF2B5EF4-FFF2-40B4-BE49-F238E27FC236}">
-                <a16:creationId xmlns:a16="http://schemas.microsoft.com/office/drawing/2014/main" id="{BFB1E1F3-514C-4412-AFD3-9EF504DFAFB4}"/>
+                <a16:creationId xmlns:a16="http://schemas.microsoft.com/office/drawing/2014/main" id="{41F3B6A6-4A4B-4DD3-B909-8E56AE19721E}"/>
               </a:ext>
             </a:extLst>
           </p:cNvPr>
@@ -3962,7 +3962,7 @@
           <p:cNvPr id="2" name="">
             <a:extLst xmlns:a="http://schemas.openxmlformats.org/drawingml/2006/main">
               <a:ext uri="{FF2B5EF4-FFF2-40B4-BE49-F238E27FC236}">
-                <a16:creationId xmlns:a16="http://schemas.microsoft.com/office/drawing/2014/main" id="{E9897A32-E0CA-4C7D-904E-E5BD01A0ECB7}"/>
+                <a16:creationId xmlns:a16="http://schemas.microsoft.com/office/drawing/2014/main" id="{086392FE-C0CF-46F7-9B5E-614B2DF24F14}"/>
               </a:ext>
             </a:extLst>
           </p:cNvPr>
@@ -3995,7 +3995,7 @@
           <p:cNvPr id="3" name="">
             <a:extLst xmlns:a="http://schemas.openxmlformats.org/drawingml/2006/main">
               <a:ext uri="{FF2B5EF4-FFF2-40B4-BE49-F238E27FC236}">
-                <a16:creationId xmlns:a16="http://schemas.microsoft.com/office/drawing/2014/main" id="{04FDA912-7202-48C0-9C4C-164C79E9B03F}"/>
+                <a16:creationId xmlns:a16="http://schemas.microsoft.com/office/drawing/2014/main" id="{1B21C722-4F38-45C4-A553-37B56163A908}"/>
               </a:ext>
             </a:extLst>
           </p:cNvPr>
@@ -4046,7 +4046,7 @@
           <p:cNvPr id="4" name="">
             <a:extLst xmlns:a="http://schemas.openxmlformats.org/drawingml/2006/main">
               <a:ext uri="{FF2B5EF4-FFF2-40B4-BE49-F238E27FC236}">
-                <a16:creationId xmlns:a16="http://schemas.microsoft.com/office/drawing/2014/main" id="{9C4BD37B-CDBC-4599-A028-5FCF4A2BBED8}"/>
+                <a16:creationId xmlns:a16="http://schemas.microsoft.com/office/drawing/2014/main" id="{272CF2D5-22E3-4299-9E99-9A600E0B2258}"/>
               </a:ext>
             </a:extLst>
           </p:cNvPr>
@@ -4097,7 +4097,7 @@
           <p:cNvPr id="5" name="">
             <a:extLst xmlns:a="http://schemas.openxmlformats.org/drawingml/2006/main">
               <a:ext uri="{FF2B5EF4-FFF2-40B4-BE49-F238E27FC236}">
-                <a16:creationId xmlns:a16="http://schemas.microsoft.com/office/drawing/2014/main" id="{28D6E9A8-D2CE-4880-A88E-390FE7513972}"/>
+                <a16:creationId xmlns:a16="http://schemas.microsoft.com/office/drawing/2014/main" id="{4E2D8BC7-133C-4FEF-B549-F31A7D5E63F4}"/>
               </a:ext>
             </a:extLst>
           </p:cNvPr>
@@ -4148,7 +4148,7 @@
           <p:cNvPr id="6" name="">
             <a:extLst xmlns:a="http://schemas.openxmlformats.org/drawingml/2006/main">
               <a:ext uri="{FF2B5EF4-FFF2-40B4-BE49-F238E27FC236}">
-                <a16:creationId xmlns:a16="http://schemas.microsoft.com/office/drawing/2014/main" id="{D2158D0E-C56A-40CD-91DD-F43FC3E978EE}"/>
+                <a16:creationId xmlns:a16="http://schemas.microsoft.com/office/drawing/2014/main" id="{B2781ADB-0108-48EF-B976-A42CF120C373}"/>
               </a:ext>
             </a:extLst>
           </p:cNvPr>
@@ -4199,7 +4199,7 @@
           <p:cNvPr id="7" name="">
             <a:extLst xmlns:a="http://schemas.openxmlformats.org/drawingml/2006/main">
               <a:ext uri="{FF2B5EF4-FFF2-40B4-BE49-F238E27FC236}">
-                <a16:creationId xmlns:a16="http://schemas.microsoft.com/office/drawing/2014/main" id="{FCF004A0-9D73-4753-8A44-9EFF8949F830}"/>
+                <a16:creationId xmlns:a16="http://schemas.microsoft.com/office/drawing/2014/main" id="{AB22F639-1148-4DB2-8DB2-2D8ABE51C740}"/>
               </a:ext>
             </a:extLst>
           </p:cNvPr>
@@ -4250,7 +4250,7 @@
           <p:cNvPr id="8" name="">
             <a:extLst xmlns:a="http://schemas.openxmlformats.org/drawingml/2006/main">
               <a:ext uri="{FF2B5EF4-FFF2-40B4-BE49-F238E27FC236}">
-                <a16:creationId xmlns:a16="http://schemas.microsoft.com/office/drawing/2014/main" id="{9E192DD9-B4DA-44F1-9411-CA40DE652E6F}"/>
+                <a16:creationId xmlns:a16="http://schemas.microsoft.com/office/drawing/2014/main" id="{F30471C2-DE59-45B6-A74E-E2C0F91C5DF7}"/>
               </a:ext>
             </a:extLst>
           </p:cNvPr>
@@ -4283,7 +4283,7 @@
           <p:cNvPr id="9" name="">
             <a:extLst xmlns:a="http://schemas.openxmlformats.org/drawingml/2006/main">
               <a:ext uri="{FF2B5EF4-FFF2-40B4-BE49-F238E27FC236}">
-                <a16:creationId xmlns:a16="http://schemas.microsoft.com/office/drawing/2014/main" id="{9C85835D-A238-4BB2-B322-9CA0D5558B08}"/>
+                <a16:creationId xmlns:a16="http://schemas.microsoft.com/office/drawing/2014/main" id="{C6733890-7525-40DF-A3D6-C2FC88795C59}"/>
               </a:ext>
             </a:extLst>
           </p:cNvPr>
@@ -4334,7 +4334,7 @@
           <p:cNvPr id="10" name="">
             <a:extLst xmlns:a="http://schemas.openxmlformats.org/drawingml/2006/main">
               <a:ext uri="{FF2B5EF4-FFF2-40B4-BE49-F238E27FC236}">
-                <a16:creationId xmlns:a16="http://schemas.microsoft.com/office/drawing/2014/main" id="{30F5549B-4CF3-4729-8B99-663191747C34}"/>
+                <a16:creationId xmlns:a16="http://schemas.microsoft.com/office/drawing/2014/main" id="{FD3C4208-59B9-4FD5-BC15-A5EB714BA20E}"/>
               </a:ext>
             </a:extLst>
           </p:cNvPr>
@@ -4385,7 +4385,7 @@
           <p:cNvPr id="11" name="">
             <a:extLst xmlns:a="http://schemas.openxmlformats.org/drawingml/2006/main">
               <a:ext uri="{FF2B5EF4-FFF2-40B4-BE49-F238E27FC236}">
-                <a16:creationId xmlns:a16="http://schemas.microsoft.com/office/drawing/2014/main" id="{F5F0929E-24C8-4C4B-A8B9-3BF925AFC328}"/>
+                <a16:creationId xmlns:a16="http://schemas.microsoft.com/office/drawing/2014/main" id="{E36559CB-A9EC-445F-8575-7E380CF5CFD6}"/>
               </a:ext>
             </a:extLst>
           </p:cNvPr>
@@ -4436,7 +4436,7 @@
           <p:cNvPr id="12" name="">
             <a:extLst xmlns:a="http://schemas.openxmlformats.org/drawingml/2006/main">
               <a:ext uri="{FF2B5EF4-FFF2-40B4-BE49-F238E27FC236}">
-                <a16:creationId xmlns:a16="http://schemas.microsoft.com/office/drawing/2014/main" id="{A58129E1-2C39-48B0-863E-F4C139A58B30}"/>
+                <a16:creationId xmlns:a16="http://schemas.microsoft.com/office/drawing/2014/main" id="{4CEA349D-CA16-4A29-B183-2DBFD7C9D973}"/>
               </a:ext>
             </a:extLst>
           </p:cNvPr>
@@ -4469,7 +4469,7 @@
           <p:cNvPr id="13" name="">
             <a:extLst xmlns:a="http://schemas.openxmlformats.org/drawingml/2006/main">
               <a:ext uri="{FF2B5EF4-FFF2-40B4-BE49-F238E27FC236}">
-                <a16:creationId xmlns:a16="http://schemas.microsoft.com/office/drawing/2014/main" id="{3268BC99-3619-409C-A742-38F3343E5042}"/>
+                <a16:creationId xmlns:a16="http://schemas.microsoft.com/office/drawing/2014/main" id="{877FCF0E-CB00-4A80-BDA5-9A81BC2FD367}"/>
               </a:ext>
             </a:extLst>
           </p:cNvPr>
@@ -4502,7 +4502,7 @@
           <p:cNvPr id="14" name="">
             <a:extLst xmlns:a="http://schemas.openxmlformats.org/drawingml/2006/main">
               <a:ext uri="{FF2B5EF4-FFF2-40B4-BE49-F238E27FC236}">
-                <a16:creationId xmlns:a16="http://schemas.microsoft.com/office/drawing/2014/main" id="{78ADA367-9B15-4486-9DEC-1D656715995B}"/>
+                <a16:creationId xmlns:a16="http://schemas.microsoft.com/office/drawing/2014/main" id="{5ADF5661-0BC7-4104-8033-00B2FD4E3936}"/>
               </a:ext>
             </a:extLst>
           </p:cNvPr>
@@ -4553,7 +4553,7 @@
           <p:cNvPr id="15" name="">
             <a:extLst xmlns:a="http://schemas.openxmlformats.org/drawingml/2006/main">
               <a:ext uri="{FF2B5EF4-FFF2-40B4-BE49-F238E27FC236}">
-                <a16:creationId xmlns:a16="http://schemas.microsoft.com/office/drawing/2014/main" id="{94D28119-A5BF-4B71-A1DF-50CD5EAA7669}"/>
+                <a16:creationId xmlns:a16="http://schemas.microsoft.com/office/drawing/2014/main" id="{D9DE753C-902C-4DBD-8347-7F6F9BD7D6FB}"/>
               </a:ext>
             </a:extLst>
           </p:cNvPr>
@@ -4604,7 +4604,7 @@
           <p:cNvPr id="16" name="">
             <a:extLst xmlns:a="http://schemas.openxmlformats.org/drawingml/2006/main">
               <a:ext uri="{FF2B5EF4-FFF2-40B4-BE49-F238E27FC236}">
-                <a16:creationId xmlns:a16="http://schemas.microsoft.com/office/drawing/2014/main" id="{D8CEEF06-375A-4B17-A2A5-891DEC321D9F}"/>
+                <a16:creationId xmlns:a16="http://schemas.microsoft.com/office/drawing/2014/main" id="{3C3EBD49-07A5-4344-ABAD-E2FB836D73DB}"/>
               </a:ext>
             </a:extLst>
           </p:cNvPr>
@@ -4637,7 +4637,7 @@
           <p:cNvPr id="17" name="">
             <a:extLst xmlns:a="http://schemas.openxmlformats.org/drawingml/2006/main">
               <a:ext uri="{FF2B5EF4-FFF2-40B4-BE49-F238E27FC236}">
-                <a16:creationId xmlns:a16="http://schemas.microsoft.com/office/drawing/2014/main" id="{0E9523FA-8172-4147-9FE2-C80A63CD8BD3}"/>
+                <a16:creationId xmlns:a16="http://schemas.microsoft.com/office/drawing/2014/main" id="{843CC0B7-3783-4387-AA1B-62144378D047}"/>
               </a:ext>
             </a:extLst>
           </p:cNvPr>
@@ -4670,7 +4670,7 @@
           <p:cNvPr id="18" name="">
             <a:extLst xmlns:a="http://schemas.openxmlformats.org/drawingml/2006/main">
               <a:ext uri="{FF2B5EF4-FFF2-40B4-BE49-F238E27FC236}">
-                <a16:creationId xmlns:a16="http://schemas.microsoft.com/office/drawing/2014/main" id="{51FBF23F-6DD1-46A3-846D-98CFD4F7B8A0}"/>
+                <a16:creationId xmlns:a16="http://schemas.microsoft.com/office/drawing/2014/main" id="{1AFEA0DE-9A35-44A9-BA9D-4D7B376BEAFC}"/>
               </a:ext>
             </a:extLst>
           </p:cNvPr>
@@ -4721,7 +4721,7 @@
           <p:cNvPr id="19" name="">
             <a:extLst xmlns:a="http://schemas.openxmlformats.org/drawingml/2006/main">
               <a:ext uri="{FF2B5EF4-FFF2-40B4-BE49-F238E27FC236}">
-                <a16:creationId xmlns:a16="http://schemas.microsoft.com/office/drawing/2014/main" id="{371D81EB-3569-42B7-B7A8-055559847BD9}"/>
+                <a16:creationId xmlns:a16="http://schemas.microsoft.com/office/drawing/2014/main" id="{A83A55BE-C42D-4CCE-8F8D-86428B4B9733}"/>
               </a:ext>
             </a:extLst>
           </p:cNvPr>
@@ -4772,7 +4772,7 @@
           <p:cNvPr id="20" name="">
             <a:extLst xmlns:a="http://schemas.openxmlformats.org/drawingml/2006/main">
               <a:ext uri="{FF2B5EF4-FFF2-40B4-BE49-F238E27FC236}">
-                <a16:creationId xmlns:a16="http://schemas.microsoft.com/office/drawing/2014/main" id="{36B6CCAF-E751-49B7-BF3E-7D6A8561761F}"/>
+                <a16:creationId xmlns:a16="http://schemas.microsoft.com/office/drawing/2014/main" id="{FE31B257-A7C8-4076-B598-1E22382B765C}"/>
               </a:ext>
             </a:extLst>
           </p:cNvPr>
@@ -4805,7 +4805,7 @@
           <p:cNvPr id="21" name="">
             <a:extLst xmlns:a="http://schemas.openxmlformats.org/drawingml/2006/main">
               <a:ext uri="{FF2B5EF4-FFF2-40B4-BE49-F238E27FC236}">
-                <a16:creationId xmlns:a16="http://schemas.microsoft.com/office/drawing/2014/main" id="{2393CEF3-FF42-4315-B0AB-998409616154}"/>
+                <a16:creationId xmlns:a16="http://schemas.microsoft.com/office/drawing/2014/main" id="{95E1D16B-1B2C-4FAD-92C8-B41296AE5F6C}"/>
               </a:ext>
             </a:extLst>
           </p:cNvPr>
@@ -4838,7 +4838,7 @@
           <p:cNvPr id="22" name="">
             <a:extLst xmlns:a="http://schemas.openxmlformats.org/drawingml/2006/main">
               <a:ext uri="{FF2B5EF4-FFF2-40B4-BE49-F238E27FC236}">
-                <a16:creationId xmlns:a16="http://schemas.microsoft.com/office/drawing/2014/main" id="{45DE8B06-775A-4AEB-B0F8-0556ADC213BB}"/>
+                <a16:creationId xmlns:a16="http://schemas.microsoft.com/office/drawing/2014/main" id="{672554EF-FEAF-4E20-ACBF-BF082E14E022}"/>
               </a:ext>
             </a:extLst>
           </p:cNvPr>
@@ -4889,7 +4889,7 @@
           <p:cNvPr id="23" name="">
             <a:extLst xmlns:a="http://schemas.openxmlformats.org/drawingml/2006/main">
               <a:ext uri="{FF2B5EF4-FFF2-40B4-BE49-F238E27FC236}">
-                <a16:creationId xmlns:a16="http://schemas.microsoft.com/office/drawing/2014/main" id="{D92712A9-3230-41B9-80CE-17C7FC9829DB}"/>
+                <a16:creationId xmlns:a16="http://schemas.microsoft.com/office/drawing/2014/main" id="{8991927E-7D9C-42AA-A487-D30E5E5BECBA}"/>
               </a:ext>
             </a:extLst>
           </p:cNvPr>
@@ -4940,7 +4940,7 @@
           <p:cNvPr id="24" name="">
             <a:extLst xmlns:a="http://schemas.openxmlformats.org/drawingml/2006/main">
               <a:ext uri="{FF2B5EF4-FFF2-40B4-BE49-F238E27FC236}">
-                <a16:creationId xmlns:a16="http://schemas.microsoft.com/office/drawing/2014/main" id="{A01D9A24-3C98-47E8-B697-71193C3FA76A}"/>
+                <a16:creationId xmlns:a16="http://schemas.microsoft.com/office/drawing/2014/main" id="{50E10E62-C84C-4319-B98A-64D4AA0DEC64}"/>
               </a:ext>
             </a:extLst>
           </p:cNvPr>
@@ -4991,7 +4991,7 @@
           <p:cNvPr id="25" name="">
             <a:extLst xmlns:a="http://schemas.openxmlformats.org/drawingml/2006/main">
               <a:ext uri="{FF2B5EF4-FFF2-40B4-BE49-F238E27FC236}">
-                <a16:creationId xmlns:a16="http://schemas.microsoft.com/office/drawing/2014/main" id="{52388290-D4FE-456A-AFD6-F3C08BCE42B9}"/>
+                <a16:creationId xmlns:a16="http://schemas.microsoft.com/office/drawing/2014/main" id="{3BAE0977-3AF7-44DD-B158-E842EB01D0B3}"/>
               </a:ext>
             </a:extLst>
           </p:cNvPr>
@@ -5040,7 +5040,7 @@
     </p:spTree>
     <p:extLst>
       <p:ext uri="{BB962C8B-B14F-4D97-AF65-F5344CB8AC3E}">
-        <p14:creationId xmlns:p14="http://schemas.microsoft.com/office/powerpoint/2010/main" val="128841676"/>
+        <p14:creationId xmlns:p14="http://schemas.microsoft.com/office/powerpoint/2010/main" val="1075445566"/>
       </p:ext>
     </p:extLst>
   </p:cSld>
@@ -5064,7 +5064,7 @@
           <p:cNvPr id="1" name="">
             <a:extLst xmlns:a="http://schemas.openxmlformats.org/drawingml/2006/main">
               <a:ext uri="{FF2B5EF4-FFF2-40B4-BE49-F238E27FC236}">
-                <a16:creationId xmlns:a16="http://schemas.microsoft.com/office/drawing/2014/main" id="{9ACB2097-3969-49F1-A502-C2F1C57ADD97}"/>
+                <a16:creationId xmlns:a16="http://schemas.microsoft.com/office/drawing/2014/main" id="{3B2D082E-33F5-436E-A617-7D3BC482F360}"/>
               </a:ext>
             </a:extLst>
           </p:cNvPr>
@@ -5097,7 +5097,7 @@
           <p:cNvPr id="2" name="">
             <a:extLst xmlns:a="http://schemas.openxmlformats.org/drawingml/2006/main">
               <a:ext uri="{FF2B5EF4-FFF2-40B4-BE49-F238E27FC236}">
-                <a16:creationId xmlns:a16="http://schemas.microsoft.com/office/drawing/2014/main" id="{1B4C4CA6-BAF7-4AB3-8A93-DAAF61F386A6}"/>
+                <a16:creationId xmlns:a16="http://schemas.microsoft.com/office/drawing/2014/main" id="{C570E9AA-2836-4F38-B749-BFE4483807EB}"/>
               </a:ext>
             </a:extLst>
           </p:cNvPr>
@@ -5148,7 +5148,7 @@
           <p:cNvPr id="3" name="">
             <a:extLst xmlns:a="http://schemas.openxmlformats.org/drawingml/2006/main">
               <a:ext uri="{FF2B5EF4-FFF2-40B4-BE49-F238E27FC236}">
-                <a16:creationId xmlns:a16="http://schemas.microsoft.com/office/drawing/2014/main" id="{C62F1815-E17F-43D5-995F-B13E26D42E91}"/>
+                <a16:creationId xmlns:a16="http://schemas.microsoft.com/office/drawing/2014/main" id="{3426E803-7201-47CB-878E-641D9D8A9A5D}"/>
               </a:ext>
             </a:extLst>
           </p:cNvPr>
@@ -5199,7 +5199,7 @@
           <p:cNvPr id="4" name="">
             <a:extLst xmlns:a="http://schemas.openxmlformats.org/drawingml/2006/main">
               <a:ext uri="{FF2B5EF4-FFF2-40B4-BE49-F238E27FC236}">
-                <a16:creationId xmlns:a16="http://schemas.microsoft.com/office/drawing/2014/main" id="{D0A416CE-5F7D-405D-83D8-47EEDBB146CB}"/>
+                <a16:creationId xmlns:a16="http://schemas.microsoft.com/office/drawing/2014/main" id="{9BC155C1-D19F-4891-B31E-6C13A6D4823A}"/>
               </a:ext>
             </a:extLst>
           </p:cNvPr>
@@ -5250,7 +5250,7 @@
           <p:cNvPr id="5" name="">
             <a:extLst xmlns:a="http://schemas.openxmlformats.org/drawingml/2006/main">
               <a:ext uri="{FF2B5EF4-FFF2-40B4-BE49-F238E27FC236}">
-                <a16:creationId xmlns:a16="http://schemas.microsoft.com/office/drawing/2014/main" id="{F86A1389-091F-4020-B8F3-68152C51716F}"/>
+                <a16:creationId xmlns:a16="http://schemas.microsoft.com/office/drawing/2014/main" id="{15033870-5A6C-4FA0-8B19-46D80FFBB782}"/>
               </a:ext>
             </a:extLst>
           </p:cNvPr>
@@ -5283,7 +5283,7 @@
           <p:cNvPr id="6" name="">
             <a:extLst xmlns:a="http://schemas.openxmlformats.org/drawingml/2006/main">
               <a:ext uri="{FF2B5EF4-FFF2-40B4-BE49-F238E27FC236}">
-                <a16:creationId xmlns:a16="http://schemas.microsoft.com/office/drawing/2014/main" id="{D5DABA5D-0B47-4F36-BADC-A38BF752C128}"/>
+                <a16:creationId xmlns:a16="http://schemas.microsoft.com/office/drawing/2014/main" id="{EA1E97E7-10C8-4DE1-9E0C-078FD548318C}"/>
               </a:ext>
             </a:extLst>
           </p:cNvPr>
@@ -5316,7 +5316,7 @@
           <p:cNvPr id="7" name="">
             <a:extLst xmlns:a="http://schemas.openxmlformats.org/drawingml/2006/main">
               <a:ext uri="{FF2B5EF4-FFF2-40B4-BE49-F238E27FC236}">
-                <a16:creationId xmlns:a16="http://schemas.microsoft.com/office/drawing/2014/main" id="{EE37B350-606B-44FD-8CC1-204DA1429641}"/>
+                <a16:creationId xmlns:a16="http://schemas.microsoft.com/office/drawing/2014/main" id="{71FF7FC3-0A6E-42EB-BEAD-431A8535CC51}"/>
               </a:ext>
             </a:extLst>
           </p:cNvPr>
@@ -5367,7 +5367,7 @@
           <p:cNvPr id="8" name="">
             <a:extLst xmlns:a="http://schemas.openxmlformats.org/drawingml/2006/main">
               <a:ext uri="{FF2B5EF4-FFF2-40B4-BE49-F238E27FC236}">
-                <a16:creationId xmlns:a16="http://schemas.microsoft.com/office/drawing/2014/main" id="{749441E7-9308-4BC6-9FA6-12ABEA773ECD}"/>
+                <a16:creationId xmlns:a16="http://schemas.microsoft.com/office/drawing/2014/main" id="{A8DED2A7-FD5C-4205-A087-ADBEB0B1DBC6}"/>
               </a:ext>
             </a:extLst>
           </p:cNvPr>
@@ -5418,7 +5418,7 @@
           <p:cNvPr id="9" name="">
             <a:extLst xmlns:a="http://schemas.openxmlformats.org/drawingml/2006/main">
               <a:ext uri="{FF2B5EF4-FFF2-40B4-BE49-F238E27FC236}">
-                <a16:creationId xmlns:a16="http://schemas.microsoft.com/office/drawing/2014/main" id="{606B2CB4-D6B9-435D-886E-54C1801CE398}"/>
+                <a16:creationId xmlns:a16="http://schemas.microsoft.com/office/drawing/2014/main" id="{E5E2F186-BD63-4E63-BD5B-D9BEF7A70CA2}"/>
               </a:ext>
             </a:extLst>
           </p:cNvPr>
@@ -5451,7 +5451,7 @@
           <p:cNvPr id="10" name="">
             <a:extLst xmlns:a="http://schemas.openxmlformats.org/drawingml/2006/main">
               <a:ext uri="{FF2B5EF4-FFF2-40B4-BE49-F238E27FC236}">
-                <a16:creationId xmlns:a16="http://schemas.microsoft.com/office/drawing/2014/main" id="{4750C2AA-9B60-473B-909A-B5BAAC886169}"/>
+                <a16:creationId xmlns:a16="http://schemas.microsoft.com/office/drawing/2014/main" id="{9881A0DB-216E-4398-B96F-E80865B6A942}"/>
               </a:ext>
             </a:extLst>
           </p:cNvPr>
@@ -5484,7 +5484,7 @@
           <p:cNvPr id="11" name="">
             <a:extLst xmlns:a="http://schemas.openxmlformats.org/drawingml/2006/main">
               <a:ext uri="{FF2B5EF4-FFF2-40B4-BE49-F238E27FC236}">
-                <a16:creationId xmlns:a16="http://schemas.microsoft.com/office/drawing/2014/main" id="{085BEDED-3936-4CF5-9635-B16ADA56DABD}"/>
+                <a16:creationId xmlns:a16="http://schemas.microsoft.com/office/drawing/2014/main" id="{4077BF3A-AAA1-4EFE-BF30-A6FC164E6212}"/>
               </a:ext>
             </a:extLst>
           </p:cNvPr>
@@ -5535,7 +5535,7 @@
           <p:cNvPr id="12" name="">
             <a:extLst xmlns:a="http://schemas.openxmlformats.org/drawingml/2006/main">
               <a:ext uri="{FF2B5EF4-FFF2-40B4-BE49-F238E27FC236}">
-                <a16:creationId xmlns:a16="http://schemas.microsoft.com/office/drawing/2014/main" id="{9079A200-5C3C-4FC0-9798-A1B609E5CFE4}"/>
+                <a16:creationId xmlns:a16="http://schemas.microsoft.com/office/drawing/2014/main" id="{80AF966D-E12E-4C18-BD0F-9795BDC3A39A}"/>
               </a:ext>
             </a:extLst>
           </p:cNvPr>
@@ -5586,7 +5586,7 @@
           <p:cNvPr id="13" name="">
             <a:extLst xmlns:a="http://schemas.openxmlformats.org/drawingml/2006/main">
               <a:ext uri="{FF2B5EF4-FFF2-40B4-BE49-F238E27FC236}">
-                <a16:creationId xmlns:a16="http://schemas.microsoft.com/office/drawing/2014/main" id="{36CC44D0-AB8A-4CB9-BBEA-D8A0027F4690}"/>
+                <a16:creationId xmlns:a16="http://schemas.microsoft.com/office/drawing/2014/main" id="{4193D793-8A55-41B8-8C31-B2E91064E6D7}"/>
               </a:ext>
             </a:extLst>
           </p:cNvPr>
@@ -5619,7 +5619,7 @@
           <p:cNvPr id="14" name="">
             <a:extLst xmlns:a="http://schemas.openxmlformats.org/drawingml/2006/main">
               <a:ext uri="{FF2B5EF4-FFF2-40B4-BE49-F238E27FC236}">
-                <a16:creationId xmlns:a16="http://schemas.microsoft.com/office/drawing/2014/main" id="{3E78E1FE-B622-4948-9B35-8A67E3503DA6}"/>
+                <a16:creationId xmlns:a16="http://schemas.microsoft.com/office/drawing/2014/main" id="{F44622FC-EDED-464A-9E4E-68284238F5C0}"/>
               </a:ext>
             </a:extLst>
           </p:cNvPr>
@@ -5652,7 +5652,7 @@
           <p:cNvPr id="15" name="">
             <a:extLst xmlns:a="http://schemas.openxmlformats.org/drawingml/2006/main">
               <a:ext uri="{FF2B5EF4-FFF2-40B4-BE49-F238E27FC236}">
-                <a16:creationId xmlns:a16="http://schemas.microsoft.com/office/drawing/2014/main" id="{2691F68A-F178-449E-9F3A-061260865191}"/>
+                <a16:creationId xmlns:a16="http://schemas.microsoft.com/office/drawing/2014/main" id="{489963E5-E55A-4379-A70D-A6D6CE095FE4}"/>
               </a:ext>
             </a:extLst>
           </p:cNvPr>
@@ -5703,7 +5703,7 @@
           <p:cNvPr id="16" name="">
             <a:extLst xmlns:a="http://schemas.openxmlformats.org/drawingml/2006/main">
               <a:ext uri="{FF2B5EF4-FFF2-40B4-BE49-F238E27FC236}">
-                <a16:creationId xmlns:a16="http://schemas.microsoft.com/office/drawing/2014/main" id="{BF6D0F60-9E19-4D92-87A4-81152F29ED9E}"/>
+                <a16:creationId xmlns:a16="http://schemas.microsoft.com/office/drawing/2014/main" id="{B7E8E02B-688B-4EEF-A974-7F7B0718C148}"/>
               </a:ext>
             </a:extLst>
           </p:cNvPr>
@@ -5754,7 +5754,7 @@
           <p:cNvPr id="17" name="">
             <a:extLst xmlns:a="http://schemas.openxmlformats.org/drawingml/2006/main">
               <a:ext uri="{FF2B5EF4-FFF2-40B4-BE49-F238E27FC236}">
-                <a16:creationId xmlns:a16="http://schemas.microsoft.com/office/drawing/2014/main" id="{CE393F91-C790-410E-80DC-C5D364F0D100}"/>
+                <a16:creationId xmlns:a16="http://schemas.microsoft.com/office/drawing/2014/main" id="{FD42A0CC-774B-44EF-A409-E2933A8186DF}"/>
               </a:ext>
             </a:extLst>
           </p:cNvPr>
@@ -5787,7 +5787,7 @@
           <p:cNvPr id="18" name="">
             <a:extLst xmlns:a="http://schemas.openxmlformats.org/drawingml/2006/main">
               <a:ext uri="{FF2B5EF4-FFF2-40B4-BE49-F238E27FC236}">
-                <a16:creationId xmlns:a16="http://schemas.microsoft.com/office/drawing/2014/main" id="{DEBFAD6A-30AF-4136-BC79-C96FA652F58D}"/>
+                <a16:creationId xmlns:a16="http://schemas.microsoft.com/office/drawing/2014/main" id="{FDCF1D60-D0CC-4E7D-BA1F-E24E4EBEE44C}"/>
               </a:ext>
             </a:extLst>
           </p:cNvPr>
@@ -5820,7 +5820,7 @@
           <p:cNvPr id="19" name="">
             <a:extLst xmlns:a="http://schemas.openxmlformats.org/drawingml/2006/main">
               <a:ext uri="{FF2B5EF4-FFF2-40B4-BE49-F238E27FC236}">
-                <a16:creationId xmlns:a16="http://schemas.microsoft.com/office/drawing/2014/main" id="{3558A166-BFF3-4131-A865-2A3C1188A94F}"/>
+                <a16:creationId xmlns:a16="http://schemas.microsoft.com/office/drawing/2014/main" id="{47D5F5CD-8AA4-4DE2-9550-ACDBB312CF57}"/>
               </a:ext>
             </a:extLst>
           </p:cNvPr>
@@ -5871,7 +5871,7 @@
           <p:cNvPr id="20" name="">
             <a:extLst xmlns:a="http://schemas.openxmlformats.org/drawingml/2006/main">
               <a:ext uri="{FF2B5EF4-FFF2-40B4-BE49-F238E27FC236}">
-                <a16:creationId xmlns:a16="http://schemas.microsoft.com/office/drawing/2014/main" id="{DEC8A14D-9A08-41AA-8F61-B8B552F9C0EB}"/>
+                <a16:creationId xmlns:a16="http://schemas.microsoft.com/office/drawing/2014/main" id="{7D5AF23D-7E44-450B-ABC2-20545D262A93}"/>
               </a:ext>
             </a:extLst>
           </p:cNvPr>
@@ -5922,7 +5922,7 @@
           <p:cNvPr id="21" name="">
             <a:extLst xmlns:a="http://schemas.openxmlformats.org/drawingml/2006/main">
               <a:ext uri="{FF2B5EF4-FFF2-40B4-BE49-F238E27FC236}">
-                <a16:creationId xmlns:a16="http://schemas.microsoft.com/office/drawing/2014/main" id="{BAB84A35-DF27-491A-BD77-FB243D0C5BA3}"/>
+                <a16:creationId xmlns:a16="http://schemas.microsoft.com/office/drawing/2014/main" id="{6FE5DDAA-C85E-414D-8B0B-D71A0720442E}"/>
               </a:ext>
             </a:extLst>
           </p:cNvPr>
@@ -5955,7 +5955,7 @@
           <p:cNvPr id="22" name="">
             <a:extLst xmlns:a="http://schemas.openxmlformats.org/drawingml/2006/main">
               <a:ext uri="{FF2B5EF4-FFF2-40B4-BE49-F238E27FC236}">
-                <a16:creationId xmlns:a16="http://schemas.microsoft.com/office/drawing/2014/main" id="{8B1E88FA-2276-4DA3-BD9D-CDCF0DE593C9}"/>
+                <a16:creationId xmlns:a16="http://schemas.microsoft.com/office/drawing/2014/main" id="{59CFDBAB-2174-4A5E-801F-68ED81BF50F6}"/>
               </a:ext>
             </a:extLst>
           </p:cNvPr>
@@ -5988,7 +5988,7 @@
           <p:cNvPr id="23" name="">
             <a:extLst xmlns:a="http://schemas.openxmlformats.org/drawingml/2006/main">
               <a:ext uri="{FF2B5EF4-FFF2-40B4-BE49-F238E27FC236}">
-                <a16:creationId xmlns:a16="http://schemas.microsoft.com/office/drawing/2014/main" id="{3CB2E207-5194-4C22-9F1C-769778DFA6E5}"/>
+                <a16:creationId xmlns:a16="http://schemas.microsoft.com/office/drawing/2014/main" id="{BB791FF8-50F3-47CD-A9A1-544230148A05}"/>
               </a:ext>
             </a:extLst>
           </p:cNvPr>
@@ -6039,7 +6039,7 @@
           <p:cNvPr id="24" name="">
             <a:extLst xmlns:a="http://schemas.openxmlformats.org/drawingml/2006/main">
               <a:ext uri="{FF2B5EF4-FFF2-40B4-BE49-F238E27FC236}">
-                <a16:creationId xmlns:a16="http://schemas.microsoft.com/office/drawing/2014/main" id="{E3F01CCC-4AA6-484D-ADBD-A66430413A17}"/>
+                <a16:creationId xmlns:a16="http://schemas.microsoft.com/office/drawing/2014/main" id="{6595A59A-3E5F-4F75-BD1C-444D53A36E4D}"/>
               </a:ext>
             </a:extLst>
           </p:cNvPr>
@@ -6090,7 +6090,7 @@
           <p:cNvPr id="25" name="">
             <a:extLst xmlns:a="http://schemas.openxmlformats.org/drawingml/2006/main">
               <a:ext uri="{FF2B5EF4-FFF2-40B4-BE49-F238E27FC236}">
-                <a16:creationId xmlns:a16="http://schemas.microsoft.com/office/drawing/2014/main" id="{AF1C1EFF-52B3-4C7E-859F-D2A06F7F0888}"/>
+                <a16:creationId xmlns:a16="http://schemas.microsoft.com/office/drawing/2014/main" id="{882643BB-1D58-460C-B28D-FDF9737BA071}"/>
               </a:ext>
             </a:extLst>
           </p:cNvPr>
@@ -6123,7 +6123,7 @@
           <p:cNvPr id="26" name="">
             <a:extLst xmlns:a="http://schemas.openxmlformats.org/drawingml/2006/main">
               <a:ext uri="{FF2B5EF4-FFF2-40B4-BE49-F238E27FC236}">
-                <a16:creationId xmlns:a16="http://schemas.microsoft.com/office/drawing/2014/main" id="{03CCD780-7F68-4329-94C3-03447BAE4726}"/>
+                <a16:creationId xmlns:a16="http://schemas.microsoft.com/office/drawing/2014/main" id="{B1344B9E-1166-4D6A-B8F4-BCE3D6F3DE92}"/>
               </a:ext>
             </a:extLst>
           </p:cNvPr>
@@ -6156,7 +6156,7 @@
           <p:cNvPr id="27" name="">
             <a:extLst xmlns:a="http://schemas.openxmlformats.org/drawingml/2006/main">
               <a:ext uri="{FF2B5EF4-FFF2-40B4-BE49-F238E27FC236}">
-                <a16:creationId xmlns:a16="http://schemas.microsoft.com/office/drawing/2014/main" id="{5D33791A-24D5-47BE-B0A7-F4081BB6844A}"/>
+                <a16:creationId xmlns:a16="http://schemas.microsoft.com/office/drawing/2014/main" id="{6FF8105F-1D47-4073-9071-49CF18CA6FB2}"/>
               </a:ext>
             </a:extLst>
           </p:cNvPr>
@@ -6207,7 +6207,7 @@
           <p:cNvPr id="28" name="">
             <a:extLst xmlns:a="http://schemas.openxmlformats.org/drawingml/2006/main">
               <a:ext uri="{FF2B5EF4-FFF2-40B4-BE49-F238E27FC236}">
-                <a16:creationId xmlns:a16="http://schemas.microsoft.com/office/drawing/2014/main" id="{62E43CB2-ACF3-4B4E-AA17-620BBBBD8B41}"/>
+                <a16:creationId xmlns:a16="http://schemas.microsoft.com/office/drawing/2014/main" id="{5CBFBEF4-63B4-4BAF-8F13-04D61F5F62DD}"/>
               </a:ext>
             </a:extLst>
           </p:cNvPr>
@@ -6258,7 +6258,7 @@
           <p:cNvPr id="29" name="">
             <a:extLst xmlns:a="http://schemas.openxmlformats.org/drawingml/2006/main">
               <a:ext uri="{FF2B5EF4-FFF2-40B4-BE49-F238E27FC236}">
-                <a16:creationId xmlns:a16="http://schemas.microsoft.com/office/drawing/2014/main" id="{DFEBAA23-F2FE-468B-804A-120D88050C52}"/>
+                <a16:creationId xmlns:a16="http://schemas.microsoft.com/office/drawing/2014/main" id="{B2B0F18C-4425-48EA-82EA-EBE92E4A521B}"/>
               </a:ext>
             </a:extLst>
           </p:cNvPr>
@@ -6291,7 +6291,7 @@
           <p:cNvPr id="30" name="">
             <a:extLst xmlns:a="http://schemas.openxmlformats.org/drawingml/2006/main">
               <a:ext uri="{FF2B5EF4-FFF2-40B4-BE49-F238E27FC236}">
-                <a16:creationId xmlns:a16="http://schemas.microsoft.com/office/drawing/2014/main" id="{EBB19421-60F6-4EE7-AC6B-E968C4B48950}"/>
+                <a16:creationId xmlns:a16="http://schemas.microsoft.com/office/drawing/2014/main" id="{0AB7571E-5A13-4666-91BB-69E0104C1759}"/>
               </a:ext>
             </a:extLst>
           </p:cNvPr>
@@ -6324,7 +6324,7 @@
           <p:cNvPr id="31" name="">
             <a:extLst xmlns:a="http://schemas.openxmlformats.org/drawingml/2006/main">
               <a:ext uri="{FF2B5EF4-FFF2-40B4-BE49-F238E27FC236}">
-                <a16:creationId xmlns:a16="http://schemas.microsoft.com/office/drawing/2014/main" id="{2B40EA34-A32C-4072-9498-6A5AD47DAB58}"/>
+                <a16:creationId xmlns:a16="http://schemas.microsoft.com/office/drawing/2014/main" id="{15329137-7BB6-4E58-B5F5-35543FD1C225}"/>
               </a:ext>
             </a:extLst>
           </p:cNvPr>
@@ -6375,7 +6375,7 @@
           <p:cNvPr id="32" name="">
             <a:extLst xmlns:a="http://schemas.openxmlformats.org/drawingml/2006/main">
               <a:ext uri="{FF2B5EF4-FFF2-40B4-BE49-F238E27FC236}">
-                <a16:creationId xmlns:a16="http://schemas.microsoft.com/office/drawing/2014/main" id="{085EF4F3-D277-4A6B-BAB4-21343F042245}"/>
+                <a16:creationId xmlns:a16="http://schemas.microsoft.com/office/drawing/2014/main" id="{F8BB5714-548E-4B24-A1CF-A6B73F9D40BD}"/>
               </a:ext>
             </a:extLst>
           </p:cNvPr>
@@ -6426,7 +6426,7 @@
           <p:cNvPr id="33" name="">
             <a:extLst xmlns:a="http://schemas.openxmlformats.org/drawingml/2006/main">
               <a:ext uri="{FF2B5EF4-FFF2-40B4-BE49-F238E27FC236}">
-                <a16:creationId xmlns:a16="http://schemas.microsoft.com/office/drawing/2014/main" id="{3661F09A-2025-49FD-A889-63D8D4E611D0}"/>
+                <a16:creationId xmlns:a16="http://schemas.microsoft.com/office/drawing/2014/main" id="{74717E0C-2D03-484C-9489-B5F319D955DA}"/>
               </a:ext>
             </a:extLst>
           </p:cNvPr>
@@ -6477,7 +6477,7 @@
           <p:cNvPr id="34" name="">
             <a:extLst xmlns:a="http://schemas.openxmlformats.org/drawingml/2006/main">
               <a:ext uri="{FF2B5EF4-FFF2-40B4-BE49-F238E27FC236}">
-                <a16:creationId xmlns:a16="http://schemas.microsoft.com/office/drawing/2014/main" id="{8F448856-22B9-42E0-98F5-FA40EDB7F05E}"/>
+                <a16:creationId xmlns:a16="http://schemas.microsoft.com/office/drawing/2014/main" id="{2E472409-3FF6-4389-822A-48E5030F6C72}"/>
               </a:ext>
             </a:extLst>
           </p:cNvPr>
@@ -6526,7 +6526,7 @@
     </p:spTree>
     <p:extLst>
       <p:ext uri="{BB962C8B-B14F-4D97-AF65-F5344CB8AC3E}">
-        <p14:creationId xmlns:p14="http://schemas.microsoft.com/office/powerpoint/2010/main" val="1047464516"/>
+        <p14:creationId xmlns:p14="http://schemas.microsoft.com/office/powerpoint/2010/main" val="318801805"/>
       </p:ext>
     </p:extLst>
   </p:cSld>
@@ -6550,7 +6550,7 @@
           <p:cNvPr id="1" name="">
             <a:extLst xmlns:a="http://schemas.openxmlformats.org/drawingml/2006/main">
               <a:ext uri="{FF2B5EF4-FFF2-40B4-BE49-F238E27FC236}">
-                <a16:creationId xmlns:a16="http://schemas.microsoft.com/office/drawing/2014/main" id="{AA224BCB-3C6D-4B8F-B1BE-6FA98D7DB12F}"/>
+                <a16:creationId xmlns:a16="http://schemas.microsoft.com/office/drawing/2014/main" id="{C75248DF-86D7-4658-BF12-C0F1C7272495}"/>
               </a:ext>
             </a:extLst>
           </p:cNvPr>
@@ -6583,7 +6583,7 @@
           <p:cNvPr id="2" name="">
             <a:extLst xmlns:a="http://schemas.openxmlformats.org/drawingml/2006/main">
               <a:ext uri="{FF2B5EF4-FFF2-40B4-BE49-F238E27FC236}">
-                <a16:creationId xmlns:a16="http://schemas.microsoft.com/office/drawing/2014/main" id="{4837E99D-024F-428A-9505-1B359D414239}"/>
+                <a16:creationId xmlns:a16="http://schemas.microsoft.com/office/drawing/2014/main" id="{DCBDA448-ADD4-4448-A220-B5942DBA4DB2}"/>
               </a:ext>
             </a:extLst>
           </p:cNvPr>
@@ -6634,7 +6634,7 @@
           <p:cNvPr id="3" name="">
             <a:extLst xmlns:a="http://schemas.openxmlformats.org/drawingml/2006/main">
               <a:ext uri="{FF2B5EF4-FFF2-40B4-BE49-F238E27FC236}">
-                <a16:creationId xmlns:a16="http://schemas.microsoft.com/office/drawing/2014/main" id="{DBCD0C85-8704-48FF-88D3-9D419992E1FA}"/>
+                <a16:creationId xmlns:a16="http://schemas.microsoft.com/office/drawing/2014/main" id="{BD265EFE-494E-4D2D-9162-FCB6FCB7B669}"/>
               </a:ext>
             </a:extLst>
           </p:cNvPr>
@@ -6685,7 +6685,7 @@
           <p:cNvPr id="4" name="">
             <a:extLst xmlns:a="http://schemas.openxmlformats.org/drawingml/2006/main">
               <a:ext uri="{FF2B5EF4-FFF2-40B4-BE49-F238E27FC236}">
-                <a16:creationId xmlns:a16="http://schemas.microsoft.com/office/drawing/2014/main" id="{3478E4C8-1DE5-4974-AC2E-567F76F7A0AE}"/>
+                <a16:creationId xmlns:a16="http://schemas.microsoft.com/office/drawing/2014/main" id="{05D4DAF1-3753-4E3E-B032-6D353DB0250F}"/>
               </a:ext>
             </a:extLst>
           </p:cNvPr>
@@ -6718,7 +6718,7 @@
           <p:cNvPr id="5" name="">
             <a:extLst xmlns:a="http://schemas.openxmlformats.org/drawingml/2006/main">
               <a:ext uri="{FF2B5EF4-FFF2-40B4-BE49-F238E27FC236}">
-                <a16:creationId xmlns:a16="http://schemas.microsoft.com/office/drawing/2014/main" id="{F64F2301-4DA4-42AE-BF1A-A1DE8A66230C}"/>
+                <a16:creationId xmlns:a16="http://schemas.microsoft.com/office/drawing/2014/main" id="{ABCE024C-B05D-448C-9FCC-CBF23B02A5B8}"/>
               </a:ext>
             </a:extLst>
           </p:cNvPr>
@@ -6751,7 +6751,7 @@
           <p:cNvPr id="6" name="">
             <a:extLst xmlns:a="http://schemas.openxmlformats.org/drawingml/2006/main">
               <a:ext uri="{FF2B5EF4-FFF2-40B4-BE49-F238E27FC236}">
-                <a16:creationId xmlns:a16="http://schemas.microsoft.com/office/drawing/2014/main" id="{7570826D-DF6E-4BCB-8A2B-EAA51B50FBE8}"/>
+                <a16:creationId xmlns:a16="http://schemas.microsoft.com/office/drawing/2014/main" id="{C263E332-717E-4BA2-8231-B248844585BE}"/>
               </a:ext>
             </a:extLst>
           </p:cNvPr>
@@ -6802,7 +6802,7 @@
           <p:cNvPr id="7" name="">
             <a:extLst xmlns:a="http://schemas.openxmlformats.org/drawingml/2006/main">
               <a:ext uri="{FF2B5EF4-FFF2-40B4-BE49-F238E27FC236}">
-                <a16:creationId xmlns:a16="http://schemas.microsoft.com/office/drawing/2014/main" id="{56425EE7-3808-4195-88D1-8DEC28F97521}"/>
+                <a16:creationId xmlns:a16="http://schemas.microsoft.com/office/drawing/2014/main" id="{B421E990-C302-4A23-BE6E-D45D5039AC78}"/>
               </a:ext>
             </a:extLst>
           </p:cNvPr>
@@ -6835,7 +6835,7 @@
           <p:cNvPr id="8" name="">
             <a:extLst xmlns:a="http://schemas.openxmlformats.org/drawingml/2006/main">
               <a:ext uri="{FF2B5EF4-FFF2-40B4-BE49-F238E27FC236}">
-                <a16:creationId xmlns:a16="http://schemas.microsoft.com/office/drawing/2014/main" id="{BBF283CF-45BC-463E-9FCA-BFC5C81C1DF5}"/>
+                <a16:creationId xmlns:a16="http://schemas.microsoft.com/office/drawing/2014/main" id="{449F73A3-AD1D-4A7E-A879-5F015D69B79E}"/>
               </a:ext>
             </a:extLst>
           </p:cNvPr>
@@ -6886,7 +6886,7 @@
           <p:cNvPr id="9" name="">
             <a:extLst xmlns:a="http://schemas.openxmlformats.org/drawingml/2006/main">
               <a:ext uri="{FF2B5EF4-FFF2-40B4-BE49-F238E27FC236}">
-                <a16:creationId xmlns:a16="http://schemas.microsoft.com/office/drawing/2014/main" id="{E45C9D14-E263-4308-9093-8AE05AF88434}"/>
+                <a16:creationId xmlns:a16="http://schemas.microsoft.com/office/drawing/2014/main" id="{A6DFAFFE-DABB-4D38-9B0A-6C9EA6974A14}"/>
               </a:ext>
             </a:extLst>
           </p:cNvPr>
@@ -6919,7 +6919,7 @@
           <p:cNvPr id="10" name="">
             <a:extLst xmlns:a="http://schemas.openxmlformats.org/drawingml/2006/main">
               <a:ext uri="{FF2B5EF4-FFF2-40B4-BE49-F238E27FC236}">
-                <a16:creationId xmlns:a16="http://schemas.microsoft.com/office/drawing/2014/main" id="{3AD1A722-6D08-4633-B4F1-4968BA8229C5}"/>
+                <a16:creationId xmlns:a16="http://schemas.microsoft.com/office/drawing/2014/main" id="{195DD952-81D6-4A24-813E-6B5C3424E649}"/>
               </a:ext>
             </a:extLst>
           </p:cNvPr>
@@ -6970,7 +6970,7 @@
           <p:cNvPr id="11" name="">
             <a:extLst xmlns:a="http://schemas.openxmlformats.org/drawingml/2006/main">
               <a:ext uri="{FF2B5EF4-FFF2-40B4-BE49-F238E27FC236}">
-                <a16:creationId xmlns:a16="http://schemas.microsoft.com/office/drawing/2014/main" id="{96AB25C1-1F63-43FA-BAD5-417A95968C3A}"/>
+                <a16:creationId xmlns:a16="http://schemas.microsoft.com/office/drawing/2014/main" id="{32122382-AC46-4DB2-BDE5-A601FBE5D4FE}"/>
               </a:ext>
             </a:extLst>
           </p:cNvPr>
@@ -7003,7 +7003,7 @@
           <p:cNvPr id="12" name="">
             <a:extLst xmlns:a="http://schemas.openxmlformats.org/drawingml/2006/main">
               <a:ext uri="{FF2B5EF4-FFF2-40B4-BE49-F238E27FC236}">
-                <a16:creationId xmlns:a16="http://schemas.microsoft.com/office/drawing/2014/main" id="{B16CC759-6797-492A-8E43-7AAC2405AB94}"/>
+                <a16:creationId xmlns:a16="http://schemas.microsoft.com/office/drawing/2014/main" id="{93A835F9-CB8D-4F1B-99A4-52DE976904FC}"/>
               </a:ext>
             </a:extLst>
           </p:cNvPr>
@@ -7054,7 +7054,7 @@
           <p:cNvPr id="13" name="">
             <a:extLst xmlns:a="http://schemas.openxmlformats.org/drawingml/2006/main">
               <a:ext uri="{FF2B5EF4-FFF2-40B4-BE49-F238E27FC236}">
-                <a16:creationId xmlns:a16="http://schemas.microsoft.com/office/drawing/2014/main" id="{C7A795BD-16EC-4434-B6B4-F67B36BEA1C8}"/>
+                <a16:creationId xmlns:a16="http://schemas.microsoft.com/office/drawing/2014/main" id="{B1FB066B-34F9-4BEE-965E-3DA274F193F1}"/>
               </a:ext>
             </a:extLst>
           </p:cNvPr>
@@ -7087,7 +7087,7 @@
           <p:cNvPr id="14" name="">
             <a:extLst xmlns:a="http://schemas.openxmlformats.org/drawingml/2006/main">
               <a:ext uri="{FF2B5EF4-FFF2-40B4-BE49-F238E27FC236}">
-                <a16:creationId xmlns:a16="http://schemas.microsoft.com/office/drawing/2014/main" id="{65F74ECD-19EB-4548-87F3-BFEC855A2629}"/>
+                <a16:creationId xmlns:a16="http://schemas.microsoft.com/office/drawing/2014/main" id="{1C234E9E-6B65-422D-B4CC-FA8B01BF4057}"/>
               </a:ext>
             </a:extLst>
           </p:cNvPr>
@@ -7138,7 +7138,7 @@
           <p:cNvPr id="15" name="">
             <a:extLst xmlns:a="http://schemas.openxmlformats.org/drawingml/2006/main">
               <a:ext uri="{FF2B5EF4-FFF2-40B4-BE49-F238E27FC236}">
-                <a16:creationId xmlns:a16="http://schemas.microsoft.com/office/drawing/2014/main" id="{97569988-0B3B-4DAA-81AD-687771C3EFD4}"/>
+                <a16:creationId xmlns:a16="http://schemas.microsoft.com/office/drawing/2014/main" id="{7B4789D1-003A-4D38-9795-FA3657BE075E}"/>
               </a:ext>
             </a:extLst>
           </p:cNvPr>
@@ -7171,7 +7171,7 @@
           <p:cNvPr id="16" name="">
             <a:extLst xmlns:a="http://schemas.openxmlformats.org/drawingml/2006/main">
               <a:ext uri="{FF2B5EF4-FFF2-40B4-BE49-F238E27FC236}">
-                <a16:creationId xmlns:a16="http://schemas.microsoft.com/office/drawing/2014/main" id="{DFC3F536-A28B-41F8-8D03-D9638449F839}"/>
+                <a16:creationId xmlns:a16="http://schemas.microsoft.com/office/drawing/2014/main" id="{2B24D63F-68BF-48D0-9669-995E9A66611B}"/>
               </a:ext>
             </a:extLst>
           </p:cNvPr>
@@ -7204,7 +7204,7 @@
           <p:cNvPr id="17" name="">
             <a:extLst xmlns:a="http://schemas.openxmlformats.org/drawingml/2006/main">
               <a:ext uri="{FF2B5EF4-FFF2-40B4-BE49-F238E27FC236}">
-                <a16:creationId xmlns:a16="http://schemas.microsoft.com/office/drawing/2014/main" id="{16199D0F-05C9-4E1E-A34F-E3DF497F4CA0}"/>
+                <a16:creationId xmlns:a16="http://schemas.microsoft.com/office/drawing/2014/main" id="{FE4A2958-41D5-4E77-B02F-987FA708837C}"/>
               </a:ext>
             </a:extLst>
           </p:cNvPr>
@@ -7255,7 +7255,7 @@
           <p:cNvPr id="18" name="">
             <a:extLst xmlns:a="http://schemas.openxmlformats.org/drawingml/2006/main">
               <a:ext uri="{FF2B5EF4-FFF2-40B4-BE49-F238E27FC236}">
-                <a16:creationId xmlns:a16="http://schemas.microsoft.com/office/drawing/2014/main" id="{5A470CEE-450F-45BC-A085-7299C4AE55AB}"/>
+                <a16:creationId xmlns:a16="http://schemas.microsoft.com/office/drawing/2014/main" id="{C14835E8-C091-4324-AEC0-CFCB06AFEAC4}"/>
               </a:ext>
             </a:extLst>
           </p:cNvPr>
@@ -7288,7 +7288,7 @@
           <p:cNvPr id="19" name="">
             <a:extLst xmlns:a="http://schemas.openxmlformats.org/drawingml/2006/main">
               <a:ext uri="{FF2B5EF4-FFF2-40B4-BE49-F238E27FC236}">
-                <a16:creationId xmlns:a16="http://schemas.microsoft.com/office/drawing/2014/main" id="{49128BAA-2347-4D6A-901D-7BA0848D80DE}"/>
+                <a16:creationId xmlns:a16="http://schemas.microsoft.com/office/drawing/2014/main" id="{67CF6907-6AF5-4277-8C1F-C0F1ADC510E3}"/>
               </a:ext>
             </a:extLst>
           </p:cNvPr>
@@ -7339,7 +7339,7 @@
           <p:cNvPr id="20" name="">
             <a:extLst xmlns:a="http://schemas.openxmlformats.org/drawingml/2006/main">
               <a:ext uri="{FF2B5EF4-FFF2-40B4-BE49-F238E27FC236}">
-                <a16:creationId xmlns:a16="http://schemas.microsoft.com/office/drawing/2014/main" id="{734BEE20-F16B-49B6-A62B-77A2205587FB}"/>
+                <a16:creationId xmlns:a16="http://schemas.microsoft.com/office/drawing/2014/main" id="{2D4FDD1E-746B-4D33-AEC6-474CF82786E7}"/>
               </a:ext>
             </a:extLst>
           </p:cNvPr>
@@ -7372,7 +7372,7 @@
           <p:cNvPr id="21" name="">
             <a:extLst xmlns:a="http://schemas.openxmlformats.org/drawingml/2006/main">
               <a:ext uri="{FF2B5EF4-FFF2-40B4-BE49-F238E27FC236}">
-                <a16:creationId xmlns:a16="http://schemas.microsoft.com/office/drawing/2014/main" id="{6D485B07-4284-4809-B4D7-D5B5EED6884D}"/>
+                <a16:creationId xmlns:a16="http://schemas.microsoft.com/office/drawing/2014/main" id="{86E74080-7DE3-4E02-BB3F-E4E18AC0F736}"/>
               </a:ext>
             </a:extLst>
           </p:cNvPr>
@@ -7423,7 +7423,7 @@
           <p:cNvPr id="22" name="">
             <a:extLst xmlns:a="http://schemas.openxmlformats.org/drawingml/2006/main">
               <a:ext uri="{FF2B5EF4-FFF2-40B4-BE49-F238E27FC236}">
-                <a16:creationId xmlns:a16="http://schemas.microsoft.com/office/drawing/2014/main" id="{39F53EDF-4419-4730-8808-8903AF6FD053}"/>
+                <a16:creationId xmlns:a16="http://schemas.microsoft.com/office/drawing/2014/main" id="{426D167C-3529-4274-BD23-8C5B8A66C32C}"/>
               </a:ext>
             </a:extLst>
           </p:cNvPr>
@@ -7456,7 +7456,7 @@
           <p:cNvPr id="23" name="">
             <a:extLst xmlns:a="http://schemas.openxmlformats.org/drawingml/2006/main">
               <a:ext uri="{FF2B5EF4-FFF2-40B4-BE49-F238E27FC236}">
-                <a16:creationId xmlns:a16="http://schemas.microsoft.com/office/drawing/2014/main" id="{0BD95D67-99E4-45E5-B35D-40EAC9C4833D}"/>
+                <a16:creationId xmlns:a16="http://schemas.microsoft.com/office/drawing/2014/main" id="{ED721584-27CF-4A31-8833-2BA1EB4C4C27}"/>
               </a:ext>
             </a:extLst>
           </p:cNvPr>
@@ -7507,7 +7507,7 @@
           <p:cNvPr id="24" name="">
             <a:extLst xmlns:a="http://schemas.openxmlformats.org/drawingml/2006/main">
               <a:ext uri="{FF2B5EF4-FFF2-40B4-BE49-F238E27FC236}">
-                <a16:creationId xmlns:a16="http://schemas.microsoft.com/office/drawing/2014/main" id="{DCFEBDD7-2D8C-4CCA-A626-262CDFC0E407}"/>
+                <a16:creationId xmlns:a16="http://schemas.microsoft.com/office/drawing/2014/main" id="{FB2F7D71-B591-4154-AA99-59BE390D56B6}"/>
               </a:ext>
             </a:extLst>
           </p:cNvPr>
@@ -7540,7 +7540,7 @@
           <p:cNvPr id="25" name="">
             <a:extLst xmlns:a="http://schemas.openxmlformats.org/drawingml/2006/main">
               <a:ext uri="{FF2B5EF4-FFF2-40B4-BE49-F238E27FC236}">
-                <a16:creationId xmlns:a16="http://schemas.microsoft.com/office/drawing/2014/main" id="{064F2162-3126-41AD-B014-639840C1CDC2}"/>
+                <a16:creationId xmlns:a16="http://schemas.microsoft.com/office/drawing/2014/main" id="{F0A849B6-FA49-41BA-BCF1-C6471B89D1D2}"/>
               </a:ext>
             </a:extLst>
           </p:cNvPr>
@@ -7591,7 +7591,7 @@
           <p:cNvPr id="26" name="">
             <a:extLst xmlns:a="http://schemas.openxmlformats.org/drawingml/2006/main">
               <a:ext uri="{FF2B5EF4-FFF2-40B4-BE49-F238E27FC236}">
-                <a16:creationId xmlns:a16="http://schemas.microsoft.com/office/drawing/2014/main" id="{5B2D84F0-D93B-4345-A89F-E3371FFB44DF}"/>
+                <a16:creationId xmlns:a16="http://schemas.microsoft.com/office/drawing/2014/main" id="{7AF294BF-55DE-4555-BBFD-E21E24E42828}"/>
               </a:ext>
             </a:extLst>
           </p:cNvPr>
@@ -7624,7 +7624,7 @@
           <p:cNvPr id="27" name="">
             <a:extLst xmlns:a="http://schemas.openxmlformats.org/drawingml/2006/main">
               <a:ext uri="{FF2B5EF4-FFF2-40B4-BE49-F238E27FC236}">
-                <a16:creationId xmlns:a16="http://schemas.microsoft.com/office/drawing/2014/main" id="{B9B207A2-41FD-473F-B4CE-C74B03C9F677}"/>
+                <a16:creationId xmlns:a16="http://schemas.microsoft.com/office/drawing/2014/main" id="{BAFABB9B-970B-43EC-8E2B-9375B46D6D6B}"/>
               </a:ext>
             </a:extLst>
           </p:cNvPr>
@@ -7657,7 +7657,7 @@
           <p:cNvPr id="28" name="">
             <a:extLst xmlns:a="http://schemas.openxmlformats.org/drawingml/2006/main">
               <a:ext uri="{FF2B5EF4-FFF2-40B4-BE49-F238E27FC236}">
-                <a16:creationId xmlns:a16="http://schemas.microsoft.com/office/drawing/2014/main" id="{9150D7E7-44B5-45E8-8469-D6260D0ACAC7}"/>
+                <a16:creationId xmlns:a16="http://schemas.microsoft.com/office/drawing/2014/main" id="{58A27230-44D1-44B2-BB49-B322F16ECE7B}"/>
               </a:ext>
             </a:extLst>
           </p:cNvPr>
@@ -7708,7 +7708,7 @@
           <p:cNvPr id="29" name="">
             <a:extLst xmlns:a="http://schemas.openxmlformats.org/drawingml/2006/main">
               <a:ext uri="{FF2B5EF4-FFF2-40B4-BE49-F238E27FC236}">
-                <a16:creationId xmlns:a16="http://schemas.microsoft.com/office/drawing/2014/main" id="{5C40A906-94FD-409A-9F43-A9FA37297044}"/>
+                <a16:creationId xmlns:a16="http://schemas.microsoft.com/office/drawing/2014/main" id="{9FC1ADAD-C7C6-40DF-B18F-C9AF8A6BB3FF}"/>
               </a:ext>
             </a:extLst>
           </p:cNvPr>
@@ -7741,7 +7741,7 @@
           <p:cNvPr id="30" name="">
             <a:extLst xmlns:a="http://schemas.openxmlformats.org/drawingml/2006/main">
               <a:ext uri="{FF2B5EF4-FFF2-40B4-BE49-F238E27FC236}">
-                <a16:creationId xmlns:a16="http://schemas.microsoft.com/office/drawing/2014/main" id="{BD32A7E3-1359-4790-877E-434D52C3C523}"/>
+                <a16:creationId xmlns:a16="http://schemas.microsoft.com/office/drawing/2014/main" id="{EDA69B85-1482-4994-817B-9212D1AC46CF}"/>
               </a:ext>
             </a:extLst>
           </p:cNvPr>
@@ -7792,7 +7792,7 @@
           <p:cNvPr id="31" name="">
             <a:extLst xmlns:a="http://schemas.openxmlformats.org/drawingml/2006/main">
               <a:ext uri="{FF2B5EF4-FFF2-40B4-BE49-F238E27FC236}">
-                <a16:creationId xmlns:a16="http://schemas.microsoft.com/office/drawing/2014/main" id="{5A905DF0-B80E-4298-9573-F0810BF5C37D}"/>
+                <a16:creationId xmlns:a16="http://schemas.microsoft.com/office/drawing/2014/main" id="{24F87EC3-4F59-4BA4-A073-5D0C16510F8A}"/>
               </a:ext>
             </a:extLst>
           </p:cNvPr>
@@ -7825,7 +7825,7 @@
           <p:cNvPr id="32" name="">
             <a:extLst xmlns:a="http://schemas.openxmlformats.org/drawingml/2006/main">
               <a:ext uri="{FF2B5EF4-FFF2-40B4-BE49-F238E27FC236}">
-                <a16:creationId xmlns:a16="http://schemas.microsoft.com/office/drawing/2014/main" id="{1BD7B885-96FC-482C-AD0A-EE7151F7C371}"/>
+                <a16:creationId xmlns:a16="http://schemas.microsoft.com/office/drawing/2014/main" id="{8AE324EE-F5C8-4224-921D-A4A06221FA97}"/>
               </a:ext>
             </a:extLst>
           </p:cNvPr>
@@ -7876,7 +7876,7 @@
           <p:cNvPr id="33" name="">
             <a:extLst xmlns:a="http://schemas.openxmlformats.org/drawingml/2006/main">
               <a:ext uri="{FF2B5EF4-FFF2-40B4-BE49-F238E27FC236}">
-                <a16:creationId xmlns:a16="http://schemas.microsoft.com/office/drawing/2014/main" id="{EA7E52E6-0CE4-472A-93FE-0F4959645AA7}"/>
+                <a16:creationId xmlns:a16="http://schemas.microsoft.com/office/drawing/2014/main" id="{68E62E2A-4162-45BE-90A6-381499B99C47}"/>
               </a:ext>
             </a:extLst>
           </p:cNvPr>
@@ -7909,7 +7909,7 @@
           <p:cNvPr id="34" name="">
             <a:extLst xmlns:a="http://schemas.openxmlformats.org/drawingml/2006/main">
               <a:ext uri="{FF2B5EF4-FFF2-40B4-BE49-F238E27FC236}">
-                <a16:creationId xmlns:a16="http://schemas.microsoft.com/office/drawing/2014/main" id="{F9E27290-4D84-4552-90C3-A04032E082C6}"/>
+                <a16:creationId xmlns:a16="http://schemas.microsoft.com/office/drawing/2014/main" id="{2D5326C8-1C01-403A-850D-6CD2B1843345}"/>
               </a:ext>
             </a:extLst>
           </p:cNvPr>
@@ -7960,7 +7960,7 @@
           <p:cNvPr id="35" name="">
             <a:extLst xmlns:a="http://schemas.openxmlformats.org/drawingml/2006/main">
               <a:ext uri="{FF2B5EF4-FFF2-40B4-BE49-F238E27FC236}">
-                <a16:creationId xmlns:a16="http://schemas.microsoft.com/office/drawing/2014/main" id="{2C965936-8865-410E-AD5B-4D3960F61266}"/>
+                <a16:creationId xmlns:a16="http://schemas.microsoft.com/office/drawing/2014/main" id="{A37F994A-9614-4175-A331-B38EF8B943C9}"/>
               </a:ext>
             </a:extLst>
           </p:cNvPr>
@@ -7993,7 +7993,7 @@
           <p:cNvPr id="36" name="">
             <a:extLst xmlns:a="http://schemas.openxmlformats.org/drawingml/2006/main">
               <a:ext uri="{FF2B5EF4-FFF2-40B4-BE49-F238E27FC236}">
-                <a16:creationId xmlns:a16="http://schemas.microsoft.com/office/drawing/2014/main" id="{442182E1-CB3A-4DB1-A0FB-EBA4FD717757}"/>
+                <a16:creationId xmlns:a16="http://schemas.microsoft.com/office/drawing/2014/main" id="{401F7ABA-59FD-40C4-8901-C83EFF7F3852}"/>
               </a:ext>
             </a:extLst>
           </p:cNvPr>
@@ -8044,7 +8044,7 @@
           <p:cNvPr id="37" name="">
             <a:extLst xmlns:a="http://schemas.openxmlformats.org/drawingml/2006/main">
               <a:ext uri="{FF2B5EF4-FFF2-40B4-BE49-F238E27FC236}">
-                <a16:creationId xmlns:a16="http://schemas.microsoft.com/office/drawing/2014/main" id="{E1393674-7FCF-4201-A7FB-46CDC09E1739}"/>
+                <a16:creationId xmlns:a16="http://schemas.microsoft.com/office/drawing/2014/main" id="{85903B3F-95F9-4A6A-B365-A5374B9325A8}"/>
               </a:ext>
             </a:extLst>
           </p:cNvPr>
@@ -8095,7 +8095,7 @@
           <p:cNvPr id="38" name="">
             <a:extLst xmlns:a="http://schemas.openxmlformats.org/drawingml/2006/main">
               <a:ext uri="{FF2B5EF4-FFF2-40B4-BE49-F238E27FC236}">
-                <a16:creationId xmlns:a16="http://schemas.microsoft.com/office/drawing/2014/main" id="{8FC65B0A-8437-479C-91BC-E17D76B9E743}"/>
+                <a16:creationId xmlns:a16="http://schemas.microsoft.com/office/drawing/2014/main" id="{E481880F-545E-4656-889B-8D0E091F43BD}"/>
               </a:ext>
             </a:extLst>
           </p:cNvPr>
@@ -8146,7 +8146,7 @@
           <p:cNvPr id="39" name="">
             <a:extLst xmlns:a="http://schemas.openxmlformats.org/drawingml/2006/main">
               <a:ext uri="{FF2B5EF4-FFF2-40B4-BE49-F238E27FC236}">
-                <a16:creationId xmlns:a16="http://schemas.microsoft.com/office/drawing/2014/main" id="{3DBC587E-3E13-455F-BCBD-15CD22FD90EE}"/>
+                <a16:creationId xmlns:a16="http://schemas.microsoft.com/office/drawing/2014/main" id="{16CCA8DB-69D8-4609-A0BA-82E59AB140DE}"/>
               </a:ext>
             </a:extLst>
           </p:cNvPr>
@@ -8197,7 +8197,7 @@
           <p:cNvPr id="40" name="">
             <a:extLst xmlns:a="http://schemas.openxmlformats.org/drawingml/2006/main">
               <a:ext uri="{FF2B5EF4-FFF2-40B4-BE49-F238E27FC236}">
-                <a16:creationId xmlns:a16="http://schemas.microsoft.com/office/drawing/2014/main" id="{FD267EBC-76BB-4255-8F67-74ACFD59AD68}"/>
+                <a16:creationId xmlns:a16="http://schemas.microsoft.com/office/drawing/2014/main" id="{CCA6E482-EC90-4CB0-97B1-73346276BA69}"/>
               </a:ext>
             </a:extLst>
           </p:cNvPr>
@@ -8246,7 +8246,7 @@
     </p:spTree>
     <p:extLst>
       <p:ext uri="{BB962C8B-B14F-4D97-AF65-F5344CB8AC3E}">
-        <p14:creationId xmlns:p14="http://schemas.microsoft.com/office/powerpoint/2010/main" val="800764287"/>
+        <p14:creationId xmlns:p14="http://schemas.microsoft.com/office/powerpoint/2010/main" val="757400114"/>
       </p:ext>
     </p:extLst>
   </p:cSld>
@@ -8270,7 +8270,7 @@
           <p:cNvPr id="1" name="">
             <a:extLst xmlns:a="http://schemas.openxmlformats.org/drawingml/2006/main">
               <a:ext uri="{FF2B5EF4-FFF2-40B4-BE49-F238E27FC236}">
-                <a16:creationId xmlns:a16="http://schemas.microsoft.com/office/drawing/2014/main" id="{844F4144-879E-4F50-9F7B-AD6310EC4A1F}"/>
+                <a16:creationId xmlns:a16="http://schemas.microsoft.com/office/drawing/2014/main" id="{91421AE4-13A3-47FC-982F-BB7DDC9FF60C}"/>
               </a:ext>
             </a:extLst>
           </p:cNvPr>
@@ -8303,7 +8303,7 @@
           <p:cNvPr id="2" name="">
             <a:extLst xmlns:a="http://schemas.openxmlformats.org/drawingml/2006/main">
               <a:ext uri="{FF2B5EF4-FFF2-40B4-BE49-F238E27FC236}">
-                <a16:creationId xmlns:a16="http://schemas.microsoft.com/office/drawing/2014/main" id="{8985043A-0DA5-4641-A5B1-9E8CA5F6B056}"/>
+                <a16:creationId xmlns:a16="http://schemas.microsoft.com/office/drawing/2014/main" id="{49163BA8-EABE-4B34-B98F-C78344C56390}"/>
               </a:ext>
             </a:extLst>
           </p:cNvPr>
@@ -8354,7 +8354,7 @@
           <p:cNvPr id="3" name="">
             <a:extLst xmlns:a="http://schemas.openxmlformats.org/drawingml/2006/main">
               <a:ext uri="{FF2B5EF4-FFF2-40B4-BE49-F238E27FC236}">
-                <a16:creationId xmlns:a16="http://schemas.microsoft.com/office/drawing/2014/main" id="{661A520C-788A-4CA4-A649-1A9B51A19110}"/>
+                <a16:creationId xmlns:a16="http://schemas.microsoft.com/office/drawing/2014/main" id="{7327F017-DDA3-4687-BDF3-E08F66917166}"/>
               </a:ext>
             </a:extLst>
           </p:cNvPr>
@@ -8405,7 +8405,7 @@
           <p:cNvPr id="4" name="">
             <a:extLst xmlns:a="http://schemas.openxmlformats.org/drawingml/2006/main">
               <a:ext uri="{FF2B5EF4-FFF2-40B4-BE49-F238E27FC236}">
-                <a16:creationId xmlns:a16="http://schemas.microsoft.com/office/drawing/2014/main" id="{11AA92F2-693D-4873-9AD7-3B65779BFB33}"/>
+                <a16:creationId xmlns:a16="http://schemas.microsoft.com/office/drawing/2014/main" id="{9BB61773-6ED6-47E5-8FB0-FF8181082093}"/>
               </a:ext>
             </a:extLst>
           </p:cNvPr>
@@ -8456,7 +8456,7 @@
           <p:cNvPr id="5" name="">
             <a:extLst xmlns:a="http://schemas.openxmlformats.org/drawingml/2006/main">
               <a:ext uri="{FF2B5EF4-FFF2-40B4-BE49-F238E27FC236}">
-                <a16:creationId xmlns:a16="http://schemas.microsoft.com/office/drawing/2014/main" id="{556E55CB-627F-463C-BABE-525534A13DDE}"/>
+                <a16:creationId xmlns:a16="http://schemas.microsoft.com/office/drawing/2014/main" id="{806AE433-FD3E-4A59-B540-5AE22C0FC3BD}"/>
               </a:ext>
             </a:extLst>
           </p:cNvPr>
@@ -8507,7 +8507,7 @@
           <p:cNvPr id="6" name="">
             <a:extLst xmlns:a="http://schemas.openxmlformats.org/drawingml/2006/main">
               <a:ext uri="{FF2B5EF4-FFF2-40B4-BE49-F238E27FC236}">
-                <a16:creationId xmlns:a16="http://schemas.microsoft.com/office/drawing/2014/main" id="{5783C444-9996-40C7-B909-B13583556C95}"/>
+                <a16:creationId xmlns:a16="http://schemas.microsoft.com/office/drawing/2014/main" id="{955A25C8-880E-442D-B1D4-8FD8C1C60B54}"/>
               </a:ext>
             </a:extLst>
           </p:cNvPr>
@@ -8558,7 +8558,7 @@
           <p:cNvPr id="7" name="">
             <a:extLst xmlns:a="http://schemas.openxmlformats.org/drawingml/2006/main">
               <a:ext uri="{FF2B5EF4-FFF2-40B4-BE49-F238E27FC236}">
-                <a16:creationId xmlns:a16="http://schemas.microsoft.com/office/drawing/2014/main" id="{08027EDF-A2A3-48CF-9EF4-99CB93943676}"/>
+                <a16:creationId xmlns:a16="http://schemas.microsoft.com/office/drawing/2014/main" id="{03062977-8289-42E8-A196-18F27766EEE4}"/>
               </a:ext>
             </a:extLst>
           </p:cNvPr>
@@ -8591,7 +8591,7 @@
           <p:cNvPr id="8" name="">
             <a:extLst xmlns:a="http://schemas.openxmlformats.org/drawingml/2006/main">
               <a:ext uri="{FF2B5EF4-FFF2-40B4-BE49-F238E27FC236}">
-                <a16:creationId xmlns:a16="http://schemas.microsoft.com/office/drawing/2014/main" id="{E8EB8470-E7EE-45BD-A8F6-F56C8A98EA33}"/>
+                <a16:creationId xmlns:a16="http://schemas.microsoft.com/office/drawing/2014/main" id="{1D3C8324-7A4A-457F-9116-906374DB6713}"/>
               </a:ext>
             </a:extLst>
           </p:cNvPr>
@@ -8624,7 +8624,7 @@
           <p:cNvPr id="9" name="">
             <a:extLst xmlns:a="http://schemas.openxmlformats.org/drawingml/2006/main">
               <a:ext uri="{FF2B5EF4-FFF2-40B4-BE49-F238E27FC236}">
-                <a16:creationId xmlns:a16="http://schemas.microsoft.com/office/drawing/2014/main" id="{34A8A43C-B770-40DB-A5DF-6BF2C69F8390}"/>
+                <a16:creationId xmlns:a16="http://schemas.microsoft.com/office/drawing/2014/main" id="{406136BF-5E81-40A4-9590-D85FA17D1B0F}"/>
               </a:ext>
             </a:extLst>
           </p:cNvPr>
@@ -8675,7 +8675,7 @@
           <p:cNvPr id="10" name="">
             <a:extLst xmlns:a="http://schemas.openxmlformats.org/drawingml/2006/main">
               <a:ext uri="{FF2B5EF4-FFF2-40B4-BE49-F238E27FC236}">
-                <a16:creationId xmlns:a16="http://schemas.microsoft.com/office/drawing/2014/main" id="{5721B0A7-36B8-4369-B8E2-92CA78EE3867}"/>
+                <a16:creationId xmlns:a16="http://schemas.microsoft.com/office/drawing/2014/main" id="{F5D916AC-403D-48D4-B0D4-029CF3F583ED}"/>
               </a:ext>
             </a:extLst>
           </p:cNvPr>
@@ -8726,7 +8726,7 @@
           <p:cNvPr id="11" name="">
             <a:extLst xmlns:a="http://schemas.openxmlformats.org/drawingml/2006/main">
               <a:ext uri="{FF2B5EF4-FFF2-40B4-BE49-F238E27FC236}">
-                <a16:creationId xmlns:a16="http://schemas.microsoft.com/office/drawing/2014/main" id="{9537C390-A31B-496A-91D8-26886B9A3C56}"/>
+                <a16:creationId xmlns:a16="http://schemas.microsoft.com/office/drawing/2014/main" id="{666C204C-BE55-43D0-9C13-C98D5E031720}"/>
               </a:ext>
             </a:extLst>
           </p:cNvPr>
@@ -8759,7 +8759,7 @@
           <p:cNvPr id="12" name="">
             <a:extLst xmlns:a="http://schemas.openxmlformats.org/drawingml/2006/main">
               <a:ext uri="{FF2B5EF4-FFF2-40B4-BE49-F238E27FC236}">
-                <a16:creationId xmlns:a16="http://schemas.microsoft.com/office/drawing/2014/main" id="{2DC474B4-2F19-4B08-A2F7-EC111F2936CE}"/>
+                <a16:creationId xmlns:a16="http://schemas.microsoft.com/office/drawing/2014/main" id="{D40C3466-E69D-4FDE-85F8-7A5EA2E031FE}"/>
               </a:ext>
             </a:extLst>
           </p:cNvPr>
@@ -8792,7 +8792,7 @@
           <p:cNvPr id="13" name="">
             <a:extLst xmlns:a="http://schemas.openxmlformats.org/drawingml/2006/main">
               <a:ext uri="{FF2B5EF4-FFF2-40B4-BE49-F238E27FC236}">
-                <a16:creationId xmlns:a16="http://schemas.microsoft.com/office/drawing/2014/main" id="{3950F8F9-C671-442B-8F8F-C1577BD50A76}"/>
+                <a16:creationId xmlns:a16="http://schemas.microsoft.com/office/drawing/2014/main" id="{1E6C9003-2779-4158-8975-0F1CB9D7CA95}"/>
               </a:ext>
             </a:extLst>
           </p:cNvPr>
@@ -8843,7 +8843,7 @@
           <p:cNvPr id="14" name="">
             <a:extLst xmlns:a="http://schemas.openxmlformats.org/drawingml/2006/main">
               <a:ext uri="{FF2B5EF4-FFF2-40B4-BE49-F238E27FC236}">
-                <a16:creationId xmlns:a16="http://schemas.microsoft.com/office/drawing/2014/main" id="{4C0F5C8A-877D-494E-9564-406499780E57}"/>
+                <a16:creationId xmlns:a16="http://schemas.microsoft.com/office/drawing/2014/main" id="{D90D68BF-1C14-4CE3-B56D-FF3D5BB1AFE9}"/>
               </a:ext>
             </a:extLst>
           </p:cNvPr>
@@ -8894,7 +8894,7 @@
           <p:cNvPr id="15" name="">
             <a:extLst xmlns:a="http://schemas.openxmlformats.org/drawingml/2006/main">
               <a:ext uri="{FF2B5EF4-FFF2-40B4-BE49-F238E27FC236}">
-                <a16:creationId xmlns:a16="http://schemas.microsoft.com/office/drawing/2014/main" id="{60B5EB52-2058-4493-984E-B795FB7F32E6}"/>
+                <a16:creationId xmlns:a16="http://schemas.microsoft.com/office/drawing/2014/main" id="{F88C51F5-489E-4D61-9E06-10C232AB256C}"/>
               </a:ext>
             </a:extLst>
           </p:cNvPr>
@@ -8927,7 +8927,7 @@
           <p:cNvPr id="16" name="">
             <a:extLst xmlns:a="http://schemas.openxmlformats.org/drawingml/2006/main">
               <a:ext uri="{FF2B5EF4-FFF2-40B4-BE49-F238E27FC236}">
-                <a16:creationId xmlns:a16="http://schemas.microsoft.com/office/drawing/2014/main" id="{6B4E9FEE-7D55-4B7D-8351-325FDACDBD05}"/>
+                <a16:creationId xmlns:a16="http://schemas.microsoft.com/office/drawing/2014/main" id="{8D8575FE-EB3F-4BB0-BA16-E0BB3F8294B0}"/>
               </a:ext>
             </a:extLst>
           </p:cNvPr>
@@ -8960,7 +8960,7 @@
           <p:cNvPr id="17" name="">
             <a:extLst xmlns:a="http://schemas.openxmlformats.org/drawingml/2006/main">
               <a:ext uri="{FF2B5EF4-FFF2-40B4-BE49-F238E27FC236}">
-                <a16:creationId xmlns:a16="http://schemas.microsoft.com/office/drawing/2014/main" id="{F9AC1656-7164-4C22-B616-D67466428742}"/>
+                <a16:creationId xmlns:a16="http://schemas.microsoft.com/office/drawing/2014/main" id="{7425CEDC-A675-4473-AC01-892CFD4D4896}"/>
               </a:ext>
             </a:extLst>
           </p:cNvPr>
@@ -9011,7 +9011,7 @@
           <p:cNvPr id="18" name="">
             <a:extLst xmlns:a="http://schemas.openxmlformats.org/drawingml/2006/main">
               <a:ext uri="{FF2B5EF4-FFF2-40B4-BE49-F238E27FC236}">
-                <a16:creationId xmlns:a16="http://schemas.microsoft.com/office/drawing/2014/main" id="{A39E2018-7889-43E8-BA60-FA03ABBA6126}"/>
+                <a16:creationId xmlns:a16="http://schemas.microsoft.com/office/drawing/2014/main" id="{C5ABC4AA-A86D-4070-A2B5-D4A95C2859EA}"/>
               </a:ext>
             </a:extLst>
           </p:cNvPr>
@@ -9062,7 +9062,7 @@
           <p:cNvPr id="19" name="">
             <a:extLst xmlns:a="http://schemas.openxmlformats.org/drawingml/2006/main">
               <a:ext uri="{FF2B5EF4-FFF2-40B4-BE49-F238E27FC236}">
-                <a16:creationId xmlns:a16="http://schemas.microsoft.com/office/drawing/2014/main" id="{449F55A4-DDE6-44BC-A3AF-65212CE8CACB}"/>
+                <a16:creationId xmlns:a16="http://schemas.microsoft.com/office/drawing/2014/main" id="{FC741A1D-E5D9-4763-B69A-1AE99C0CF563}"/>
               </a:ext>
             </a:extLst>
           </p:cNvPr>
@@ -9095,7 +9095,7 @@
           <p:cNvPr id="20" name="">
             <a:extLst xmlns:a="http://schemas.openxmlformats.org/drawingml/2006/main">
               <a:ext uri="{FF2B5EF4-FFF2-40B4-BE49-F238E27FC236}">
-                <a16:creationId xmlns:a16="http://schemas.microsoft.com/office/drawing/2014/main" id="{0802C6E3-45B6-45B8-B804-43521117A1FB}"/>
+                <a16:creationId xmlns:a16="http://schemas.microsoft.com/office/drawing/2014/main" id="{3E222F92-5DC3-468B-A4D5-B26AE6A12500}"/>
               </a:ext>
             </a:extLst>
           </p:cNvPr>
@@ -9128,7 +9128,7 @@
           <p:cNvPr id="21" name="">
             <a:extLst xmlns:a="http://schemas.openxmlformats.org/drawingml/2006/main">
               <a:ext uri="{FF2B5EF4-FFF2-40B4-BE49-F238E27FC236}">
-                <a16:creationId xmlns:a16="http://schemas.microsoft.com/office/drawing/2014/main" id="{DC0E29BA-9E59-4D2A-8F5C-64FF500799AD}"/>
+                <a16:creationId xmlns:a16="http://schemas.microsoft.com/office/drawing/2014/main" id="{D72ADCD7-BBD9-4066-9BC6-BA583F34CCAF}"/>
               </a:ext>
             </a:extLst>
           </p:cNvPr>
@@ -9179,7 +9179,7 @@
           <p:cNvPr id="22" name="">
             <a:extLst xmlns:a="http://schemas.openxmlformats.org/drawingml/2006/main">
               <a:ext uri="{FF2B5EF4-FFF2-40B4-BE49-F238E27FC236}">
-                <a16:creationId xmlns:a16="http://schemas.microsoft.com/office/drawing/2014/main" id="{D2DA855A-1751-4BC3-9955-04861A4F6DD1}"/>
+                <a16:creationId xmlns:a16="http://schemas.microsoft.com/office/drawing/2014/main" id="{0840D6BE-1447-4A65-AD48-C64C768AB22C}"/>
               </a:ext>
             </a:extLst>
           </p:cNvPr>
@@ -9230,7 +9230,7 @@
           <p:cNvPr id="23" name="">
             <a:extLst xmlns:a="http://schemas.openxmlformats.org/drawingml/2006/main">
               <a:ext uri="{FF2B5EF4-FFF2-40B4-BE49-F238E27FC236}">
-                <a16:creationId xmlns:a16="http://schemas.microsoft.com/office/drawing/2014/main" id="{831A0DC7-30A5-4685-AC54-ED1B0C409CFA}"/>
+                <a16:creationId xmlns:a16="http://schemas.microsoft.com/office/drawing/2014/main" id="{9EDEC11E-C5FB-4423-978C-E98CCB83F3A7}"/>
               </a:ext>
             </a:extLst>
           </p:cNvPr>
@@ -9281,7 +9281,7 @@
           <p:cNvPr id="24" name="">
             <a:extLst xmlns:a="http://schemas.openxmlformats.org/drawingml/2006/main">
               <a:ext uri="{FF2B5EF4-FFF2-40B4-BE49-F238E27FC236}">
-                <a16:creationId xmlns:a16="http://schemas.microsoft.com/office/drawing/2014/main" id="{72443B55-8057-4DB8-9AE9-EFFF8D5A451F}"/>
+                <a16:creationId xmlns:a16="http://schemas.microsoft.com/office/drawing/2014/main" id="{CF2D9B0C-FA0D-41EA-82C8-EBDC9B7F5852}"/>
               </a:ext>
             </a:extLst>
           </p:cNvPr>
@@ -9332,7 +9332,7 @@
           <p:cNvPr id="25" name="">
             <a:extLst xmlns:a="http://schemas.openxmlformats.org/drawingml/2006/main">
               <a:ext uri="{FF2B5EF4-FFF2-40B4-BE49-F238E27FC236}">
-                <a16:creationId xmlns:a16="http://schemas.microsoft.com/office/drawing/2014/main" id="{302DD8B8-2607-4CEE-A0B5-82FB6DEA2389}"/>
+                <a16:creationId xmlns:a16="http://schemas.microsoft.com/office/drawing/2014/main" id="{F8FC9B9C-D881-4D51-899C-D744288B9405}"/>
               </a:ext>
             </a:extLst>
           </p:cNvPr>
@@ -9381,7 +9381,7 @@
     </p:spTree>
     <p:extLst>
       <p:ext uri="{BB962C8B-B14F-4D97-AF65-F5344CB8AC3E}">
-        <p14:creationId xmlns:p14="http://schemas.microsoft.com/office/powerpoint/2010/main" val="1003413164"/>
+        <p14:creationId xmlns:p14="http://schemas.microsoft.com/office/powerpoint/2010/main" val="1995150264"/>
       </p:ext>
     </p:extLst>
   </p:cSld>
@@ -9405,7 +9405,7 @@
           <p:cNvPr id="1" name="">
             <a:extLst xmlns:a="http://schemas.openxmlformats.org/drawingml/2006/main">
               <a:ext uri="{FF2B5EF4-FFF2-40B4-BE49-F238E27FC236}">
-                <a16:creationId xmlns:a16="http://schemas.microsoft.com/office/drawing/2014/main" id="{2992A29F-F8B1-432F-A5DE-CB58F1F5FA2D}"/>
+                <a16:creationId xmlns:a16="http://schemas.microsoft.com/office/drawing/2014/main" id="{74ACDC9F-7B58-41B1-9926-681A2551D04C}"/>
               </a:ext>
             </a:extLst>
           </p:cNvPr>
@@ -9438,7 +9438,7 @@
           <p:cNvPr id="2" name="">
             <a:extLst xmlns:a="http://schemas.openxmlformats.org/drawingml/2006/main">
               <a:ext uri="{FF2B5EF4-FFF2-40B4-BE49-F238E27FC236}">
-                <a16:creationId xmlns:a16="http://schemas.microsoft.com/office/drawing/2014/main" id="{82933334-9B97-4CE1-B9F0-CEB3AA299773}"/>
+                <a16:creationId xmlns:a16="http://schemas.microsoft.com/office/drawing/2014/main" id="{ADCE0509-84B6-44BD-8452-CDA3F5D66C84}"/>
               </a:ext>
             </a:extLst>
           </p:cNvPr>
@@ -9489,7 +9489,7 @@
           <p:cNvPr id="3" name="">
             <a:extLst xmlns:a="http://schemas.openxmlformats.org/drawingml/2006/main">
               <a:ext uri="{FF2B5EF4-FFF2-40B4-BE49-F238E27FC236}">
-                <a16:creationId xmlns:a16="http://schemas.microsoft.com/office/drawing/2014/main" id="{3A9BCE7F-30A1-43F2-9FEF-AAB4FBA6EBB5}"/>
+                <a16:creationId xmlns:a16="http://schemas.microsoft.com/office/drawing/2014/main" id="{9E3EE278-FFB6-40AA-B205-0D8DCE3E3018}"/>
               </a:ext>
             </a:extLst>
           </p:cNvPr>
@@ -9540,7 +9540,7 @@
           <p:cNvPr id="4" name="">
             <a:extLst xmlns:a="http://schemas.openxmlformats.org/drawingml/2006/main">
               <a:ext uri="{FF2B5EF4-FFF2-40B4-BE49-F238E27FC236}">
-                <a16:creationId xmlns:a16="http://schemas.microsoft.com/office/drawing/2014/main" id="{0F2BC9D4-C0CB-47D1-BE5C-73B43F590D7B}"/>
+                <a16:creationId xmlns:a16="http://schemas.microsoft.com/office/drawing/2014/main" id="{E52AF4B2-3FE6-466A-AE38-9F40F6EA6D91}"/>
               </a:ext>
             </a:extLst>
           </p:cNvPr>
@@ -9573,7 +9573,7 @@
           <p:cNvPr id="5" name="">
             <a:extLst xmlns:a="http://schemas.openxmlformats.org/drawingml/2006/main">
               <a:ext uri="{FF2B5EF4-FFF2-40B4-BE49-F238E27FC236}">
-                <a16:creationId xmlns:a16="http://schemas.microsoft.com/office/drawing/2014/main" id="{8AA8EFD2-67E4-4536-841D-51CE0215697B}"/>
+                <a16:creationId xmlns:a16="http://schemas.microsoft.com/office/drawing/2014/main" id="{7D338FAE-6C6A-4F0E-AE4E-0BCA47DF821B}"/>
               </a:ext>
             </a:extLst>
           </p:cNvPr>
@@ -9606,7 +9606,7 @@
           <p:cNvPr id="6" name="">
             <a:extLst xmlns:a="http://schemas.openxmlformats.org/drawingml/2006/main">
               <a:ext uri="{FF2B5EF4-FFF2-40B4-BE49-F238E27FC236}">
-                <a16:creationId xmlns:a16="http://schemas.microsoft.com/office/drawing/2014/main" id="{D313F0E5-4D47-4D45-BFE5-590418D6554F}"/>
+                <a16:creationId xmlns:a16="http://schemas.microsoft.com/office/drawing/2014/main" id="{82370A90-8AFF-4675-8F70-C29C557CB2AC}"/>
               </a:ext>
             </a:extLst>
           </p:cNvPr>
@@ -9657,7 +9657,7 @@
           <p:cNvPr id="7" name="">
             <a:extLst xmlns:a="http://schemas.openxmlformats.org/drawingml/2006/main">
               <a:ext uri="{FF2B5EF4-FFF2-40B4-BE49-F238E27FC236}">
-                <a16:creationId xmlns:a16="http://schemas.microsoft.com/office/drawing/2014/main" id="{867D8755-EB8E-41F4-94AB-B725DB5EFB88}"/>
+                <a16:creationId xmlns:a16="http://schemas.microsoft.com/office/drawing/2014/main" id="{D5AC7A8B-251E-44FD-BF37-9599A7F0B3AB}"/>
               </a:ext>
             </a:extLst>
           </p:cNvPr>
@@ -9708,7 +9708,7 @@
           <p:cNvPr id="8" name="">
             <a:extLst xmlns:a="http://schemas.openxmlformats.org/drawingml/2006/main">
               <a:ext uri="{FF2B5EF4-FFF2-40B4-BE49-F238E27FC236}">
-                <a16:creationId xmlns:a16="http://schemas.microsoft.com/office/drawing/2014/main" id="{74B11FDB-EDF5-433C-8C14-7FDBCD864172}"/>
+                <a16:creationId xmlns:a16="http://schemas.microsoft.com/office/drawing/2014/main" id="{9512D71B-517A-4440-88BA-2AD86EBA96DE}"/>
               </a:ext>
             </a:extLst>
           </p:cNvPr>
@@ -9741,7 +9741,7 @@
           <p:cNvPr id="9" name="">
             <a:extLst xmlns:a="http://schemas.openxmlformats.org/drawingml/2006/main">
               <a:ext uri="{FF2B5EF4-FFF2-40B4-BE49-F238E27FC236}">
-                <a16:creationId xmlns:a16="http://schemas.microsoft.com/office/drawing/2014/main" id="{17F78B48-2CA8-4D18-BBD0-0ACFEFCA1BAB}"/>
+                <a16:creationId xmlns:a16="http://schemas.microsoft.com/office/drawing/2014/main" id="{4C0D8C5C-3AC5-4522-8FF9-721F10572F45}"/>
               </a:ext>
             </a:extLst>
           </p:cNvPr>
@@ -9774,7 +9774,7 @@
           <p:cNvPr id="10" name="">
             <a:extLst xmlns:a="http://schemas.openxmlformats.org/drawingml/2006/main">
               <a:ext uri="{FF2B5EF4-FFF2-40B4-BE49-F238E27FC236}">
-                <a16:creationId xmlns:a16="http://schemas.microsoft.com/office/drawing/2014/main" id="{B7606BC4-55B9-4F97-BE04-B8402D339084}"/>
+                <a16:creationId xmlns:a16="http://schemas.microsoft.com/office/drawing/2014/main" id="{A3FB9111-5B94-4EDE-BF15-BE9B894D26F9}"/>
               </a:ext>
             </a:extLst>
           </p:cNvPr>
@@ -9825,7 +9825,7 @@
           <p:cNvPr id="11" name="">
             <a:extLst xmlns:a="http://schemas.openxmlformats.org/drawingml/2006/main">
               <a:ext uri="{FF2B5EF4-FFF2-40B4-BE49-F238E27FC236}">
-                <a16:creationId xmlns:a16="http://schemas.microsoft.com/office/drawing/2014/main" id="{CF2DAEF7-5FF0-42C9-94A9-A9473D181F3B}"/>
+                <a16:creationId xmlns:a16="http://schemas.microsoft.com/office/drawing/2014/main" id="{FC6A1E8B-AD5F-477F-98DA-D075F8BBC4C5}"/>
               </a:ext>
             </a:extLst>
           </p:cNvPr>
@@ -9876,7 +9876,7 @@
           <p:cNvPr id="12" name="">
             <a:extLst xmlns:a="http://schemas.openxmlformats.org/drawingml/2006/main">
               <a:ext uri="{FF2B5EF4-FFF2-40B4-BE49-F238E27FC236}">
-                <a16:creationId xmlns:a16="http://schemas.microsoft.com/office/drawing/2014/main" id="{AED65E41-6B65-4953-A791-AFBF4DFA8CCE}"/>
+                <a16:creationId xmlns:a16="http://schemas.microsoft.com/office/drawing/2014/main" id="{901B6089-98A6-4FD7-8AC6-3D56860B6E4C}"/>
               </a:ext>
             </a:extLst>
           </p:cNvPr>
@@ -9909,7 +9909,7 @@
           <p:cNvPr id="13" name="">
             <a:extLst xmlns:a="http://schemas.openxmlformats.org/drawingml/2006/main">
               <a:ext uri="{FF2B5EF4-FFF2-40B4-BE49-F238E27FC236}">
-                <a16:creationId xmlns:a16="http://schemas.microsoft.com/office/drawing/2014/main" id="{EB97B9DC-0D89-46DD-AF37-BD73B518FD59}"/>
+                <a16:creationId xmlns:a16="http://schemas.microsoft.com/office/drawing/2014/main" id="{B2D228C3-F5ED-40DE-8D9C-1ED7B3447AA2}"/>
               </a:ext>
             </a:extLst>
           </p:cNvPr>
@@ -9942,7 +9942,7 @@
           <p:cNvPr id="14" name="">
             <a:extLst xmlns:a="http://schemas.openxmlformats.org/drawingml/2006/main">
               <a:ext uri="{FF2B5EF4-FFF2-40B4-BE49-F238E27FC236}">
-                <a16:creationId xmlns:a16="http://schemas.microsoft.com/office/drawing/2014/main" id="{9FF1B27A-9AFB-44D8-B4C2-22CE10845A6C}"/>
+                <a16:creationId xmlns:a16="http://schemas.microsoft.com/office/drawing/2014/main" id="{2C7030B1-33DD-44C0-B6D6-DD2C8A3EC72F}"/>
               </a:ext>
             </a:extLst>
           </p:cNvPr>
@@ -9993,7 +9993,7 @@
           <p:cNvPr id="15" name="">
             <a:extLst xmlns:a="http://schemas.openxmlformats.org/drawingml/2006/main">
               <a:ext uri="{FF2B5EF4-FFF2-40B4-BE49-F238E27FC236}">
-                <a16:creationId xmlns:a16="http://schemas.microsoft.com/office/drawing/2014/main" id="{F1649DE6-3E0B-47BB-B187-8756780ACC1E}"/>
+                <a16:creationId xmlns:a16="http://schemas.microsoft.com/office/drawing/2014/main" id="{0D96F31E-F4DD-4078-A6D8-CE4F252AC31D}"/>
               </a:ext>
             </a:extLst>
           </p:cNvPr>
@@ -10044,7 +10044,7 @@
           <p:cNvPr id="16" name="">
             <a:extLst xmlns:a="http://schemas.openxmlformats.org/drawingml/2006/main">
               <a:ext uri="{FF2B5EF4-FFF2-40B4-BE49-F238E27FC236}">
-                <a16:creationId xmlns:a16="http://schemas.microsoft.com/office/drawing/2014/main" id="{86F864C3-E284-4387-9F69-DA0930A9D57B}"/>
+                <a16:creationId xmlns:a16="http://schemas.microsoft.com/office/drawing/2014/main" id="{A2FEBD98-0E74-4BD5-A044-8D966567EF85}"/>
               </a:ext>
             </a:extLst>
           </p:cNvPr>
@@ -10077,7 +10077,7 @@
           <p:cNvPr id="17" name="">
             <a:extLst xmlns:a="http://schemas.openxmlformats.org/drawingml/2006/main">
               <a:ext uri="{FF2B5EF4-FFF2-40B4-BE49-F238E27FC236}">
-                <a16:creationId xmlns:a16="http://schemas.microsoft.com/office/drawing/2014/main" id="{9BDDE790-0148-4898-88CF-B5FD1207807E}"/>
+                <a16:creationId xmlns:a16="http://schemas.microsoft.com/office/drawing/2014/main" id="{7D7E2CEA-4BAE-490B-B340-B101DEE8D19B}"/>
               </a:ext>
             </a:extLst>
           </p:cNvPr>
@@ -10110,7 +10110,7 @@
           <p:cNvPr id="18" name="">
             <a:extLst xmlns:a="http://schemas.openxmlformats.org/drawingml/2006/main">
               <a:ext uri="{FF2B5EF4-FFF2-40B4-BE49-F238E27FC236}">
-                <a16:creationId xmlns:a16="http://schemas.microsoft.com/office/drawing/2014/main" id="{99608F69-D998-430D-AA43-7B1107E8DFB3}"/>
+                <a16:creationId xmlns:a16="http://schemas.microsoft.com/office/drawing/2014/main" id="{F57AD614-AE98-4709-8D9B-CC69E2553D1D}"/>
               </a:ext>
             </a:extLst>
           </p:cNvPr>
@@ -10161,7 +10161,7 @@
           <p:cNvPr id="19" name="">
             <a:extLst xmlns:a="http://schemas.openxmlformats.org/drawingml/2006/main">
               <a:ext uri="{FF2B5EF4-FFF2-40B4-BE49-F238E27FC236}">
-                <a16:creationId xmlns:a16="http://schemas.microsoft.com/office/drawing/2014/main" id="{1B0C5DFB-6D33-4B22-9667-C9EC1713CD4D}"/>
+                <a16:creationId xmlns:a16="http://schemas.microsoft.com/office/drawing/2014/main" id="{1A359FB1-2307-4A04-909B-66CBFDDB4C05}"/>
               </a:ext>
             </a:extLst>
           </p:cNvPr>
@@ -10212,7 +10212,7 @@
           <p:cNvPr id="20" name="">
             <a:extLst xmlns:a="http://schemas.openxmlformats.org/drawingml/2006/main">
               <a:ext uri="{FF2B5EF4-FFF2-40B4-BE49-F238E27FC236}">
-                <a16:creationId xmlns:a16="http://schemas.microsoft.com/office/drawing/2014/main" id="{4856969F-30EA-4B57-84FC-678F2D506008}"/>
+                <a16:creationId xmlns:a16="http://schemas.microsoft.com/office/drawing/2014/main" id="{5EA5E2CC-BB30-496A-A5AD-82A17FB6FD09}"/>
               </a:ext>
             </a:extLst>
           </p:cNvPr>
@@ -10245,7 +10245,7 @@
           <p:cNvPr id="21" name="">
             <a:extLst xmlns:a="http://schemas.openxmlformats.org/drawingml/2006/main">
               <a:ext uri="{FF2B5EF4-FFF2-40B4-BE49-F238E27FC236}">
-                <a16:creationId xmlns:a16="http://schemas.microsoft.com/office/drawing/2014/main" id="{37A1AA7E-BB41-43C7-81C1-D5C55F02839E}"/>
+                <a16:creationId xmlns:a16="http://schemas.microsoft.com/office/drawing/2014/main" id="{02794E2B-65E9-4593-8E6C-ECDAA4BCF1AD}"/>
               </a:ext>
             </a:extLst>
           </p:cNvPr>
@@ -10278,7 +10278,7 @@
           <p:cNvPr id="22" name="">
             <a:extLst xmlns:a="http://schemas.openxmlformats.org/drawingml/2006/main">
               <a:ext uri="{FF2B5EF4-FFF2-40B4-BE49-F238E27FC236}">
-                <a16:creationId xmlns:a16="http://schemas.microsoft.com/office/drawing/2014/main" id="{54EEA548-FDB2-4B62-93D1-C99DD87E5838}"/>
+                <a16:creationId xmlns:a16="http://schemas.microsoft.com/office/drawing/2014/main" id="{24BA5F77-AF63-48B5-AA01-D5616B09AD24}"/>
               </a:ext>
             </a:extLst>
           </p:cNvPr>
@@ -10329,7 +10329,7 @@
           <p:cNvPr id="23" name="">
             <a:extLst xmlns:a="http://schemas.openxmlformats.org/drawingml/2006/main">
               <a:ext uri="{FF2B5EF4-FFF2-40B4-BE49-F238E27FC236}">
-                <a16:creationId xmlns:a16="http://schemas.microsoft.com/office/drawing/2014/main" id="{B9E258B4-6C5B-47BF-8D64-0FB992A23C8B}"/>
+                <a16:creationId xmlns:a16="http://schemas.microsoft.com/office/drawing/2014/main" id="{70627762-020C-4866-A09C-CF8CB84CC67B}"/>
               </a:ext>
             </a:extLst>
           </p:cNvPr>
@@ -10380,7 +10380,7 @@
           <p:cNvPr id="24" name="">
             <a:extLst xmlns:a="http://schemas.openxmlformats.org/drawingml/2006/main">
               <a:ext uri="{FF2B5EF4-FFF2-40B4-BE49-F238E27FC236}">
-                <a16:creationId xmlns:a16="http://schemas.microsoft.com/office/drawing/2014/main" id="{235587DF-60EF-48E5-95A7-F44882895873}"/>
+                <a16:creationId xmlns:a16="http://schemas.microsoft.com/office/drawing/2014/main" id="{EF693C70-A7E9-4260-9862-F148FF5A18FD}"/>
               </a:ext>
             </a:extLst>
           </p:cNvPr>
@@ -10413,7 +10413,7 @@
           <p:cNvPr id="25" name="">
             <a:extLst xmlns:a="http://schemas.openxmlformats.org/drawingml/2006/main">
               <a:ext uri="{FF2B5EF4-FFF2-40B4-BE49-F238E27FC236}">
-                <a16:creationId xmlns:a16="http://schemas.microsoft.com/office/drawing/2014/main" id="{A49E3ED9-EA30-4162-8374-06698CBEC84D}"/>
+                <a16:creationId xmlns:a16="http://schemas.microsoft.com/office/drawing/2014/main" id="{C2DA3AC6-1E80-4833-AEAE-5721A0F5E3A5}"/>
               </a:ext>
             </a:extLst>
           </p:cNvPr>
@@ -10446,7 +10446,7 @@
           <p:cNvPr id="26" name="">
             <a:extLst xmlns:a="http://schemas.openxmlformats.org/drawingml/2006/main">
               <a:ext uri="{FF2B5EF4-FFF2-40B4-BE49-F238E27FC236}">
-                <a16:creationId xmlns:a16="http://schemas.microsoft.com/office/drawing/2014/main" id="{A2E5AE06-B7CD-4812-B353-5DB5BD687311}"/>
+                <a16:creationId xmlns:a16="http://schemas.microsoft.com/office/drawing/2014/main" id="{7882C06B-3BC6-4F96-A380-3BEA8014BC3D}"/>
               </a:ext>
             </a:extLst>
           </p:cNvPr>
@@ -10497,7 +10497,7 @@
           <p:cNvPr id="27" name="">
             <a:extLst xmlns:a="http://schemas.openxmlformats.org/drawingml/2006/main">
               <a:ext uri="{FF2B5EF4-FFF2-40B4-BE49-F238E27FC236}">
-                <a16:creationId xmlns:a16="http://schemas.microsoft.com/office/drawing/2014/main" id="{FA944C3E-BDF7-4CA6-9178-E1827CBB34BD}"/>
+                <a16:creationId xmlns:a16="http://schemas.microsoft.com/office/drawing/2014/main" id="{E22AFB0E-8E3F-4173-AA35-A1B82596F33D}"/>
               </a:ext>
             </a:extLst>
           </p:cNvPr>
@@ -10548,7 +10548,7 @@
           <p:cNvPr id="28" name="">
             <a:extLst xmlns:a="http://schemas.openxmlformats.org/drawingml/2006/main">
               <a:ext uri="{FF2B5EF4-FFF2-40B4-BE49-F238E27FC236}">
-                <a16:creationId xmlns:a16="http://schemas.microsoft.com/office/drawing/2014/main" id="{CAD88CEC-B7E4-4F85-9A73-BF067405F171}"/>
+                <a16:creationId xmlns:a16="http://schemas.microsoft.com/office/drawing/2014/main" id="{D3126999-00E5-4043-B8D9-5EAD3980FA58}"/>
               </a:ext>
             </a:extLst>
           </p:cNvPr>
@@ -10599,7 +10599,7 @@
           <p:cNvPr id="29" name="">
             <a:extLst xmlns:a="http://schemas.openxmlformats.org/drawingml/2006/main">
               <a:ext uri="{FF2B5EF4-FFF2-40B4-BE49-F238E27FC236}">
-                <a16:creationId xmlns:a16="http://schemas.microsoft.com/office/drawing/2014/main" id="{F359EC9D-2329-4331-8539-E57AD1BDCABE}"/>
+                <a16:creationId xmlns:a16="http://schemas.microsoft.com/office/drawing/2014/main" id="{5580125C-C980-454D-9D98-AE9FC7AFC70E}"/>
               </a:ext>
             </a:extLst>
           </p:cNvPr>
@@ -10648,7 +10648,7 @@
     </p:spTree>
     <p:extLst>
       <p:ext uri="{BB962C8B-B14F-4D97-AF65-F5344CB8AC3E}">
-        <p14:creationId xmlns:p14="http://schemas.microsoft.com/office/powerpoint/2010/main" val="246501900"/>
+        <p14:creationId xmlns:p14="http://schemas.microsoft.com/office/powerpoint/2010/main" val="340009906"/>
       </p:ext>
     </p:extLst>
   </p:cSld>
@@ -10672,7 +10672,7 @@
           <p:cNvPr id="1" name="">
             <a:extLst xmlns:a="http://schemas.openxmlformats.org/drawingml/2006/main">
               <a:ext uri="{FF2B5EF4-FFF2-40B4-BE49-F238E27FC236}">
-                <a16:creationId xmlns:a16="http://schemas.microsoft.com/office/drawing/2014/main" id="{4AF70CFB-89BE-4EC5-9DF2-94D044F4A600}"/>
+                <a16:creationId xmlns:a16="http://schemas.microsoft.com/office/drawing/2014/main" id="{CF12BA3A-F61B-417C-8DBF-FD63978283BC}"/>
               </a:ext>
             </a:extLst>
           </p:cNvPr>
@@ -10705,7 +10705,7 @@
           <p:cNvPr id="2" name="">
             <a:extLst xmlns:a="http://schemas.openxmlformats.org/drawingml/2006/main">
               <a:ext uri="{FF2B5EF4-FFF2-40B4-BE49-F238E27FC236}">
-                <a16:creationId xmlns:a16="http://schemas.microsoft.com/office/drawing/2014/main" id="{C7185B00-0CDC-43D6-9BAB-2CE6CD849F42}"/>
+                <a16:creationId xmlns:a16="http://schemas.microsoft.com/office/drawing/2014/main" id="{3989EABD-131B-48C4-9DC4-694AD952764C}"/>
               </a:ext>
             </a:extLst>
           </p:cNvPr>
@@ -10742,7 +10742,7 @@
           <p:nvPr/>
         </p:nvPicPr>
         <p:blipFill>
-          <a:blip xmlns:r="http://schemas.openxmlformats.org/officeDocument/2006/relationships" xmlns:a="http://schemas.openxmlformats.org/drawingml/2006/main" r:embed="R85c1a5c1a1754a0a"/>
+          <a:blip xmlns:r="http://schemas.openxmlformats.org/officeDocument/2006/relationships" xmlns:a="http://schemas.openxmlformats.org/drawingml/2006/main" r:embed="R1168033db0ab4f59"/>
           <a:stretch xmlns:a="http://schemas.openxmlformats.org/drawingml/2006/main"/>
         </p:blipFill>
         <p:spPr>
@@ -10760,7 +10760,7 @@
           <p:cNvPr id="4" name="">
             <a:extLst xmlns:a="http://schemas.openxmlformats.org/drawingml/2006/main">
               <a:ext uri="{FF2B5EF4-FFF2-40B4-BE49-F238E27FC236}">
-                <a16:creationId xmlns:a16="http://schemas.microsoft.com/office/drawing/2014/main" id="{79192076-D2ED-4906-BBC4-10D9E3012B75}"/>
+                <a16:creationId xmlns:a16="http://schemas.microsoft.com/office/drawing/2014/main" id="{4C6B0C4A-2DFB-40BF-B6B0-387683D4BF80}"/>
               </a:ext>
             </a:extLst>
           </p:cNvPr>
@@ -10811,7 +10811,7 @@
           <p:cNvPr id="5" name="">
             <a:extLst xmlns:a="http://schemas.openxmlformats.org/drawingml/2006/main">
               <a:ext uri="{FF2B5EF4-FFF2-40B4-BE49-F238E27FC236}">
-                <a16:creationId xmlns:a16="http://schemas.microsoft.com/office/drawing/2014/main" id="{0575AFF9-B6DB-40FE-A885-66BC33FB8E48}"/>
+                <a16:creationId xmlns:a16="http://schemas.microsoft.com/office/drawing/2014/main" id="{313DA7B2-09D1-4427-A6E7-B66696621ED4}"/>
               </a:ext>
             </a:extLst>
           </p:cNvPr>
@@ -10862,7 +10862,7 @@
           <p:cNvPr id="6" name="">
             <a:extLst xmlns:a="http://schemas.openxmlformats.org/drawingml/2006/main">
               <a:ext uri="{FF2B5EF4-FFF2-40B4-BE49-F238E27FC236}">
-                <a16:creationId xmlns:a16="http://schemas.microsoft.com/office/drawing/2014/main" id="{D5BD4BCF-8BC9-4FA7-9775-83A518AB87C2}"/>
+                <a16:creationId xmlns:a16="http://schemas.microsoft.com/office/drawing/2014/main" id="{189E8764-92D4-4C70-979B-5952C2656447}"/>
               </a:ext>
             </a:extLst>
           </p:cNvPr>
@@ -10913,7 +10913,7 @@
           <p:cNvPr id="7" name="">
             <a:extLst xmlns:a="http://schemas.openxmlformats.org/drawingml/2006/main">
               <a:ext uri="{FF2B5EF4-FFF2-40B4-BE49-F238E27FC236}">
-                <a16:creationId xmlns:a16="http://schemas.microsoft.com/office/drawing/2014/main" id="{89F55AFD-C62F-413C-9D70-80A366E16636}"/>
+                <a16:creationId xmlns:a16="http://schemas.microsoft.com/office/drawing/2014/main" id="{C309F023-30CF-4F29-AAA3-32DE95575819}"/>
               </a:ext>
             </a:extLst>
           </p:cNvPr>
@@ -10946,7 +10946,7 @@
           <p:cNvPr id="8" name="">
             <a:extLst xmlns:a="http://schemas.openxmlformats.org/drawingml/2006/main">
               <a:ext uri="{FF2B5EF4-FFF2-40B4-BE49-F238E27FC236}">
-                <a16:creationId xmlns:a16="http://schemas.microsoft.com/office/drawing/2014/main" id="{9E1B1BD7-AED7-4206-A739-DC82F134C3F5}"/>
+                <a16:creationId xmlns:a16="http://schemas.microsoft.com/office/drawing/2014/main" id="{FF670EB0-8CE1-4CE8-A1B1-88356015B958}"/>
               </a:ext>
             </a:extLst>
           </p:cNvPr>
@@ -10979,7 +10979,7 @@
           <p:cNvPr id="9" name="">
             <a:extLst xmlns:a="http://schemas.openxmlformats.org/drawingml/2006/main">
               <a:ext uri="{FF2B5EF4-FFF2-40B4-BE49-F238E27FC236}">
-                <a16:creationId xmlns:a16="http://schemas.microsoft.com/office/drawing/2014/main" id="{EAE482F9-CCCC-46AA-A7AE-5B2C39DFC49E}"/>
+                <a16:creationId xmlns:a16="http://schemas.microsoft.com/office/drawing/2014/main" id="{9F0742E8-924D-4BB9-9F3A-74495DB78007}"/>
               </a:ext>
             </a:extLst>
           </p:cNvPr>
@@ -11030,7 +11030,7 @@
           <p:cNvPr id="10" name="">
             <a:extLst xmlns:a="http://schemas.openxmlformats.org/drawingml/2006/main">
               <a:ext uri="{FF2B5EF4-FFF2-40B4-BE49-F238E27FC236}">
-                <a16:creationId xmlns:a16="http://schemas.microsoft.com/office/drawing/2014/main" id="{309D37EA-BAAF-41E8-8AF5-2D2A2A8E6F58}"/>
+                <a16:creationId xmlns:a16="http://schemas.microsoft.com/office/drawing/2014/main" id="{20C730E6-8AA8-4756-8550-83CBF970D4AB}"/>
               </a:ext>
             </a:extLst>
           </p:cNvPr>
@@ -11081,7 +11081,7 @@
           <p:cNvPr id="11" name="">
             <a:extLst xmlns:a="http://schemas.openxmlformats.org/drawingml/2006/main">
               <a:ext uri="{FF2B5EF4-FFF2-40B4-BE49-F238E27FC236}">
-                <a16:creationId xmlns:a16="http://schemas.microsoft.com/office/drawing/2014/main" id="{1FBAE6C3-4135-40A2-8F6F-6E7F30573B22}"/>
+                <a16:creationId xmlns:a16="http://schemas.microsoft.com/office/drawing/2014/main" id="{8BA07855-6FB9-47A8-857C-599BC27C119D}"/>
               </a:ext>
             </a:extLst>
           </p:cNvPr>
@@ -11114,7 +11114,7 @@
           <p:cNvPr id="12" name="">
             <a:extLst xmlns:a="http://schemas.openxmlformats.org/drawingml/2006/main">
               <a:ext uri="{FF2B5EF4-FFF2-40B4-BE49-F238E27FC236}">
-                <a16:creationId xmlns:a16="http://schemas.microsoft.com/office/drawing/2014/main" id="{0C31786B-66D3-4AED-B817-3229B0A80090}"/>
+                <a16:creationId xmlns:a16="http://schemas.microsoft.com/office/drawing/2014/main" id="{1767A3EB-24E2-4E55-991E-85A11FC4E347}"/>
               </a:ext>
             </a:extLst>
           </p:cNvPr>
@@ -11147,7 +11147,7 @@
           <p:cNvPr id="13" name="">
             <a:extLst xmlns:a="http://schemas.openxmlformats.org/drawingml/2006/main">
               <a:ext uri="{FF2B5EF4-FFF2-40B4-BE49-F238E27FC236}">
-                <a16:creationId xmlns:a16="http://schemas.microsoft.com/office/drawing/2014/main" id="{BFF79351-1DE9-4E12-9683-C9F6B174FE6A}"/>
+                <a16:creationId xmlns:a16="http://schemas.microsoft.com/office/drawing/2014/main" id="{66C44F50-4A61-423B-9DE7-9DFEA6767914}"/>
               </a:ext>
             </a:extLst>
           </p:cNvPr>
@@ -11198,7 +11198,7 @@
           <p:cNvPr id="14" name="">
             <a:extLst xmlns:a="http://schemas.openxmlformats.org/drawingml/2006/main">
               <a:ext uri="{FF2B5EF4-FFF2-40B4-BE49-F238E27FC236}">
-                <a16:creationId xmlns:a16="http://schemas.microsoft.com/office/drawing/2014/main" id="{87FC0735-7B23-4153-BAAE-129121C9F5B0}"/>
+                <a16:creationId xmlns:a16="http://schemas.microsoft.com/office/drawing/2014/main" id="{C662F4CD-BF3C-4DFA-B4A6-9F24A73EEBD9}"/>
               </a:ext>
             </a:extLst>
           </p:cNvPr>
@@ -11249,7 +11249,7 @@
           <p:cNvPr id="15" name="">
             <a:extLst xmlns:a="http://schemas.openxmlformats.org/drawingml/2006/main">
               <a:ext uri="{FF2B5EF4-FFF2-40B4-BE49-F238E27FC236}">
-                <a16:creationId xmlns:a16="http://schemas.microsoft.com/office/drawing/2014/main" id="{7693937E-5629-4710-BD4E-B7752C978A0B}"/>
+                <a16:creationId xmlns:a16="http://schemas.microsoft.com/office/drawing/2014/main" id="{B0BC258D-825A-4EE1-A9E7-E568F76179CF}"/>
               </a:ext>
             </a:extLst>
           </p:cNvPr>
@@ -11282,7 +11282,7 @@
           <p:cNvPr id="16" name="">
             <a:extLst xmlns:a="http://schemas.openxmlformats.org/drawingml/2006/main">
               <a:ext uri="{FF2B5EF4-FFF2-40B4-BE49-F238E27FC236}">
-                <a16:creationId xmlns:a16="http://schemas.microsoft.com/office/drawing/2014/main" id="{46D5A2EE-CAC9-414F-B9C4-DFD4177707F9}"/>
+                <a16:creationId xmlns:a16="http://schemas.microsoft.com/office/drawing/2014/main" id="{9579F368-5922-452A-9F43-1B03D7348714}"/>
               </a:ext>
             </a:extLst>
           </p:cNvPr>
@@ -11315,7 +11315,7 @@
           <p:cNvPr id="17" name="">
             <a:extLst xmlns:a="http://schemas.openxmlformats.org/drawingml/2006/main">
               <a:ext uri="{FF2B5EF4-FFF2-40B4-BE49-F238E27FC236}">
-                <a16:creationId xmlns:a16="http://schemas.microsoft.com/office/drawing/2014/main" id="{0F2941DE-7B3F-46DC-8EB7-7D3372FBC79B}"/>
+                <a16:creationId xmlns:a16="http://schemas.microsoft.com/office/drawing/2014/main" id="{8D7C9AA1-D18A-4842-A9E3-367CE9A6A8FC}"/>
               </a:ext>
             </a:extLst>
           </p:cNvPr>
@@ -11366,7 +11366,7 @@
           <p:cNvPr id="18" name="">
             <a:extLst xmlns:a="http://schemas.openxmlformats.org/drawingml/2006/main">
               <a:ext uri="{FF2B5EF4-FFF2-40B4-BE49-F238E27FC236}">
-                <a16:creationId xmlns:a16="http://schemas.microsoft.com/office/drawing/2014/main" id="{2A803CC5-4144-496B-A22B-3878E466A107}"/>
+                <a16:creationId xmlns:a16="http://schemas.microsoft.com/office/drawing/2014/main" id="{71D4E199-41C3-4AA3-B615-7E250AEA7AA0}"/>
               </a:ext>
             </a:extLst>
           </p:cNvPr>
@@ -11417,7 +11417,7 @@
           <p:cNvPr id="19" name="">
             <a:extLst xmlns:a="http://schemas.openxmlformats.org/drawingml/2006/main">
               <a:ext uri="{FF2B5EF4-FFF2-40B4-BE49-F238E27FC236}">
-                <a16:creationId xmlns:a16="http://schemas.microsoft.com/office/drawing/2014/main" id="{002B469D-3BD0-4EBB-BD73-ED70C8349E33}"/>
+                <a16:creationId xmlns:a16="http://schemas.microsoft.com/office/drawing/2014/main" id="{7B930A9A-B56F-4397-8680-04694D9E4ADB}"/>
               </a:ext>
             </a:extLst>
           </p:cNvPr>
@@ -11468,7 +11468,7 @@
           <p:cNvPr id="20" name="">
             <a:extLst xmlns:a="http://schemas.openxmlformats.org/drawingml/2006/main">
               <a:ext uri="{FF2B5EF4-FFF2-40B4-BE49-F238E27FC236}">
-                <a16:creationId xmlns:a16="http://schemas.microsoft.com/office/drawing/2014/main" id="{FFC2781E-A18C-4172-830B-BE7B9AFDB467}"/>
+                <a16:creationId xmlns:a16="http://schemas.microsoft.com/office/drawing/2014/main" id="{10BFC484-5B04-4706-858A-AD7FEBD093AA}"/>
               </a:ext>
             </a:extLst>
           </p:cNvPr>
@@ -11517,7 +11517,7 @@
     </p:spTree>
     <p:extLst>
       <p:ext uri="{BB962C8B-B14F-4D97-AF65-F5344CB8AC3E}">
-        <p14:creationId xmlns:p14="http://schemas.microsoft.com/office/powerpoint/2010/main" val="180261459"/>
+        <p14:creationId xmlns:p14="http://schemas.microsoft.com/office/powerpoint/2010/main" val="472038161"/>
       </p:ext>
     </p:extLst>
   </p:cSld>
@@ -11541,7 +11541,7 @@
           <p:cNvPr id="1" name="">
             <a:extLst xmlns:a="http://schemas.openxmlformats.org/drawingml/2006/main">
               <a:ext uri="{FF2B5EF4-FFF2-40B4-BE49-F238E27FC236}">
-                <a16:creationId xmlns:a16="http://schemas.microsoft.com/office/drawing/2014/main" id="{9F9B4995-8EFF-4CAE-8968-D1D1F0104EAB}"/>
+                <a16:creationId xmlns:a16="http://schemas.microsoft.com/office/drawing/2014/main" id="{DDE9B8DE-6CFA-4693-91F7-26CDA8DE4C4A}"/>
               </a:ext>
             </a:extLst>
           </p:cNvPr>
@@ -11574,7 +11574,7 @@
           <p:cNvPr id="2" name="">
             <a:extLst xmlns:a="http://schemas.openxmlformats.org/drawingml/2006/main">
               <a:ext uri="{FF2B5EF4-FFF2-40B4-BE49-F238E27FC236}">
-                <a16:creationId xmlns:a16="http://schemas.microsoft.com/office/drawing/2014/main" id="{61C89D43-218D-45A9-A9F1-D5B3E4645C2B}"/>
+                <a16:creationId xmlns:a16="http://schemas.microsoft.com/office/drawing/2014/main" id="{A19200BC-7EC9-4DAD-979E-8311D30E3B9F}"/>
               </a:ext>
             </a:extLst>
           </p:cNvPr>
@@ -11625,7 +11625,7 @@
           <p:cNvPr id="3" name="">
             <a:extLst xmlns:a="http://schemas.openxmlformats.org/drawingml/2006/main">
               <a:ext uri="{FF2B5EF4-FFF2-40B4-BE49-F238E27FC236}">
-                <a16:creationId xmlns:a16="http://schemas.microsoft.com/office/drawing/2014/main" id="{7AAED509-B89C-4E11-A198-F36EA90B102B}"/>
+                <a16:creationId xmlns:a16="http://schemas.microsoft.com/office/drawing/2014/main" id="{5BB4DAB7-68E6-42A2-8B64-2C2A44E6683B}"/>
               </a:ext>
             </a:extLst>
           </p:cNvPr>
@@ -11676,7 +11676,7 @@
           <p:cNvPr id="4" name="">
             <a:extLst xmlns:a="http://schemas.openxmlformats.org/drawingml/2006/main">
               <a:ext uri="{FF2B5EF4-FFF2-40B4-BE49-F238E27FC236}">
-                <a16:creationId xmlns:a16="http://schemas.microsoft.com/office/drawing/2014/main" id="{C4D86E3E-913E-46C6-B6CD-E12EFAB092A9}"/>
+                <a16:creationId xmlns:a16="http://schemas.microsoft.com/office/drawing/2014/main" id="{633FD8C4-D696-4945-8DC6-0E3F7F20D4D5}"/>
               </a:ext>
             </a:extLst>
           </p:cNvPr>
@@ -11713,7 +11713,7 @@
           <p:nvPr/>
         </p:nvPicPr>
         <p:blipFill>
-          <a:blip xmlns:r="http://schemas.openxmlformats.org/officeDocument/2006/relationships" xmlns:a="http://schemas.openxmlformats.org/drawingml/2006/main" r:embed="R19b1ab2cb4aa40e1"/>
+          <a:blip xmlns:r="http://schemas.openxmlformats.org/officeDocument/2006/relationships" xmlns:a="http://schemas.openxmlformats.org/drawingml/2006/main" r:embed="Rab7d5a3b8fa7404c"/>
           <a:stretch xmlns:a="http://schemas.openxmlformats.org/drawingml/2006/main"/>
         </p:blipFill>
         <p:spPr>
@@ -11731,7 +11731,7 @@
           <p:cNvPr id="6" name="">
             <a:extLst xmlns:a="http://schemas.openxmlformats.org/drawingml/2006/main">
               <a:ext uri="{FF2B5EF4-FFF2-40B4-BE49-F238E27FC236}">
-                <a16:creationId xmlns:a16="http://schemas.microsoft.com/office/drawing/2014/main" id="{9ACCB194-BDCF-492B-B660-48192920A49C}"/>
+                <a16:creationId xmlns:a16="http://schemas.microsoft.com/office/drawing/2014/main" id="{763C9AD1-8BF4-4954-9C5B-587490F5FE00}"/>
               </a:ext>
             </a:extLst>
           </p:cNvPr>
@@ -11785,7 +11785,7 @@
           <p:cNvPr id="7" name="">
             <a:extLst xmlns:a="http://schemas.openxmlformats.org/drawingml/2006/main">
               <a:ext uri="{FF2B5EF4-FFF2-40B4-BE49-F238E27FC236}">
-                <a16:creationId xmlns:a16="http://schemas.microsoft.com/office/drawing/2014/main" id="{937DCE3D-2544-47F6-B532-CC5B916EF0BD}"/>
+                <a16:creationId xmlns:a16="http://schemas.microsoft.com/office/drawing/2014/main" id="{A2885075-1CDD-4C06-8499-07892961D100}"/>
               </a:ext>
             </a:extLst>
           </p:cNvPr>
@@ -11822,7 +11822,7 @@
           <p:nvPr/>
         </p:nvPicPr>
         <p:blipFill>
-          <a:blip xmlns:r="http://schemas.openxmlformats.org/officeDocument/2006/relationships" xmlns:a="http://schemas.openxmlformats.org/drawingml/2006/main" r:embed="R42f943d826c145e0"/>
+          <a:blip xmlns:r="http://schemas.openxmlformats.org/officeDocument/2006/relationships" xmlns:a="http://schemas.openxmlformats.org/drawingml/2006/main" r:embed="R73895721f8f04fd4"/>
           <a:stretch xmlns:a="http://schemas.openxmlformats.org/drawingml/2006/main"/>
         </p:blipFill>
         <p:spPr>
@@ -11840,7 +11840,7 @@
           <p:cNvPr id="9" name="">
             <a:extLst xmlns:a="http://schemas.openxmlformats.org/drawingml/2006/main">
               <a:ext uri="{FF2B5EF4-FFF2-40B4-BE49-F238E27FC236}">
-                <a16:creationId xmlns:a16="http://schemas.microsoft.com/office/drawing/2014/main" id="{014F8030-FF64-4931-B882-1E7C7C3D78B5}"/>
+                <a16:creationId xmlns:a16="http://schemas.microsoft.com/office/drawing/2014/main" id="{3EE68493-D5C0-459C-BA08-88E1B711475A}"/>
               </a:ext>
             </a:extLst>
           </p:cNvPr>
@@ -11894,7 +11894,7 @@
           <p:cNvPr id="10" name="">
             <a:extLst xmlns:a="http://schemas.openxmlformats.org/drawingml/2006/main">
               <a:ext uri="{FF2B5EF4-FFF2-40B4-BE49-F238E27FC236}">
-                <a16:creationId xmlns:a16="http://schemas.microsoft.com/office/drawing/2014/main" id="{4684AD23-7F1B-4F36-A4BD-FF0F1653956A}"/>
+                <a16:creationId xmlns:a16="http://schemas.microsoft.com/office/drawing/2014/main" id="{EE6616BD-8B44-49EF-817C-89820231E504}"/>
               </a:ext>
             </a:extLst>
           </p:cNvPr>
@@ -11931,7 +11931,7 @@
           <p:nvPr/>
         </p:nvPicPr>
         <p:blipFill>
-          <a:blip xmlns:r="http://schemas.openxmlformats.org/officeDocument/2006/relationships" xmlns:a="http://schemas.openxmlformats.org/drawingml/2006/main" r:embed="R1d054932e292464a"/>
+          <a:blip xmlns:r="http://schemas.openxmlformats.org/officeDocument/2006/relationships" xmlns:a="http://schemas.openxmlformats.org/drawingml/2006/main" r:embed="Rc69b734812994ef7"/>
           <a:stretch xmlns:a="http://schemas.openxmlformats.org/drawingml/2006/main"/>
         </p:blipFill>
         <p:spPr>
@@ -11949,7 +11949,7 @@
           <p:cNvPr id="12" name="">
             <a:extLst xmlns:a="http://schemas.openxmlformats.org/drawingml/2006/main">
               <a:ext uri="{FF2B5EF4-FFF2-40B4-BE49-F238E27FC236}">
-                <a16:creationId xmlns:a16="http://schemas.microsoft.com/office/drawing/2014/main" id="{433F8582-663B-4CB8-8CEB-11941937C1C4}"/>
+                <a16:creationId xmlns:a16="http://schemas.microsoft.com/office/drawing/2014/main" id="{28D9EDBC-CB9F-498C-9B0C-ED69E20DAFB1}"/>
               </a:ext>
             </a:extLst>
           </p:cNvPr>
@@ -12003,7 +12003,7 @@
           <p:cNvPr id="13" name="">
             <a:extLst xmlns:a="http://schemas.openxmlformats.org/drawingml/2006/main">
               <a:ext uri="{FF2B5EF4-FFF2-40B4-BE49-F238E27FC236}">
-                <a16:creationId xmlns:a16="http://schemas.microsoft.com/office/drawing/2014/main" id="{89001FD7-2B76-4079-885F-EFFE53F5B324}"/>
+                <a16:creationId xmlns:a16="http://schemas.microsoft.com/office/drawing/2014/main" id="{3DD7A25E-F7DC-4F8F-980D-AE0FB2C99294}"/>
               </a:ext>
             </a:extLst>
           </p:cNvPr>
@@ -12036,7 +12036,7 @@
           <p:cNvPr id="14" name="">
             <a:extLst xmlns:a="http://schemas.openxmlformats.org/drawingml/2006/main">
               <a:ext uri="{FF2B5EF4-FFF2-40B4-BE49-F238E27FC236}">
-                <a16:creationId xmlns:a16="http://schemas.microsoft.com/office/drawing/2014/main" id="{8F4BE3CC-A599-470C-A2D2-39406CC6D2E1}"/>
+                <a16:creationId xmlns:a16="http://schemas.microsoft.com/office/drawing/2014/main" id="{77322885-0841-4437-8B50-9A41F69C5CD8}"/>
               </a:ext>
             </a:extLst>
           </p:cNvPr>
@@ -12069,7 +12069,7 @@
           <p:cNvPr id="15" name="">
             <a:extLst xmlns:a="http://schemas.openxmlformats.org/drawingml/2006/main">
               <a:ext uri="{FF2B5EF4-FFF2-40B4-BE49-F238E27FC236}">
-                <a16:creationId xmlns:a16="http://schemas.microsoft.com/office/drawing/2014/main" id="{64D08B0E-FB5F-4B88-AB60-9CBB6069DD20}"/>
+                <a16:creationId xmlns:a16="http://schemas.microsoft.com/office/drawing/2014/main" id="{921A4DC9-26F1-4F73-A48F-DAE7A382E141}"/>
               </a:ext>
             </a:extLst>
           </p:cNvPr>
@@ -12120,7 +12120,7 @@
           <p:cNvPr id="16" name="">
             <a:extLst xmlns:a="http://schemas.openxmlformats.org/drawingml/2006/main">
               <a:ext uri="{FF2B5EF4-FFF2-40B4-BE49-F238E27FC236}">
-                <a16:creationId xmlns:a16="http://schemas.microsoft.com/office/drawing/2014/main" id="{7D07D9C4-E481-4516-96DB-0A371A235607}"/>
+                <a16:creationId xmlns:a16="http://schemas.microsoft.com/office/drawing/2014/main" id="{5D37C9CB-195E-4CD5-80DC-0087ED21C34F}"/>
               </a:ext>
             </a:extLst>
           </p:cNvPr>
@@ -12171,7 +12171,7 @@
           <p:cNvPr id="17" name="">
             <a:extLst xmlns:a="http://schemas.openxmlformats.org/drawingml/2006/main">
               <a:ext uri="{FF2B5EF4-FFF2-40B4-BE49-F238E27FC236}">
-                <a16:creationId xmlns:a16="http://schemas.microsoft.com/office/drawing/2014/main" id="{E29F7878-9BD9-4FA7-9228-2932035216EB}"/>
+                <a16:creationId xmlns:a16="http://schemas.microsoft.com/office/drawing/2014/main" id="{1AE4C86D-A431-493C-AD4A-662DDFF65298}"/>
               </a:ext>
             </a:extLst>
           </p:cNvPr>
@@ -12222,7 +12222,7 @@
           <p:cNvPr id="18" name="">
             <a:extLst xmlns:a="http://schemas.openxmlformats.org/drawingml/2006/main">
               <a:ext uri="{FF2B5EF4-FFF2-40B4-BE49-F238E27FC236}">
-                <a16:creationId xmlns:a16="http://schemas.microsoft.com/office/drawing/2014/main" id="{CA86778A-84D1-4992-9735-8E1F57BDCB9F}"/>
+                <a16:creationId xmlns:a16="http://schemas.microsoft.com/office/drawing/2014/main" id="{1EE1C2F9-3C78-4DDA-851D-5DDC31393DC0}"/>
               </a:ext>
             </a:extLst>
           </p:cNvPr>
@@ -12271,7 +12271,7 @@
     </p:spTree>
     <p:extLst>
       <p:ext uri="{BB962C8B-B14F-4D97-AF65-F5344CB8AC3E}">
-        <p14:creationId xmlns:p14="http://schemas.microsoft.com/office/powerpoint/2010/main" val="160018142"/>
+        <p14:creationId xmlns:p14="http://schemas.microsoft.com/office/powerpoint/2010/main" val="304864011"/>
       </p:ext>
     </p:extLst>
   </p:cSld>
@@ -12295,7 +12295,7 @@
           <p:cNvPr id="1" name="">
             <a:extLst xmlns:a="http://schemas.openxmlformats.org/drawingml/2006/main">
               <a:ext uri="{FF2B5EF4-FFF2-40B4-BE49-F238E27FC236}">
-                <a16:creationId xmlns:a16="http://schemas.microsoft.com/office/drawing/2014/main" id="{665270D2-8EAD-42DE-9C08-2719FC42C4FB}"/>
+                <a16:creationId xmlns:a16="http://schemas.microsoft.com/office/drawing/2014/main" id="{976B7B42-893B-4478-A9A3-2B06F13BF51D}"/>
               </a:ext>
             </a:extLst>
           </p:cNvPr>
@@ -12328,7 +12328,7 @@
           <p:cNvPr id="2" name="">
             <a:extLst xmlns:a="http://schemas.openxmlformats.org/drawingml/2006/main">
               <a:ext uri="{FF2B5EF4-FFF2-40B4-BE49-F238E27FC236}">
-                <a16:creationId xmlns:a16="http://schemas.microsoft.com/office/drawing/2014/main" id="{ED2A82C2-4468-4808-BC66-3032C5EB0D20}"/>
+                <a16:creationId xmlns:a16="http://schemas.microsoft.com/office/drawing/2014/main" id="{26238729-DA73-499C-8812-290D985716C0}"/>
               </a:ext>
             </a:extLst>
           </p:cNvPr>
@@ -12379,7 +12379,7 @@
           <p:cNvPr id="3" name="">
             <a:extLst xmlns:a="http://schemas.openxmlformats.org/drawingml/2006/main">
               <a:ext uri="{FF2B5EF4-FFF2-40B4-BE49-F238E27FC236}">
-                <a16:creationId xmlns:a16="http://schemas.microsoft.com/office/drawing/2014/main" id="{AB79B542-26B7-43A4-98CE-B0AE57579FC7}"/>
+                <a16:creationId xmlns:a16="http://schemas.microsoft.com/office/drawing/2014/main" id="{0BFC96CD-D5D3-45F7-97A7-CA9680EB270C}"/>
               </a:ext>
             </a:extLst>
           </p:cNvPr>
@@ -12430,7 +12430,7 @@
           <p:cNvPr id="4" name="">
             <a:extLst xmlns:a="http://schemas.openxmlformats.org/drawingml/2006/main">
               <a:ext uri="{FF2B5EF4-FFF2-40B4-BE49-F238E27FC236}">
-                <a16:creationId xmlns:a16="http://schemas.microsoft.com/office/drawing/2014/main" id="{0F2B0570-C4FD-4591-8E1E-DEDCBBCB1DD1}"/>
+                <a16:creationId xmlns:a16="http://schemas.microsoft.com/office/drawing/2014/main" id="{26D9FE4F-F8AC-4749-AE3E-A67CC0D2D578}"/>
               </a:ext>
             </a:extLst>
           </p:cNvPr>
@@ -12481,7 +12481,7 @@
           <p:cNvPr id="5" name="">
             <a:extLst xmlns:a="http://schemas.openxmlformats.org/drawingml/2006/main">
               <a:ext uri="{FF2B5EF4-FFF2-40B4-BE49-F238E27FC236}">
-                <a16:creationId xmlns:a16="http://schemas.microsoft.com/office/drawing/2014/main" id="{DE49C676-8216-4FB4-8BB3-4312B79E95CE}"/>
+                <a16:creationId xmlns:a16="http://schemas.microsoft.com/office/drawing/2014/main" id="{356EA5F2-5133-4A52-B854-B7124FF74889}"/>
               </a:ext>
             </a:extLst>
           </p:cNvPr>
@@ -12514,7 +12514,7 @@
           <p:cNvPr id="6" name="">
             <a:extLst xmlns:a="http://schemas.openxmlformats.org/drawingml/2006/main">
               <a:ext uri="{FF2B5EF4-FFF2-40B4-BE49-F238E27FC236}">
-                <a16:creationId xmlns:a16="http://schemas.microsoft.com/office/drawing/2014/main" id="{579CF70A-211D-431B-92AF-434B897AA46C}"/>
+                <a16:creationId xmlns:a16="http://schemas.microsoft.com/office/drawing/2014/main" id="{C7C9C6D9-1788-49C5-AD36-45A8E776C9D9}"/>
               </a:ext>
             </a:extLst>
           </p:cNvPr>
@@ -12547,7 +12547,7 @@
           <p:cNvPr id="7" name="">
             <a:extLst xmlns:a="http://schemas.openxmlformats.org/drawingml/2006/main">
               <a:ext uri="{FF2B5EF4-FFF2-40B4-BE49-F238E27FC236}">
-                <a16:creationId xmlns:a16="http://schemas.microsoft.com/office/drawing/2014/main" id="{A6E9765A-34C6-4B08-ABC1-6A1237AEEFDF}"/>
+                <a16:creationId xmlns:a16="http://schemas.microsoft.com/office/drawing/2014/main" id="{CD014308-5418-4679-8F01-D75121CCA48A}"/>
               </a:ext>
             </a:extLst>
           </p:cNvPr>
@@ -12598,7 +12598,7 @@
           <p:cNvPr id="8" name="">
             <a:extLst xmlns:a="http://schemas.openxmlformats.org/drawingml/2006/main">
               <a:ext uri="{FF2B5EF4-FFF2-40B4-BE49-F238E27FC236}">
-                <a16:creationId xmlns:a16="http://schemas.microsoft.com/office/drawing/2014/main" id="{0CB3DA27-2AC7-4706-9E68-E8D7D4D9FAF0}"/>
+                <a16:creationId xmlns:a16="http://schemas.microsoft.com/office/drawing/2014/main" id="{26EEF1CA-67F7-4AB1-9869-E9ADE338DAC6}"/>
               </a:ext>
             </a:extLst>
           </p:cNvPr>
@@ -12649,7 +12649,7 @@
           <p:cNvPr id="9" name="">
             <a:extLst xmlns:a="http://schemas.openxmlformats.org/drawingml/2006/main">
               <a:ext uri="{FF2B5EF4-FFF2-40B4-BE49-F238E27FC236}">
-                <a16:creationId xmlns:a16="http://schemas.microsoft.com/office/drawing/2014/main" id="{AFDD7751-B6B5-4CAF-80F4-88E5005C57DF}"/>
+                <a16:creationId xmlns:a16="http://schemas.microsoft.com/office/drawing/2014/main" id="{0B4CACE4-F4A5-4B16-8A2B-C00F509E5DEA}"/>
               </a:ext>
             </a:extLst>
           </p:cNvPr>
@@ -12682,7 +12682,7 @@
           <p:cNvPr id="10" name="">
             <a:extLst xmlns:a="http://schemas.openxmlformats.org/drawingml/2006/main">
               <a:ext uri="{FF2B5EF4-FFF2-40B4-BE49-F238E27FC236}">
-                <a16:creationId xmlns:a16="http://schemas.microsoft.com/office/drawing/2014/main" id="{32899306-509A-42D4-B3A9-69240F6B8D11}"/>
+                <a16:creationId xmlns:a16="http://schemas.microsoft.com/office/drawing/2014/main" id="{9FD6A189-F935-4C1E-A396-98E3922D9282}"/>
               </a:ext>
             </a:extLst>
           </p:cNvPr>
@@ -12715,7 +12715,7 @@
           <p:cNvPr id="11" name="">
             <a:extLst xmlns:a="http://schemas.openxmlformats.org/drawingml/2006/main">
               <a:ext uri="{FF2B5EF4-FFF2-40B4-BE49-F238E27FC236}">
-                <a16:creationId xmlns:a16="http://schemas.microsoft.com/office/drawing/2014/main" id="{BA059FAB-4786-4D02-BCD7-8447654F3625}"/>
+                <a16:creationId xmlns:a16="http://schemas.microsoft.com/office/drawing/2014/main" id="{2504C3F0-9F36-4B4B-8F18-E14B87DED964}"/>
               </a:ext>
             </a:extLst>
           </p:cNvPr>
@@ -12766,7 +12766,7 @@
           <p:cNvPr id="12" name="">
             <a:extLst xmlns:a="http://schemas.openxmlformats.org/drawingml/2006/main">
               <a:ext uri="{FF2B5EF4-FFF2-40B4-BE49-F238E27FC236}">
-                <a16:creationId xmlns:a16="http://schemas.microsoft.com/office/drawing/2014/main" id="{F913F497-D0D7-41ED-AE11-802F01456B1E}"/>
+                <a16:creationId xmlns:a16="http://schemas.microsoft.com/office/drawing/2014/main" id="{DE43D0F8-B1A4-4815-9FDD-A0B58CF04C30}"/>
               </a:ext>
             </a:extLst>
           </p:cNvPr>
@@ -12817,7 +12817,7 @@
           <p:cNvPr id="13" name="">
             <a:extLst xmlns:a="http://schemas.openxmlformats.org/drawingml/2006/main">
               <a:ext uri="{FF2B5EF4-FFF2-40B4-BE49-F238E27FC236}">
-                <a16:creationId xmlns:a16="http://schemas.microsoft.com/office/drawing/2014/main" id="{BD9BCB69-3C97-454D-BFA0-B8D44D5A1C01}"/>
+                <a16:creationId xmlns:a16="http://schemas.microsoft.com/office/drawing/2014/main" id="{6E4EA5DC-D6A6-447E-95E1-FD30AD082F9A}"/>
               </a:ext>
             </a:extLst>
           </p:cNvPr>
@@ -12850,7 +12850,7 @@
           <p:cNvPr id="14" name="">
             <a:extLst xmlns:a="http://schemas.openxmlformats.org/drawingml/2006/main">
               <a:ext uri="{FF2B5EF4-FFF2-40B4-BE49-F238E27FC236}">
-                <a16:creationId xmlns:a16="http://schemas.microsoft.com/office/drawing/2014/main" id="{33AF1B78-37D2-46F4-8458-ED334B195337}"/>
+                <a16:creationId xmlns:a16="http://schemas.microsoft.com/office/drawing/2014/main" id="{6ADF6671-7BD9-4D06-B782-D6362093B412}"/>
               </a:ext>
             </a:extLst>
           </p:cNvPr>
@@ -12883,7 +12883,7 @@
           <p:cNvPr id="15" name="">
             <a:extLst xmlns:a="http://schemas.openxmlformats.org/drawingml/2006/main">
               <a:ext uri="{FF2B5EF4-FFF2-40B4-BE49-F238E27FC236}">
-                <a16:creationId xmlns:a16="http://schemas.microsoft.com/office/drawing/2014/main" id="{9B826E26-58E5-4323-8BE8-7CB4A8411D75}"/>
+                <a16:creationId xmlns:a16="http://schemas.microsoft.com/office/drawing/2014/main" id="{3579934E-4A1B-41B0-A374-3D035257678F}"/>
               </a:ext>
             </a:extLst>
           </p:cNvPr>
@@ -12934,7 +12934,7 @@
           <p:cNvPr id="16" name="">
             <a:extLst xmlns:a="http://schemas.openxmlformats.org/drawingml/2006/main">
               <a:ext uri="{FF2B5EF4-FFF2-40B4-BE49-F238E27FC236}">
-                <a16:creationId xmlns:a16="http://schemas.microsoft.com/office/drawing/2014/main" id="{64D09C05-FC33-416D-8CBC-C35F691F538B}"/>
+                <a16:creationId xmlns:a16="http://schemas.microsoft.com/office/drawing/2014/main" id="{1F415F0E-1507-4F1E-9126-962796D28B4C}"/>
               </a:ext>
             </a:extLst>
           </p:cNvPr>
@@ -12985,7 +12985,7 @@
           <p:cNvPr id="17" name="">
             <a:extLst xmlns:a="http://schemas.openxmlformats.org/drawingml/2006/main">
               <a:ext uri="{FF2B5EF4-FFF2-40B4-BE49-F238E27FC236}">
-                <a16:creationId xmlns:a16="http://schemas.microsoft.com/office/drawing/2014/main" id="{28AAA87D-D2DE-4187-AB1B-0D6209480EC6}"/>
+                <a16:creationId xmlns:a16="http://schemas.microsoft.com/office/drawing/2014/main" id="{12DB4E91-CD6F-4B84-B438-46B19CBEF3ED}"/>
               </a:ext>
             </a:extLst>
           </p:cNvPr>
@@ -13018,7 +13018,7 @@
           <p:cNvPr id="18" name="">
             <a:extLst xmlns:a="http://schemas.openxmlformats.org/drawingml/2006/main">
               <a:ext uri="{FF2B5EF4-FFF2-40B4-BE49-F238E27FC236}">
-                <a16:creationId xmlns:a16="http://schemas.microsoft.com/office/drawing/2014/main" id="{1EC25C4B-9149-4F9A-AE96-AB96F829ABF6}"/>
+                <a16:creationId xmlns:a16="http://schemas.microsoft.com/office/drawing/2014/main" id="{1D296103-7A8C-4D26-8B72-E7650CF0AFC7}"/>
               </a:ext>
             </a:extLst>
           </p:cNvPr>
@@ -13051,7 +13051,7 @@
           <p:cNvPr id="19" name="">
             <a:extLst xmlns:a="http://schemas.openxmlformats.org/drawingml/2006/main">
               <a:ext uri="{FF2B5EF4-FFF2-40B4-BE49-F238E27FC236}">
-                <a16:creationId xmlns:a16="http://schemas.microsoft.com/office/drawing/2014/main" id="{85B1EC40-F759-47B6-9C71-92E42F13B8A2}"/>
+                <a16:creationId xmlns:a16="http://schemas.microsoft.com/office/drawing/2014/main" id="{DE9403E6-4C2E-452B-9088-915B17C2359C}"/>
               </a:ext>
             </a:extLst>
           </p:cNvPr>
@@ -13102,7 +13102,7 @@
           <p:cNvPr id="20" name="">
             <a:extLst xmlns:a="http://schemas.openxmlformats.org/drawingml/2006/main">
               <a:ext uri="{FF2B5EF4-FFF2-40B4-BE49-F238E27FC236}">
-                <a16:creationId xmlns:a16="http://schemas.microsoft.com/office/drawing/2014/main" id="{241D26EA-51D6-460E-B258-861352DC9A47}"/>
+                <a16:creationId xmlns:a16="http://schemas.microsoft.com/office/drawing/2014/main" id="{2DCAB117-C3FF-446E-8D07-054729B2B09D}"/>
               </a:ext>
             </a:extLst>
           </p:cNvPr>
@@ -13153,7 +13153,7 @@
           <p:cNvPr id="21" name="">
             <a:extLst xmlns:a="http://schemas.openxmlformats.org/drawingml/2006/main">
               <a:ext uri="{FF2B5EF4-FFF2-40B4-BE49-F238E27FC236}">
-                <a16:creationId xmlns:a16="http://schemas.microsoft.com/office/drawing/2014/main" id="{7F36EFC5-2FF5-448A-9346-D44E15EB35ED}"/>
+                <a16:creationId xmlns:a16="http://schemas.microsoft.com/office/drawing/2014/main" id="{1CF8EBA0-3C9C-4D1D-AD27-C88672E12313}"/>
               </a:ext>
             </a:extLst>
           </p:cNvPr>
@@ -13186,7 +13186,7 @@
           <p:cNvPr id="22" name="">
             <a:extLst xmlns:a="http://schemas.openxmlformats.org/drawingml/2006/main">
               <a:ext uri="{FF2B5EF4-FFF2-40B4-BE49-F238E27FC236}">
-                <a16:creationId xmlns:a16="http://schemas.microsoft.com/office/drawing/2014/main" id="{713A4C02-18EA-4C55-8C52-23D12414DC7F}"/>
+                <a16:creationId xmlns:a16="http://schemas.microsoft.com/office/drawing/2014/main" id="{678F4A76-1C87-49E5-840D-4CEA9B8F5973}"/>
               </a:ext>
             </a:extLst>
           </p:cNvPr>
@@ -13219,7 +13219,7 @@
           <p:cNvPr id="23" name="">
             <a:extLst xmlns:a="http://schemas.openxmlformats.org/drawingml/2006/main">
               <a:ext uri="{FF2B5EF4-FFF2-40B4-BE49-F238E27FC236}">
-                <a16:creationId xmlns:a16="http://schemas.microsoft.com/office/drawing/2014/main" id="{1D4C4383-DFEE-4335-92FE-E4759FAB6D7F}"/>
+                <a16:creationId xmlns:a16="http://schemas.microsoft.com/office/drawing/2014/main" id="{035CC17D-7B7A-4558-A3FD-F998DA8723DE}"/>
               </a:ext>
             </a:extLst>
           </p:cNvPr>
@@ -13270,7 +13270,7 @@
           <p:cNvPr id="24" name="">
             <a:extLst xmlns:a="http://schemas.openxmlformats.org/drawingml/2006/main">
               <a:ext uri="{FF2B5EF4-FFF2-40B4-BE49-F238E27FC236}">
-                <a16:creationId xmlns:a16="http://schemas.microsoft.com/office/drawing/2014/main" id="{94960AC2-D3C8-4253-8B79-00BEB6985AB3}"/>
+                <a16:creationId xmlns:a16="http://schemas.microsoft.com/office/drawing/2014/main" id="{FBEBDBA6-BA63-48EB-BC97-F72AE8A5771B}"/>
               </a:ext>
             </a:extLst>
           </p:cNvPr>
@@ -13321,7 +13321,7 @@
           <p:cNvPr id="25" name="">
             <a:extLst xmlns:a="http://schemas.openxmlformats.org/drawingml/2006/main">
               <a:ext uri="{FF2B5EF4-FFF2-40B4-BE49-F238E27FC236}">
-                <a16:creationId xmlns:a16="http://schemas.microsoft.com/office/drawing/2014/main" id="{D0B266BB-90C4-4E23-9E77-C606AC47D6AC}"/>
+                <a16:creationId xmlns:a16="http://schemas.microsoft.com/office/drawing/2014/main" id="{837D88B1-08E8-4AB9-9A37-140F85F33565}"/>
               </a:ext>
             </a:extLst>
           </p:cNvPr>
@@ -13354,7 +13354,7 @@
           <p:cNvPr id="26" name="">
             <a:extLst xmlns:a="http://schemas.openxmlformats.org/drawingml/2006/main">
               <a:ext uri="{FF2B5EF4-FFF2-40B4-BE49-F238E27FC236}">
-                <a16:creationId xmlns:a16="http://schemas.microsoft.com/office/drawing/2014/main" id="{45385A67-694A-4F07-A6E3-C5D6BD47555D}"/>
+                <a16:creationId xmlns:a16="http://schemas.microsoft.com/office/drawing/2014/main" id="{4B18D66C-C8AF-46B7-B958-FE616B46C750}"/>
               </a:ext>
             </a:extLst>
           </p:cNvPr>
@@ -13387,7 +13387,7 @@
           <p:cNvPr id="27" name="">
             <a:extLst xmlns:a="http://schemas.openxmlformats.org/drawingml/2006/main">
               <a:ext uri="{FF2B5EF4-FFF2-40B4-BE49-F238E27FC236}">
-                <a16:creationId xmlns:a16="http://schemas.microsoft.com/office/drawing/2014/main" id="{151F53B0-7AFB-46AA-B284-732EB5854902}"/>
+                <a16:creationId xmlns:a16="http://schemas.microsoft.com/office/drawing/2014/main" id="{58FE21A8-024F-415C-875F-CBA4423C19EE}"/>
               </a:ext>
             </a:extLst>
           </p:cNvPr>
@@ -13438,7 +13438,7 @@
           <p:cNvPr id="28" name="">
             <a:extLst xmlns:a="http://schemas.openxmlformats.org/drawingml/2006/main">
               <a:ext uri="{FF2B5EF4-FFF2-40B4-BE49-F238E27FC236}">
-                <a16:creationId xmlns:a16="http://schemas.microsoft.com/office/drawing/2014/main" id="{FA5D5E79-8587-4579-8261-A1549D68DA3A}"/>
+                <a16:creationId xmlns:a16="http://schemas.microsoft.com/office/drawing/2014/main" id="{31042DF2-CEEA-4525-A3D8-E3F1789184E3}"/>
               </a:ext>
             </a:extLst>
           </p:cNvPr>
@@ -13489,7 +13489,7 @@
           <p:cNvPr id="29" name="">
             <a:extLst xmlns:a="http://schemas.openxmlformats.org/drawingml/2006/main">
               <a:ext uri="{FF2B5EF4-FFF2-40B4-BE49-F238E27FC236}">
-                <a16:creationId xmlns:a16="http://schemas.microsoft.com/office/drawing/2014/main" id="{FC7C6FC9-B5D4-44B3-B9E8-C633C4E928B7}"/>
+                <a16:creationId xmlns:a16="http://schemas.microsoft.com/office/drawing/2014/main" id="{306385B9-D538-47EF-AAC4-05F68E0496A5}"/>
               </a:ext>
             </a:extLst>
           </p:cNvPr>
@@ -13540,7 +13540,7 @@
           <p:cNvPr id="30" name="">
             <a:extLst xmlns:a="http://schemas.openxmlformats.org/drawingml/2006/main">
               <a:ext uri="{FF2B5EF4-FFF2-40B4-BE49-F238E27FC236}">
-                <a16:creationId xmlns:a16="http://schemas.microsoft.com/office/drawing/2014/main" id="{ECA9EDDD-6BC7-481D-9307-5AD93AC913C1}"/>
+                <a16:creationId xmlns:a16="http://schemas.microsoft.com/office/drawing/2014/main" id="{C19E73E3-C09E-4512-8778-0D353C547FB0}"/>
               </a:ext>
             </a:extLst>
           </p:cNvPr>
@@ -13589,7 +13589,7 @@
     </p:spTree>
     <p:extLst>
       <p:ext uri="{BB962C8B-B14F-4D97-AF65-F5344CB8AC3E}">
-        <p14:creationId xmlns:p14="http://schemas.microsoft.com/office/powerpoint/2010/main" val="534653633"/>
+        <p14:creationId xmlns:p14="http://schemas.microsoft.com/office/powerpoint/2010/main" val="294305864"/>
       </p:ext>
     </p:extLst>
   </p:cSld>
@@ -13613,7 +13613,7 @@
           <p:cNvPr id="1" name="">
             <a:extLst xmlns:a="http://schemas.openxmlformats.org/drawingml/2006/main">
               <a:ext uri="{FF2B5EF4-FFF2-40B4-BE49-F238E27FC236}">
-                <a16:creationId xmlns:a16="http://schemas.microsoft.com/office/drawing/2014/main" id="{27F61793-E149-42BA-A856-162C34B5C8AA}"/>
+                <a16:creationId xmlns:a16="http://schemas.microsoft.com/office/drawing/2014/main" id="{3FBC0981-88EE-4F0B-ADC5-C3B697690E82}"/>
               </a:ext>
             </a:extLst>
           </p:cNvPr>
@@ -13646,7 +13646,7 @@
           <p:cNvPr id="2" name="">
             <a:extLst xmlns:a="http://schemas.openxmlformats.org/drawingml/2006/main">
               <a:ext uri="{FF2B5EF4-FFF2-40B4-BE49-F238E27FC236}">
-                <a16:creationId xmlns:a16="http://schemas.microsoft.com/office/drawing/2014/main" id="{253C06E6-73C8-4B55-AE3C-AC1008D30A67}"/>
+                <a16:creationId xmlns:a16="http://schemas.microsoft.com/office/drawing/2014/main" id="{5264E9FD-4F85-4FB6-9F24-A41C9F7899E9}"/>
               </a:ext>
             </a:extLst>
           </p:cNvPr>
@@ -13697,7 +13697,7 @@
           <p:cNvPr id="3" name="">
             <a:extLst xmlns:a="http://schemas.openxmlformats.org/drawingml/2006/main">
               <a:ext uri="{FF2B5EF4-FFF2-40B4-BE49-F238E27FC236}">
-                <a16:creationId xmlns:a16="http://schemas.microsoft.com/office/drawing/2014/main" id="{ECF6DEC2-9423-4259-BB97-1DCDF90A7B06}"/>
+                <a16:creationId xmlns:a16="http://schemas.microsoft.com/office/drawing/2014/main" id="{EC0E1055-754A-4CC7-B689-FE7C7CF3AEBF}"/>
               </a:ext>
             </a:extLst>
           </p:cNvPr>
@@ -13748,7 +13748,7 @@
           <p:cNvPr id="4" name="">
             <a:extLst xmlns:a="http://schemas.openxmlformats.org/drawingml/2006/main">
               <a:ext uri="{FF2B5EF4-FFF2-40B4-BE49-F238E27FC236}">
-                <a16:creationId xmlns:a16="http://schemas.microsoft.com/office/drawing/2014/main" id="{DDF76618-6273-4069-B4F1-D2E034F67846}"/>
+                <a16:creationId xmlns:a16="http://schemas.microsoft.com/office/drawing/2014/main" id="{D90E2217-C256-422A-8FDD-909902F67798}"/>
               </a:ext>
             </a:extLst>
           </p:cNvPr>
@@ -13781,7 +13781,7 @@
           <p:cNvPr id="5" name="">
             <a:extLst xmlns:a="http://schemas.openxmlformats.org/drawingml/2006/main">
               <a:ext uri="{FF2B5EF4-FFF2-40B4-BE49-F238E27FC236}">
-                <a16:creationId xmlns:a16="http://schemas.microsoft.com/office/drawing/2014/main" id="{4791A540-A161-428B-852E-07B52264A652}"/>
+                <a16:creationId xmlns:a16="http://schemas.microsoft.com/office/drawing/2014/main" id="{4A6BB60A-18B6-4D2D-AF1E-B45F5B1E011F}"/>
               </a:ext>
             </a:extLst>
           </p:cNvPr>
@@ -13832,7 +13832,7 @@
           <p:cNvPr id="6" name="">
             <a:extLst xmlns:a="http://schemas.openxmlformats.org/drawingml/2006/main">
               <a:ext uri="{FF2B5EF4-FFF2-40B4-BE49-F238E27FC236}">
-                <a16:creationId xmlns:a16="http://schemas.microsoft.com/office/drawing/2014/main" id="{479B3E7D-33F3-45CB-9DD5-68145C5EC668}"/>
+                <a16:creationId xmlns:a16="http://schemas.microsoft.com/office/drawing/2014/main" id="{5810F5C2-29D8-43FB-8B27-89F18C8EA569}"/>
               </a:ext>
             </a:extLst>
           </p:cNvPr>
@@ -13883,7 +13883,7 @@
           <p:cNvPr id="7" name="">
             <a:extLst xmlns:a="http://schemas.openxmlformats.org/drawingml/2006/main">
               <a:ext uri="{FF2B5EF4-FFF2-40B4-BE49-F238E27FC236}">
-                <a16:creationId xmlns:a16="http://schemas.microsoft.com/office/drawing/2014/main" id="{0A7E8D56-1CC2-4934-A1C6-57273B42D0B8}"/>
+                <a16:creationId xmlns:a16="http://schemas.microsoft.com/office/drawing/2014/main" id="{8492C475-DF23-4EB2-8E05-244968272D6B}"/>
               </a:ext>
             </a:extLst>
           </p:cNvPr>
@@ -13951,7 +13951,7 @@
           <p:cNvPr id="8" name="">
             <a:extLst xmlns:a="http://schemas.openxmlformats.org/drawingml/2006/main">
               <a:ext uri="{FF2B5EF4-FFF2-40B4-BE49-F238E27FC236}">
-                <a16:creationId xmlns:a16="http://schemas.microsoft.com/office/drawing/2014/main" id="{4ABA853F-D678-4482-A7BB-316553B4D74F}"/>
+                <a16:creationId xmlns:a16="http://schemas.microsoft.com/office/drawing/2014/main" id="{81106C79-E75E-4FC0-AFA6-34A8A0999329}"/>
               </a:ext>
             </a:extLst>
           </p:cNvPr>
@@ -13984,7 +13984,7 @@
           <p:cNvPr id="9" name="">
             <a:extLst xmlns:a="http://schemas.openxmlformats.org/drawingml/2006/main">
               <a:ext uri="{FF2B5EF4-FFF2-40B4-BE49-F238E27FC236}">
-                <a16:creationId xmlns:a16="http://schemas.microsoft.com/office/drawing/2014/main" id="{2E3B6FDC-8D40-4FC1-9A40-336AECEACE2D}"/>
+                <a16:creationId xmlns:a16="http://schemas.microsoft.com/office/drawing/2014/main" id="{076508FB-C22C-438F-B4FE-F870FB2C4122}"/>
               </a:ext>
             </a:extLst>
           </p:cNvPr>
@@ -14017,7 +14017,7 @@
           <p:cNvPr id="10" name="">
             <a:extLst xmlns:a="http://schemas.openxmlformats.org/drawingml/2006/main">
               <a:ext uri="{FF2B5EF4-FFF2-40B4-BE49-F238E27FC236}">
-                <a16:creationId xmlns:a16="http://schemas.microsoft.com/office/drawing/2014/main" id="{5A243526-FCC7-4908-BFB7-CB0907EB8C8E}"/>
+                <a16:creationId xmlns:a16="http://schemas.microsoft.com/office/drawing/2014/main" id="{9A1CACE4-139F-4194-A375-8D5521BA424B}"/>
               </a:ext>
             </a:extLst>
           </p:cNvPr>
@@ -14068,7 +14068,7 @@
           <p:cNvPr id="11" name="">
             <a:extLst xmlns:a="http://schemas.openxmlformats.org/drawingml/2006/main">
               <a:ext uri="{FF2B5EF4-FFF2-40B4-BE49-F238E27FC236}">
-                <a16:creationId xmlns:a16="http://schemas.microsoft.com/office/drawing/2014/main" id="{140CBD18-3FC5-4057-AB41-8BC074D9E645}"/>
+                <a16:creationId xmlns:a16="http://schemas.microsoft.com/office/drawing/2014/main" id="{2A43D9C3-76AE-4F8E-BFFE-E472DD3E2EB6}"/>
               </a:ext>
             </a:extLst>
           </p:cNvPr>
@@ -14119,7 +14119,7 @@
           <p:cNvPr id="12" name="">
             <a:extLst xmlns:a="http://schemas.openxmlformats.org/drawingml/2006/main">
               <a:ext uri="{FF2B5EF4-FFF2-40B4-BE49-F238E27FC236}">
-                <a16:creationId xmlns:a16="http://schemas.microsoft.com/office/drawing/2014/main" id="{CF261170-A4D4-4718-AAE5-5CFF01458E85}"/>
+                <a16:creationId xmlns:a16="http://schemas.microsoft.com/office/drawing/2014/main" id="{0ED22929-85AB-4FA3-B946-CB2E22329748}"/>
               </a:ext>
             </a:extLst>
           </p:cNvPr>
@@ -14152,7 +14152,7 @@
           <p:cNvPr id="13" name="">
             <a:extLst xmlns:a="http://schemas.openxmlformats.org/drawingml/2006/main">
               <a:ext uri="{FF2B5EF4-FFF2-40B4-BE49-F238E27FC236}">
-                <a16:creationId xmlns:a16="http://schemas.microsoft.com/office/drawing/2014/main" id="{65051D35-45EA-4A3A-A194-43902C70EE78}"/>
+                <a16:creationId xmlns:a16="http://schemas.microsoft.com/office/drawing/2014/main" id="{B17A3EFF-2811-423A-87B3-B044D5203CCF}"/>
               </a:ext>
             </a:extLst>
           </p:cNvPr>
@@ -14185,7 +14185,7 @@
           <p:cNvPr id="14" name="">
             <a:extLst xmlns:a="http://schemas.openxmlformats.org/drawingml/2006/main">
               <a:ext uri="{FF2B5EF4-FFF2-40B4-BE49-F238E27FC236}">
-                <a16:creationId xmlns:a16="http://schemas.microsoft.com/office/drawing/2014/main" id="{FEB30712-57F1-403F-B527-84B7C778083E}"/>
+                <a16:creationId xmlns:a16="http://schemas.microsoft.com/office/drawing/2014/main" id="{F4071771-CB63-41EB-999C-284261955807}"/>
               </a:ext>
             </a:extLst>
           </p:cNvPr>
@@ -14236,7 +14236,7 @@
           <p:cNvPr id="15" name="">
             <a:extLst xmlns:a="http://schemas.openxmlformats.org/drawingml/2006/main">
               <a:ext uri="{FF2B5EF4-FFF2-40B4-BE49-F238E27FC236}">
-                <a16:creationId xmlns:a16="http://schemas.microsoft.com/office/drawing/2014/main" id="{86014307-724C-4525-9693-1CDDB3252059}"/>
+                <a16:creationId xmlns:a16="http://schemas.microsoft.com/office/drawing/2014/main" id="{CA09BF96-1D70-4C07-BA55-F15B579007BB}"/>
               </a:ext>
             </a:extLst>
           </p:cNvPr>
@@ -14287,7 +14287,7 @@
           <p:cNvPr id="16" name="">
             <a:extLst xmlns:a="http://schemas.openxmlformats.org/drawingml/2006/main">
               <a:ext uri="{FF2B5EF4-FFF2-40B4-BE49-F238E27FC236}">
-                <a16:creationId xmlns:a16="http://schemas.microsoft.com/office/drawing/2014/main" id="{889D0680-2753-4083-9CFC-3005AB5D7AC8}"/>
+                <a16:creationId xmlns:a16="http://schemas.microsoft.com/office/drawing/2014/main" id="{74A504FF-81D7-49B7-9C4C-A34F79999431}"/>
               </a:ext>
             </a:extLst>
           </p:cNvPr>
@@ -14320,7 +14320,7 @@
           <p:cNvPr id="17" name="">
             <a:extLst xmlns:a="http://schemas.openxmlformats.org/drawingml/2006/main">
               <a:ext uri="{FF2B5EF4-FFF2-40B4-BE49-F238E27FC236}">
-                <a16:creationId xmlns:a16="http://schemas.microsoft.com/office/drawing/2014/main" id="{D5A56D9D-ED4F-49E8-A832-AA98CA46DC84}"/>
+                <a16:creationId xmlns:a16="http://schemas.microsoft.com/office/drawing/2014/main" id="{C2F535C8-4916-4672-97D8-FE9D86B46CC5}"/>
               </a:ext>
             </a:extLst>
           </p:cNvPr>
@@ -14353,7 +14353,7 @@
           <p:cNvPr id="18" name="">
             <a:extLst xmlns:a="http://schemas.openxmlformats.org/drawingml/2006/main">
               <a:ext uri="{FF2B5EF4-FFF2-40B4-BE49-F238E27FC236}">
-                <a16:creationId xmlns:a16="http://schemas.microsoft.com/office/drawing/2014/main" id="{887B2A94-B23A-44B8-B1C7-0C2B2EFDE197}"/>
+                <a16:creationId xmlns:a16="http://schemas.microsoft.com/office/drawing/2014/main" id="{AE96DE3E-69EC-4F3D-8CD6-977C8AB833FD}"/>
               </a:ext>
             </a:extLst>
           </p:cNvPr>
@@ -14404,7 +14404,7 @@
           <p:cNvPr id="19" name="">
             <a:extLst xmlns:a="http://schemas.openxmlformats.org/drawingml/2006/main">
               <a:ext uri="{FF2B5EF4-FFF2-40B4-BE49-F238E27FC236}">
-                <a16:creationId xmlns:a16="http://schemas.microsoft.com/office/drawing/2014/main" id="{EE94F31D-BD8E-4502-98A5-256FE125FC39}"/>
+                <a16:creationId xmlns:a16="http://schemas.microsoft.com/office/drawing/2014/main" id="{02A2AD99-5B77-48EE-B6D7-D556288C0289}"/>
               </a:ext>
             </a:extLst>
           </p:cNvPr>
@@ -14445,7 +14445,7 @@
                   <a:srgbClr val="5F6F86"/>
                 </a:solidFill>
               </a:rPr>
-              <a:t>The ledger, A/R, A/P, registers, job costing, statements, recurring, bank rec, period close, and invoice/bill/statement PDFs are already built. This phase tailors and rolls them out for Raves.</a:t>
+              <a:t>The ledger, A/R, A/P, registers, job costing, statements, recurring, period close, and invoice/bill/statement PDFs are already built. This phase tailors and rolls them out for Raves.</a:t>
             </a:r>
           </a:p>
         </p:txBody>
@@ -14455,7 +14455,7 @@
           <p:cNvPr id="20" name="">
             <a:extLst xmlns:a="http://schemas.openxmlformats.org/drawingml/2006/main">
               <a:ext uri="{FF2B5EF4-FFF2-40B4-BE49-F238E27FC236}">
-                <a16:creationId xmlns:a16="http://schemas.microsoft.com/office/drawing/2014/main" id="{FDDEE929-D5B7-46BE-9F5A-2F94F2AE84DF}"/>
+                <a16:creationId xmlns:a16="http://schemas.microsoft.com/office/drawing/2014/main" id="{EC0BCDCF-63DA-43C1-86C0-05C77834E634}"/>
               </a:ext>
             </a:extLst>
           </p:cNvPr>
@@ -14506,7 +14506,7 @@
           <p:cNvPr id="21" name="">
             <a:extLst xmlns:a="http://schemas.openxmlformats.org/drawingml/2006/main">
               <a:ext uri="{FF2B5EF4-FFF2-40B4-BE49-F238E27FC236}">
-                <a16:creationId xmlns:a16="http://schemas.microsoft.com/office/drawing/2014/main" id="{1DA10B0B-4E3A-4969-BA9D-D0E6FB18A6E4}"/>
+                <a16:creationId xmlns:a16="http://schemas.microsoft.com/office/drawing/2014/main" id="{42426524-1564-45A7-ADA2-FFC847C8ECD2}"/>
               </a:ext>
             </a:extLst>
           </p:cNvPr>
@@ -14555,7 +14555,7 @@
     </p:spTree>
     <p:extLst>
       <p:ext uri="{BB962C8B-B14F-4D97-AF65-F5344CB8AC3E}">
-        <p14:creationId xmlns:p14="http://schemas.microsoft.com/office/powerpoint/2010/main" val="1425087874"/>
+        <p14:creationId xmlns:p14="http://schemas.microsoft.com/office/powerpoint/2010/main" val="1826309866"/>
       </p:ext>
     </p:extLst>
   </p:cSld>

</xml_diff>